<commit_message>
paper(presentation): address RA review comments
</commit_message>
<xml_diff>
--- a/paper/presentations/ra-presentation-intro-20260506/output/twophaseflow-research-introduction.pptx
+++ b/paper/presentations/ra-presentation-intro-20260506/output/twophaseflow-research-introduction.pptx
@@ -2,27 +2,27 @@
 <file path=ppt/presentation.xml><?xml version="1.0" encoding="utf-8"?>
 <p:presentation xmlns:p="http://schemas.openxmlformats.org/presentationml/2006/main">
   <p:sldMasterIdLst>
-    <p:sldMasterId xmlns:r="http://schemas.openxmlformats.org/officeDocument/2006/relationships" id="2147483648" r:id="R4a27cc17362e4bb7"/>
+    <p:sldMasterId xmlns:r="http://schemas.openxmlformats.org/officeDocument/2006/relationships" id="2147483648" r:id="Rc5426c7f49204978"/>
   </p:sldMasterIdLst>
   <p:notesMasterIdLst>
-    <p:notesMasterId xmlns:r="http://schemas.openxmlformats.org/officeDocument/2006/relationships" r:id="Rf1635458f0314484"/>
+    <p:notesMasterId xmlns:r="http://schemas.openxmlformats.org/officeDocument/2006/relationships" r:id="R0063d82301c24b31"/>
   </p:notesMasterIdLst>
   <p:sldIdLst>
-    <p:sldId xmlns:r="http://schemas.openxmlformats.org/officeDocument/2006/relationships" id="256" r:id="Rfa7b64377bf54801"/>
-    <p:sldId xmlns:r="http://schemas.openxmlformats.org/officeDocument/2006/relationships" id="257" r:id="Rf69bcd3a021141ea"/>
-    <p:sldId xmlns:r="http://schemas.openxmlformats.org/officeDocument/2006/relationships" id="258" r:id="Rdb655f7331f34d3d"/>
-    <p:sldId xmlns:r="http://schemas.openxmlformats.org/officeDocument/2006/relationships" id="259" r:id="R66328a36638e4401"/>
-    <p:sldId xmlns:r="http://schemas.openxmlformats.org/officeDocument/2006/relationships" id="260" r:id="R74708b524d844104"/>
-    <p:sldId xmlns:r="http://schemas.openxmlformats.org/officeDocument/2006/relationships" id="261" r:id="Rd5318f349653474f"/>
-    <p:sldId xmlns:r="http://schemas.openxmlformats.org/officeDocument/2006/relationships" id="262" r:id="Ra25d07f844114b9c"/>
-    <p:sldId xmlns:r="http://schemas.openxmlformats.org/officeDocument/2006/relationships" id="263" r:id="R7b19ab685421436f"/>
-    <p:sldId xmlns:r="http://schemas.openxmlformats.org/officeDocument/2006/relationships" id="264" r:id="Rf82e49437f994d60"/>
-    <p:sldId xmlns:r="http://schemas.openxmlformats.org/officeDocument/2006/relationships" id="265" r:id="R248730c8da494889"/>
-    <p:sldId xmlns:r="http://schemas.openxmlformats.org/officeDocument/2006/relationships" id="266" r:id="R191eea10e9af4bf7"/>
-    <p:sldId xmlns:r="http://schemas.openxmlformats.org/officeDocument/2006/relationships" id="267" r:id="R3dfea05532a84951"/>
-    <p:sldId xmlns:r="http://schemas.openxmlformats.org/officeDocument/2006/relationships" id="268" r:id="Rdecc228d61784e74"/>
-    <p:sldId xmlns:r="http://schemas.openxmlformats.org/officeDocument/2006/relationships" id="269" r:id="Rc68efa345258419e"/>
-    <p:sldId xmlns:r="http://schemas.openxmlformats.org/officeDocument/2006/relationships" id="270" r:id="Rd959fe9dbe10479f"/>
+    <p:sldId xmlns:r="http://schemas.openxmlformats.org/officeDocument/2006/relationships" id="256" r:id="R121b175bcfc94015"/>
+    <p:sldId xmlns:r="http://schemas.openxmlformats.org/officeDocument/2006/relationships" id="257" r:id="Rfab537ce535b489a"/>
+    <p:sldId xmlns:r="http://schemas.openxmlformats.org/officeDocument/2006/relationships" id="258" r:id="R4f79dab35e81418c"/>
+    <p:sldId xmlns:r="http://schemas.openxmlformats.org/officeDocument/2006/relationships" id="259" r:id="R24d5ec0f995e4c6c"/>
+    <p:sldId xmlns:r="http://schemas.openxmlformats.org/officeDocument/2006/relationships" id="260" r:id="Rfc7af19e651f4c5c"/>
+    <p:sldId xmlns:r="http://schemas.openxmlformats.org/officeDocument/2006/relationships" id="261" r:id="R2d9dc6e51b9943a5"/>
+    <p:sldId xmlns:r="http://schemas.openxmlformats.org/officeDocument/2006/relationships" id="262" r:id="Rc30e54a59c2b429b"/>
+    <p:sldId xmlns:r="http://schemas.openxmlformats.org/officeDocument/2006/relationships" id="263" r:id="R30dc277593614181"/>
+    <p:sldId xmlns:r="http://schemas.openxmlformats.org/officeDocument/2006/relationships" id="264" r:id="Rd26f9172fa6344cd"/>
+    <p:sldId xmlns:r="http://schemas.openxmlformats.org/officeDocument/2006/relationships" id="265" r:id="R8917f4e9f1bb433e"/>
+    <p:sldId xmlns:r="http://schemas.openxmlformats.org/officeDocument/2006/relationships" id="266" r:id="R019d4d01260a447e"/>
+    <p:sldId xmlns:r="http://schemas.openxmlformats.org/officeDocument/2006/relationships" id="267" r:id="Rafe3efb338354bdf"/>
+    <p:sldId xmlns:r="http://schemas.openxmlformats.org/officeDocument/2006/relationships" id="268" r:id="R6a10f2c83dcb4ad1"/>
+    <p:sldId xmlns:r="http://schemas.openxmlformats.org/officeDocument/2006/relationships" id="269" r:id="Radb6f823aec6492f"/>
+    <p:sldId xmlns:r="http://schemas.openxmlformats.org/officeDocument/2006/relationships" id="270" r:id="R214d57cde2054e4b"/>
   </p:sldIdLst>
   <p:sldSz cx="12192000" cy="6858000"/>
   <p:notesSz cx="6858000" cy="9144000"/>
@@ -1493,7 +1493,7 @@
   </p:cSld>
   <p:clrMap bg1="lt1" tx1="dk1" bg2="lt2" tx2="dk2" accent1="accent1" accent2="accent2" accent3="accent3" accent4="accent4" accent5="accent5" accent6="accent6" hlink="hlink" folHlink="folHlink"/>
   <p:sldLayoutIdLst>
-    <p:sldLayoutId xmlns:r="http://schemas.openxmlformats.org/officeDocument/2006/relationships" id="2147483649" r:id="R5bf36cab58a6420a"/>
+    <p:sldLayoutId xmlns:r="http://schemas.openxmlformats.org/officeDocument/2006/relationships" id="2147483649" r:id="Ra10458541f854144"/>
   </p:sldLayoutIdLst>
   <p:txStyles>
     <p:titleStyle>
@@ -1792,7 +1792,7 @@
           <p:cNvPr id="1" name="">
             <a:extLst xmlns:a="http://schemas.openxmlformats.org/drawingml/2006/main">
               <a:ext uri="{FF2B5EF4-FFF2-40B4-BE49-F238E27FC236}">
-                <a16:creationId xmlns:a16="http://schemas.microsoft.com/office/drawing/2014/main" id="{64C45A6C-61E0-4B91-93A4-02B9D4F5E655}"/>
+                <a16:creationId xmlns:a16="http://schemas.microsoft.com/office/drawing/2014/main" id="{737FB6CC-49F8-4667-AAEE-714E0DD372B5}"/>
               </a:ext>
             </a:extLst>
           </p:cNvPr>
@@ -1827,7 +1827,7 @@
           <p:cNvPr id="2" name="">
             <a:extLst xmlns:a="http://schemas.openxmlformats.org/drawingml/2006/main">
               <a:ext uri="{FF2B5EF4-FFF2-40B4-BE49-F238E27FC236}">
-                <a16:creationId xmlns:a16="http://schemas.microsoft.com/office/drawing/2014/main" id="{93ACAC86-B8E1-4BCA-A6F3-E95A8DEF5B5A}"/>
+                <a16:creationId xmlns:a16="http://schemas.microsoft.com/office/drawing/2014/main" id="{BC4FE195-840B-48AC-B622-589B29E4248B}"/>
               </a:ext>
             </a:extLst>
           </p:cNvPr>
@@ -1862,7 +1862,7 @@
           <p:cNvPr id="3" name="">
             <a:extLst xmlns:a="http://schemas.openxmlformats.org/drawingml/2006/main">
               <a:ext uri="{FF2B5EF4-FFF2-40B4-BE49-F238E27FC236}">
-                <a16:creationId xmlns:a16="http://schemas.microsoft.com/office/drawing/2014/main" id="{9540A9E3-B1CF-4F0A-A536-7EC15C68779F}"/>
+                <a16:creationId xmlns:a16="http://schemas.microsoft.com/office/drawing/2014/main" id="{2C951085-47E3-4AF6-9DC5-A62FF4C63BC1}"/>
               </a:ext>
             </a:extLst>
           </p:cNvPr>
@@ -1926,7 +1926,7 @@
           <p:cNvPr id="4" name="">
             <a:extLst xmlns:a="http://schemas.openxmlformats.org/drawingml/2006/main">
               <a:ext uri="{FF2B5EF4-FFF2-40B4-BE49-F238E27FC236}">
-                <a16:creationId xmlns:a16="http://schemas.microsoft.com/office/drawing/2014/main" id="{FE3E1C19-4FBF-410A-97CF-0382BEBAF9E9}"/>
+                <a16:creationId xmlns:a16="http://schemas.microsoft.com/office/drawing/2014/main" id="{919B58F6-A83F-4D98-ABD8-25F792E24947}"/>
               </a:ext>
             </a:extLst>
           </p:cNvPr>
@@ -1980,7 +1980,7 @@
                 <a:ea typeface="Hiragino Sans"/>
                 <a:cs typeface="Hiragino Sans"/>
               </a:rPr>
-              <a:t>高次コンパクト差分に基づく気液二相流数値法</a:t>
+              <a:t>CCD/FCCD/UCCD6を核にした二相流数値法</a:t>
             </a:r>
           </a:p>
         </p:txBody>
@@ -1990,7 +1990,7 @@
           <p:cNvPr id="5" name="">
             <a:extLst xmlns:a="http://schemas.openxmlformats.org/drawingml/2006/main">
               <a:ext uri="{FF2B5EF4-FFF2-40B4-BE49-F238E27FC236}">
-                <a16:creationId xmlns:a16="http://schemas.microsoft.com/office/drawing/2014/main" id="{488D1C3C-5686-460D-A580-910C146C567A}"/>
+                <a16:creationId xmlns:a16="http://schemas.microsoft.com/office/drawing/2014/main" id="{646CE9E5-809F-4490-8637-56B528B9BFB3}"/>
               </a:ext>
             </a:extLst>
           </p:cNvPr>
@@ -2044,7 +2044,7 @@
                 <a:ea typeface="Hiragino Sans"/>
                 <a:cs typeface="Hiragino Sans"/>
               </a:rPr>
-              <a:t>保存形界面追跡・Balanced-Force・pressure-jump 分相PPEを、同じ面幾何で閉じる。</a:t>
+              <a:t>保存形界面追跡・Balanced-Force・pressure-jump分相PPEを、CCDファミリの面幾何で閉じる。</a:t>
             </a:r>
           </a:p>
         </p:txBody>
@@ -2054,7 +2054,7 @@
           <p:cNvPr id="6" name="">
             <a:extLst xmlns:a="http://schemas.openxmlformats.org/drawingml/2006/main">
               <a:ext uri="{FF2B5EF4-FFF2-40B4-BE49-F238E27FC236}">
-                <a16:creationId xmlns:a16="http://schemas.microsoft.com/office/drawing/2014/main" id="{FC511642-5053-414B-B6BF-65CEEB4927E9}"/>
+                <a16:creationId xmlns:a16="http://schemas.microsoft.com/office/drawing/2014/main" id="{8BBADC10-3A35-4E0F-AB63-56E925AAC1E4}"/>
               </a:ext>
             </a:extLst>
           </p:cNvPr>
@@ -2089,7 +2089,7 @@
           <p:cNvPr id="7" name="">
             <a:extLst xmlns:a="http://schemas.openxmlformats.org/drawingml/2006/main">
               <a:ext uri="{FF2B5EF4-FFF2-40B4-BE49-F238E27FC236}">
-                <a16:creationId xmlns:a16="http://schemas.microsoft.com/office/drawing/2014/main" id="{C1CF5393-5099-4A0F-A6FE-810D5C8041AA}"/>
+                <a16:creationId xmlns:a16="http://schemas.microsoft.com/office/drawing/2014/main" id="{B025B665-5CB7-4E6F-B6AC-5FF77C70C043}"/>
               </a:ext>
             </a:extLst>
           </p:cNvPr>
@@ -2143,7 +2143,7 @@
                 <a:ea typeface="Hiragino Sans"/>
                 <a:cs typeface="Hiragino Sans"/>
               </a:rPr>
-              <a:t>Conservative Level Set</a:t>
+              <a:t>CCD node derivatives</a:t>
             </a:r>
           </a:p>
         </p:txBody>
@@ -2153,7 +2153,7 @@
           <p:cNvPr id="8" name="">
             <a:extLst xmlns:a="http://schemas.openxmlformats.org/drawingml/2006/main">
               <a:ext uri="{FF2B5EF4-FFF2-40B4-BE49-F238E27FC236}">
-                <a16:creationId xmlns:a16="http://schemas.microsoft.com/office/drawing/2014/main" id="{5A037D86-EF45-4ED2-B8FD-E83F66BE046D}"/>
+                <a16:creationId xmlns:a16="http://schemas.microsoft.com/office/drawing/2014/main" id="{1B3FDABF-E4B3-43E6-9706-EDDEA21A23E2}"/>
               </a:ext>
             </a:extLst>
           </p:cNvPr>
@@ -2188,7 +2188,7 @@
           <p:cNvPr id="9" name="">
             <a:extLst xmlns:a="http://schemas.openxmlformats.org/drawingml/2006/main">
               <a:ext uri="{FF2B5EF4-FFF2-40B4-BE49-F238E27FC236}">
-                <a16:creationId xmlns:a16="http://schemas.microsoft.com/office/drawing/2014/main" id="{31BEC05A-D405-49DA-BC99-6CABE522F686}"/>
+                <a16:creationId xmlns:a16="http://schemas.microsoft.com/office/drawing/2014/main" id="{22CD75F9-B4CE-477E-AF7B-80344DEEE544}"/>
               </a:ext>
             </a:extLst>
           </p:cNvPr>
@@ -2242,7 +2242,7 @@
                 <a:ea typeface="Hiragino Sans"/>
                 <a:cs typeface="Hiragino Sans"/>
               </a:rPr>
-              <a:t>FCCD face jet</a:t>
+              <a:t>FCCD face flux</a:t>
             </a:r>
           </a:p>
         </p:txBody>
@@ -2252,7 +2252,7 @@
           <p:cNvPr id="10" name="">
             <a:extLst xmlns:a="http://schemas.openxmlformats.org/drawingml/2006/main">
               <a:ext uri="{FF2B5EF4-FFF2-40B4-BE49-F238E27FC236}">
-                <a16:creationId xmlns:a16="http://schemas.microsoft.com/office/drawing/2014/main" id="{976FF027-9792-4792-8DE9-4C03BE165205}"/>
+                <a16:creationId xmlns:a16="http://schemas.microsoft.com/office/drawing/2014/main" id="{B1AD3291-6393-4A3F-B67D-FAEC55053E6E}"/>
               </a:ext>
             </a:extLst>
           </p:cNvPr>
@@ -2287,7 +2287,7 @@
           <p:cNvPr id="11" name="">
             <a:extLst xmlns:a="http://schemas.openxmlformats.org/drawingml/2006/main">
               <a:ext uri="{FF2B5EF4-FFF2-40B4-BE49-F238E27FC236}">
-                <a16:creationId xmlns:a16="http://schemas.microsoft.com/office/drawing/2014/main" id="{E8069D48-7EA7-4FAF-837E-9E9E79548562}"/>
+                <a16:creationId xmlns:a16="http://schemas.microsoft.com/office/drawing/2014/main" id="{9C4F2D6F-AA51-4970-90DD-B55872EC62FD}"/>
               </a:ext>
             </a:extLst>
           </p:cNvPr>
@@ -2341,7 +2341,7 @@
                 <a:ea typeface="Hiragino Sans"/>
                 <a:cs typeface="Hiragino Sans"/>
               </a:rPr>
-              <a:t>Phase-separated PPE</a:t>
+              <a:t>UCCD6 momentum</a:t>
             </a:r>
           </a:p>
         </p:txBody>
@@ -2351,7 +2351,7 @@
           <p:cNvPr id="12" name="">
             <a:extLst xmlns:a="http://schemas.openxmlformats.org/drawingml/2006/main">
               <a:ext uri="{FF2B5EF4-FFF2-40B4-BE49-F238E27FC236}">
-                <a16:creationId xmlns:a16="http://schemas.microsoft.com/office/drawing/2014/main" id="{C127D4C3-4ED3-4602-A13F-DB6AD6C8B9B2}"/>
+                <a16:creationId xmlns:a16="http://schemas.microsoft.com/office/drawing/2014/main" id="{6C290C60-426E-4F85-9587-D6491FC1BC53}"/>
               </a:ext>
             </a:extLst>
           </p:cNvPr>
@@ -2386,7 +2386,7 @@
           <p:cNvPr id="13" name="">
             <a:extLst xmlns:a="http://schemas.openxmlformats.org/drawingml/2006/main">
               <a:ext uri="{FF2B5EF4-FFF2-40B4-BE49-F238E27FC236}">
-                <a16:creationId xmlns:a16="http://schemas.microsoft.com/office/drawing/2014/main" id="{0708D52C-1B0D-44A7-B9FA-F5994E7235A4}"/>
+                <a16:creationId xmlns:a16="http://schemas.microsoft.com/office/drawing/2014/main" id="{CAE10304-8BF6-443C-9C18-7A3BD41550B8}"/>
               </a:ext>
             </a:extLst>
           </p:cNvPr>
@@ -2440,7 +2440,7 @@
                 <a:ea typeface="Hiragino Sans"/>
                 <a:cs typeface="Hiragino Sans"/>
               </a:rPr>
-              <a:t>HFE + DC</a:t>
+              <a:t>DCCD damping</a:t>
             </a:r>
           </a:p>
         </p:txBody>
@@ -2450,7 +2450,7 @@
           <p:cNvPr id="14" name="">
             <a:extLst xmlns:a="http://schemas.openxmlformats.org/drawingml/2006/main">
               <a:ext uri="{FF2B5EF4-FFF2-40B4-BE49-F238E27FC236}">
-                <a16:creationId xmlns:a16="http://schemas.microsoft.com/office/drawing/2014/main" id="{C4D29AD5-2C2B-4696-A92B-BBB7040B5A08}"/>
+                <a16:creationId xmlns:a16="http://schemas.microsoft.com/office/drawing/2014/main" id="{76E7EEF3-D5D9-4A63-ADC3-7E4D014706C2}"/>
               </a:ext>
             </a:extLst>
           </p:cNvPr>
@@ -2485,7 +2485,7 @@
           <p:cNvPr id="15" name="">
             <a:extLst xmlns:a="http://schemas.openxmlformats.org/drawingml/2006/main">
               <a:ext uri="{FF2B5EF4-FFF2-40B4-BE49-F238E27FC236}">
-                <a16:creationId xmlns:a16="http://schemas.microsoft.com/office/drawing/2014/main" id="{83EFCEF7-2DFF-46A5-B937-EBAEDD174D87}"/>
+                <a16:creationId xmlns:a16="http://schemas.microsoft.com/office/drawing/2014/main" id="{907C6283-9D0F-44B1-99EE-62201363273C}"/>
               </a:ext>
             </a:extLst>
           </p:cNvPr>
@@ -2572,7 +2572,7 @@
           <p:cNvPr id="16" name="">
             <a:extLst xmlns:a="http://schemas.openxmlformats.org/drawingml/2006/main">
               <a:ext uri="{FF2B5EF4-FFF2-40B4-BE49-F238E27FC236}">
-                <a16:creationId xmlns:a16="http://schemas.microsoft.com/office/drawing/2014/main" id="{F010DFE6-D93B-4BF7-B28E-ACCD87F77B50}"/>
+                <a16:creationId xmlns:a16="http://schemas.microsoft.com/office/drawing/2014/main" id="{F4D97DDE-06AD-40C9-B3F4-7F8327A69287}"/>
               </a:ext>
             </a:extLst>
           </p:cNvPr>
@@ -2607,7 +2607,7 @@
           <p:cNvPr id="17" name="">
             <a:extLst xmlns:a="http://schemas.openxmlformats.org/drawingml/2006/main">
               <a:ext uri="{FF2B5EF4-FFF2-40B4-BE49-F238E27FC236}">
-                <a16:creationId xmlns:a16="http://schemas.microsoft.com/office/drawing/2014/main" id="{CB4D5B21-677B-40DC-B957-B1E431A10E58}"/>
+                <a16:creationId xmlns:a16="http://schemas.microsoft.com/office/drawing/2014/main" id="{271A50ED-4138-45C4-B71B-D6D2F91D8886}"/>
               </a:ext>
             </a:extLst>
           </p:cNvPr>
@@ -2661,7 +2661,7 @@
                 <a:ea typeface="Hiragino Sans"/>
                 <a:cs typeface="Hiragino Sans"/>
               </a:rPr>
-              <a:t>source: paper/sections/00_abstract.tex; 01_introduction.tex</a:t>
+              <a:t>source: Abstract; Introduction</a:t>
             </a:r>
           </a:p>
         </p:txBody>
@@ -2671,7 +2671,7 @@
           <p:cNvPr id="18" name="">
             <a:extLst xmlns:a="http://schemas.openxmlformats.org/drawingml/2006/main">
               <a:ext uri="{FF2B5EF4-FFF2-40B4-BE49-F238E27FC236}">
-                <a16:creationId xmlns:a16="http://schemas.microsoft.com/office/drawing/2014/main" id="{2F49F292-998C-4E5E-9E45-5F3F7F789969}"/>
+                <a16:creationId xmlns:a16="http://schemas.microsoft.com/office/drawing/2014/main" id="{5EB4B836-7655-415F-A741-D00D758FC833}"/>
               </a:ext>
             </a:extLst>
           </p:cNvPr>
@@ -2733,7 +2733,7 @@
     </p:spTree>
     <p:extLst>
       <p:ext uri="{BB962C8B-B14F-4D97-AF65-F5344CB8AC3E}">
-        <p14:creationId xmlns:p14="http://schemas.microsoft.com/office/powerpoint/2010/main" val="1019754547"/>
+        <p14:creationId xmlns:p14="http://schemas.microsoft.com/office/powerpoint/2010/main" val="2091185647"/>
       </p:ext>
     </p:extLst>
   </p:cSld>
@@ -2757,7 +2757,7 @@
           <p:cNvPr id="1" name="">
             <a:extLst xmlns:a="http://schemas.openxmlformats.org/drawingml/2006/main">
               <a:ext uri="{FF2B5EF4-FFF2-40B4-BE49-F238E27FC236}">
-                <a16:creationId xmlns:a16="http://schemas.microsoft.com/office/drawing/2014/main" id="{F1816755-C568-45F5-96C3-4D18BEF500BD}"/>
+                <a16:creationId xmlns:a16="http://schemas.microsoft.com/office/drawing/2014/main" id="{025D109A-7DF5-4BA6-826B-15CED40EA118}"/>
               </a:ext>
             </a:extLst>
           </p:cNvPr>
@@ -2792,7 +2792,7 @@
           <p:cNvPr id="2" name="">
             <a:extLst xmlns:a="http://schemas.openxmlformats.org/drawingml/2006/main">
               <a:ext uri="{FF2B5EF4-FFF2-40B4-BE49-F238E27FC236}">
-                <a16:creationId xmlns:a16="http://schemas.microsoft.com/office/drawing/2014/main" id="{7DA74DB0-33EB-4878-B6D7-9AB6D40D6ADB}"/>
+                <a16:creationId xmlns:a16="http://schemas.microsoft.com/office/drawing/2014/main" id="{6CBE58F1-B83C-4D42-9B20-E7C17B8297FD}"/>
               </a:ext>
             </a:extLst>
           </p:cNvPr>
@@ -2827,7 +2827,7 @@
           <p:cNvPr id="3" name="">
             <a:extLst xmlns:a="http://schemas.openxmlformats.org/drawingml/2006/main">
               <a:ext uri="{FF2B5EF4-FFF2-40B4-BE49-F238E27FC236}">
-                <a16:creationId xmlns:a16="http://schemas.microsoft.com/office/drawing/2014/main" id="{026F42CB-9FD2-43CE-B732-AC445EB57DD8}"/>
+                <a16:creationId xmlns:a16="http://schemas.microsoft.com/office/drawing/2014/main" id="{69358829-B261-47D1-AAE0-89B4EA430B67}"/>
               </a:ext>
             </a:extLst>
           </p:cNvPr>
@@ -2881,7 +2881,7 @@
                 <a:ea typeface="Hiragino Sans"/>
                 <a:cs typeface="Hiragino Sans"/>
               </a:rPr>
-              <a:t>単体検証は、各primitiveが単独で設計どおり働くことを確認した</a:t>
+              <a:t>単体検証は、CCDファミリと圧力閉包が単独で働くことを確認</a:t>
             </a:r>
           </a:p>
         </p:txBody>
@@ -2891,7 +2891,7 @@
           <p:cNvPr id="4" name="">
             <a:extLst xmlns:a="http://schemas.openxmlformats.org/drawingml/2006/main">
               <a:ext uri="{FF2B5EF4-FFF2-40B4-BE49-F238E27FC236}">
-                <a16:creationId xmlns:a16="http://schemas.microsoft.com/office/drawing/2014/main" id="{71A23A4C-166A-4157-B2EB-2CF6ACB58C3F}"/>
+                <a16:creationId xmlns:a16="http://schemas.microsoft.com/office/drawing/2014/main" id="{7E24945E-4CAB-4B53-9E2F-22EAB3B99C1F}"/>
               </a:ext>
             </a:extLst>
           </p:cNvPr>
@@ -2945,7 +2945,7 @@
                 <a:ea typeface="Hiragino Sans"/>
                 <a:cs typeface="Hiragino Sans"/>
               </a:rPr>
-              <a:t>U1--U9は、基礎演算から否定検証までをトポロジカルに並べ、式・離散化・観測指標を一対一に結んだ。</a:t>
+              <a:t>基礎演算・非一様格子・静止液滴・圧力DCCD禁止を、式と観測指標の対応で確認した。</a:t>
             </a:r>
           </a:p>
         </p:txBody>
@@ -2955,7 +2955,7 @@
           <p:cNvPr id="5" name="">
             <a:extLst xmlns:a="http://schemas.openxmlformats.org/drawingml/2006/main">
               <a:ext uri="{FF2B5EF4-FFF2-40B4-BE49-F238E27FC236}">
-                <a16:creationId xmlns:a16="http://schemas.microsoft.com/office/drawing/2014/main" id="{823D7B95-F29F-47E0-BA58-69FBC4E5EAFE}"/>
+                <a16:creationId xmlns:a16="http://schemas.microsoft.com/office/drawing/2014/main" id="{64D64F7D-D798-4A0C-B3EC-936CB024C3CF}"/>
               </a:ext>
             </a:extLst>
           </p:cNvPr>
@@ -2988,7 +2988,7 @@
           <p:cNvPr id="6" name="">
             <a:extLst xmlns:a="http://schemas.openxmlformats.org/drawingml/2006/main">
               <a:ext uri="{FF2B5EF4-FFF2-40B4-BE49-F238E27FC236}">
-                <a16:creationId xmlns:a16="http://schemas.microsoft.com/office/drawing/2014/main" id="{B0F54418-5FB4-4B80-91C3-73C9E9150D06}"/>
+                <a16:creationId xmlns:a16="http://schemas.microsoft.com/office/drawing/2014/main" id="{183C6C44-690D-4E1C-9916-E33C08FB283C}"/>
               </a:ext>
             </a:extLst>
           </p:cNvPr>
@@ -3042,7 +3042,7 @@
                 <a:ea typeface="Hiragino Sans"/>
                 <a:cs typeface="Hiragino Sans"/>
               </a:rPr>
-              <a:t>U1</a:t>
+              <a:t>CCD演算子</a:t>
             </a:r>
           </a:p>
         </p:txBody>
@@ -3052,7 +3052,7 @@
           <p:cNvPr id="7" name="">
             <a:extLst xmlns:a="http://schemas.openxmlformats.org/drawingml/2006/main">
               <a:ext uri="{FF2B5EF4-FFF2-40B4-BE49-F238E27FC236}">
-                <a16:creationId xmlns:a16="http://schemas.microsoft.com/office/drawing/2014/main" id="{AFC40887-2010-42F9-947A-DAEC89BD7236}"/>
+                <a16:creationId xmlns:a16="http://schemas.microsoft.com/office/drawing/2014/main" id="{7917575C-ECF0-48AF-96E3-ECF60FE2DFA1}"/>
               </a:ext>
             </a:extLst>
           </p:cNvPr>
@@ -3106,7 +3106,7 @@
                 <a:ea typeface="Hiragino Sans"/>
                 <a:cs typeface="Hiragino Sans"/>
               </a:rPr>
-              <a:t>CCD h^6.0</a:t>
+              <a:t>h^6.0</a:t>
             </a:r>
           </a:p>
         </p:txBody>
@@ -3116,7 +3116,7 @@
           <p:cNvPr id="8" name="">
             <a:extLst xmlns:a="http://schemas.openxmlformats.org/drawingml/2006/main">
               <a:ext uri="{FF2B5EF4-FFF2-40B4-BE49-F238E27FC236}">
-                <a16:creationId xmlns:a16="http://schemas.microsoft.com/office/drawing/2014/main" id="{B19BC609-35B5-4C7C-B0DD-C191904E732C}"/>
+                <a16:creationId xmlns:a16="http://schemas.microsoft.com/office/drawing/2014/main" id="{9D2CDFFD-D766-460B-8442-CC853F8DFA31}"/>
               </a:ext>
             </a:extLst>
           </p:cNvPr>
@@ -3170,7 +3170,7 @@
                 <a:ea typeface="Hiragino Sans"/>
                 <a:cs typeface="Hiragino Sans"/>
               </a:rPr>
-              <a:t>operator</a:t>
+              <a:t>節点微分</a:t>
             </a:r>
           </a:p>
         </p:txBody>
@@ -3180,7 +3180,7 @@
           <p:cNvPr id="9" name="">
             <a:extLst xmlns:a="http://schemas.openxmlformats.org/drawingml/2006/main">
               <a:ext uri="{FF2B5EF4-FFF2-40B4-BE49-F238E27FC236}">
-                <a16:creationId xmlns:a16="http://schemas.microsoft.com/office/drawing/2014/main" id="{DA6CE0B8-2D84-4A0D-92AA-C7EF9CA2DAA4}"/>
+                <a16:creationId xmlns:a16="http://schemas.microsoft.com/office/drawing/2014/main" id="{A5E3E66F-F027-4E1A-A8AE-066E4FB40053}"/>
               </a:ext>
             </a:extLst>
           </p:cNvPr>
@@ -3213,7 +3213,7 @@
           <p:cNvPr id="10" name="">
             <a:extLst xmlns:a="http://schemas.openxmlformats.org/drawingml/2006/main">
               <a:ext uri="{FF2B5EF4-FFF2-40B4-BE49-F238E27FC236}">
-                <a16:creationId xmlns:a16="http://schemas.microsoft.com/office/drawing/2014/main" id="{F2D65BBB-59DB-4E5D-82AF-A81B3D0EE4E2}"/>
+                <a16:creationId xmlns:a16="http://schemas.microsoft.com/office/drawing/2014/main" id="{32C894E7-0A0A-421E-BCB3-80EFF5699DFB}"/>
               </a:ext>
             </a:extLst>
           </p:cNvPr>
@@ -3267,7 +3267,7 @@
                 <a:ea typeface="Hiragino Sans"/>
                 <a:cs typeface="Hiragino Sans"/>
               </a:rPr>
-              <a:t>U3</a:t>
+              <a:t>非一様格子</a:t>
             </a:r>
           </a:p>
         </p:txBody>
@@ -3277,7 +3277,7 @@
           <p:cNvPr id="11" name="">
             <a:extLst xmlns:a="http://schemas.openxmlformats.org/drawingml/2006/main">
               <a:ext uri="{FF2B5EF4-FFF2-40B4-BE49-F238E27FC236}">
-                <a16:creationId xmlns:a16="http://schemas.microsoft.com/office/drawing/2014/main" id="{4DB01899-9414-417B-928B-8B9198960331}"/>
+                <a16:creationId xmlns:a16="http://schemas.microsoft.com/office/drawing/2014/main" id="{ABDC4134-D76D-41BA-BE03-360C8DF79D59}"/>
               </a:ext>
             </a:extLst>
           </p:cNvPr>
@@ -3341,7 +3341,7 @@
           <p:cNvPr id="12" name="">
             <a:extLst xmlns:a="http://schemas.openxmlformats.org/drawingml/2006/main">
               <a:ext uri="{FF2B5EF4-FFF2-40B4-BE49-F238E27FC236}">
-                <a16:creationId xmlns:a16="http://schemas.microsoft.com/office/drawing/2014/main" id="{A167B0DB-4AEB-4534-A9CB-882B343A36B0}"/>
+                <a16:creationId xmlns:a16="http://schemas.microsoft.com/office/drawing/2014/main" id="{78A69FF1-4FF7-4020-8F1C-CAD53D13A047}"/>
               </a:ext>
             </a:extLst>
           </p:cNvPr>
@@ -3395,7 +3395,7 @@
                 <a:ea typeface="Hiragino Sans"/>
                 <a:cs typeface="Hiragino Sans"/>
               </a:rPr>
-              <a:t>nonuniform</a:t>
+              <a:t>metric consistency</a:t>
             </a:r>
           </a:p>
         </p:txBody>
@@ -3405,7 +3405,7 @@
           <p:cNvPr id="13" name="">
             <a:extLst xmlns:a="http://schemas.openxmlformats.org/drawingml/2006/main">
               <a:ext uri="{FF2B5EF4-FFF2-40B4-BE49-F238E27FC236}">
-                <a16:creationId xmlns:a16="http://schemas.microsoft.com/office/drawing/2014/main" id="{1E76040F-CD0B-407E-8181-96337DE86854}"/>
+                <a16:creationId xmlns:a16="http://schemas.microsoft.com/office/drawing/2014/main" id="{054D5121-D9E9-48DD-8CB1-34E28B948D28}"/>
               </a:ext>
             </a:extLst>
           </p:cNvPr>
@@ -3438,7 +3438,7 @@
           <p:cNvPr id="14" name="">
             <a:extLst xmlns:a="http://schemas.openxmlformats.org/drawingml/2006/main">
               <a:ext uri="{FF2B5EF4-FFF2-40B4-BE49-F238E27FC236}">
-                <a16:creationId xmlns:a16="http://schemas.microsoft.com/office/drawing/2014/main" id="{CB582F9C-A9B3-49AE-ADF0-011081C1B9BC}"/>
+                <a16:creationId xmlns:a16="http://schemas.microsoft.com/office/drawing/2014/main" id="{AC67373F-E8A1-466E-A10E-69B2CEDEE34D}"/>
               </a:ext>
             </a:extLst>
           </p:cNvPr>
@@ -3492,7 +3492,7 @@
                 <a:ea typeface="Hiragino Sans"/>
                 <a:cs typeface="Hiragino Sans"/>
               </a:rPr>
-              <a:t>U7</a:t>
+              <a:t>静止液滴</a:t>
             </a:r>
           </a:p>
         </p:txBody>
@@ -3502,7 +3502,7 @@
           <p:cNvPr id="15" name="">
             <a:extLst xmlns:a="http://schemas.openxmlformats.org/drawingml/2006/main">
               <a:ext uri="{FF2B5EF4-FFF2-40B4-BE49-F238E27FC236}">
-                <a16:creationId xmlns:a16="http://schemas.microsoft.com/office/drawing/2014/main" id="{392C8A86-3501-41C6-B19A-AD7F86A0B486}"/>
+                <a16:creationId xmlns:a16="http://schemas.microsoft.com/office/drawing/2014/main" id="{7CBE5350-7A72-45EF-A95A-321FF5AA74ED}"/>
               </a:ext>
             </a:extLst>
           </p:cNvPr>
@@ -3566,7 +3566,7 @@
           <p:cNvPr id="16" name="">
             <a:extLst xmlns:a="http://schemas.openxmlformats.org/drawingml/2006/main">
               <a:ext uri="{FF2B5EF4-FFF2-40B4-BE49-F238E27FC236}">
-                <a16:creationId xmlns:a16="http://schemas.microsoft.com/office/drawing/2014/main" id="{03AD9904-C6CC-4247-9017-333A42EFF6F7}"/>
+                <a16:creationId xmlns:a16="http://schemas.microsoft.com/office/drawing/2014/main" id="{169BA010-693A-4C96-8746-C1786EF57E36}"/>
               </a:ext>
             </a:extLst>
           </p:cNvPr>
@@ -3630,7 +3630,7 @@
           <p:cNvPr id="17" name="">
             <a:extLst xmlns:a="http://schemas.openxmlformats.org/drawingml/2006/main">
               <a:ext uri="{FF2B5EF4-FFF2-40B4-BE49-F238E27FC236}">
-                <a16:creationId xmlns:a16="http://schemas.microsoft.com/office/drawing/2014/main" id="{7C172058-8F67-4ED3-B6CC-DDF56B469AB6}"/>
+                <a16:creationId xmlns:a16="http://schemas.microsoft.com/office/drawing/2014/main" id="{37BD043B-96C9-47CD-8AFC-3E18C653AD8D}"/>
               </a:ext>
             </a:extLst>
           </p:cNvPr>
@@ -3663,7 +3663,7 @@
           <p:cNvPr id="18" name="">
             <a:extLst xmlns:a="http://schemas.openxmlformats.org/drawingml/2006/main">
               <a:ext uri="{FF2B5EF4-FFF2-40B4-BE49-F238E27FC236}">
-                <a16:creationId xmlns:a16="http://schemas.microsoft.com/office/drawing/2014/main" id="{38AF5DED-5B59-4A32-A5DC-01F028C5B7B0}"/>
+                <a16:creationId xmlns:a16="http://schemas.microsoft.com/office/drawing/2014/main" id="{DCA87902-3031-4EB4-AE1E-17933D8A4CE4}"/>
               </a:ext>
             </a:extLst>
           </p:cNvPr>
@@ -3717,7 +3717,7 @@
                 <a:ea typeface="Hiragino Sans"/>
                 <a:cs typeface="Hiragino Sans"/>
               </a:rPr>
-              <a:t>U9</a:t>
+              <a:t>圧力DCCD</a:t>
             </a:r>
           </a:p>
         </p:txBody>
@@ -3727,7 +3727,7 @@
           <p:cNvPr id="19" name="">
             <a:extLst xmlns:a="http://schemas.openxmlformats.org/drawingml/2006/main">
               <a:ext uri="{FF2B5EF4-FFF2-40B4-BE49-F238E27FC236}">
-                <a16:creationId xmlns:a16="http://schemas.microsoft.com/office/drawing/2014/main" id="{81744659-08D5-42EE-ACAF-724BA51AEF8B}"/>
+                <a16:creationId xmlns:a16="http://schemas.microsoft.com/office/drawing/2014/main" id="{FE3E7390-95D1-47AB-B289-8FB47552BAE1}"/>
               </a:ext>
             </a:extLst>
           </p:cNvPr>
@@ -3791,7 +3791,7 @@
           <p:cNvPr id="20" name="">
             <a:extLst xmlns:a="http://schemas.openxmlformats.org/drawingml/2006/main">
               <a:ext uri="{FF2B5EF4-FFF2-40B4-BE49-F238E27FC236}">
-                <a16:creationId xmlns:a16="http://schemas.microsoft.com/office/drawing/2014/main" id="{258B0602-FC4E-46BB-82B2-8D42518A23A7}"/>
+                <a16:creationId xmlns:a16="http://schemas.microsoft.com/office/drawing/2014/main" id="{383F0C54-59C0-46E1-BECC-21BE667C368B}"/>
               </a:ext>
             </a:extLst>
           </p:cNvPr>
@@ -3845,7 +3845,7 @@
                 <a:ea typeface="Hiragino Sans"/>
                 <a:cs typeface="Hiragino Sans"/>
               </a:rPr>
-              <a:t>DCCD on pressure</a:t>
+              <a:t>pressureには適用しない</a:t>
             </a:r>
           </a:p>
         </p:txBody>
@@ -3855,7 +3855,7 @@
           <p:cNvPr id="21" name="">
             <a:extLst xmlns:a="http://schemas.openxmlformats.org/drawingml/2006/main">
               <a:ext uri="{FF2B5EF4-FFF2-40B4-BE49-F238E27FC236}">
-                <a16:creationId xmlns:a16="http://schemas.microsoft.com/office/drawing/2014/main" id="{6B03F8F1-9484-4AFE-B236-69920115F9DC}"/>
+                <a16:creationId xmlns:a16="http://schemas.microsoft.com/office/drawing/2014/main" id="{B74AA5F6-821D-4BAF-A60C-5FBC57BB9D42}"/>
               </a:ext>
             </a:extLst>
           </p:cNvPr>
@@ -3890,7 +3890,7 @@
           <p:cNvPr id="22" name="">
             <a:extLst xmlns:a="http://schemas.openxmlformats.org/drawingml/2006/main">
               <a:ext uri="{FF2B5EF4-FFF2-40B4-BE49-F238E27FC236}">
-                <a16:creationId xmlns:a16="http://schemas.microsoft.com/office/drawing/2014/main" id="{B319D7AF-6A6D-49D7-B22D-B5F830F152B0}"/>
+                <a16:creationId xmlns:a16="http://schemas.microsoft.com/office/drawing/2014/main" id="{6F623DF4-5610-4173-81CE-9D5915E80E8E}"/>
               </a:ext>
             </a:extLst>
           </p:cNvPr>
@@ -3954,7 +3954,7 @@
           <p:cNvPr id="23" name="">
             <a:extLst xmlns:a="http://schemas.openxmlformats.org/drawingml/2006/main">
               <a:ext uri="{FF2B5EF4-FFF2-40B4-BE49-F238E27FC236}">
-                <a16:creationId xmlns:a16="http://schemas.microsoft.com/office/drawing/2014/main" id="{AF2C1D14-170C-4E94-A708-042CFFF2AD7C}"/>
+                <a16:creationId xmlns:a16="http://schemas.microsoft.com/office/drawing/2014/main" id="{0B8DAE77-AC9D-41E5-9887-0555C3F4378A}"/>
               </a:ext>
             </a:extLst>
           </p:cNvPr>
@@ -3989,7 +3989,7 @@
           <p:cNvPr id="24" name="">
             <a:extLst xmlns:a="http://schemas.openxmlformats.org/drawingml/2006/main">
               <a:ext uri="{FF2B5EF4-FFF2-40B4-BE49-F238E27FC236}">
-                <a16:creationId xmlns:a16="http://schemas.microsoft.com/office/drawing/2014/main" id="{55E2C163-768D-4AAA-82F5-4D300A08AD32}"/>
+                <a16:creationId xmlns:a16="http://schemas.microsoft.com/office/drawing/2014/main" id="{2CC65F41-9421-4AC1-A084-A97D100C12B0}"/>
               </a:ext>
             </a:extLst>
           </p:cNvPr>
@@ -4043,7 +4043,7 @@
                 <a:ea typeface="Hiragino Sans"/>
                 <a:cs typeface="Hiragino Sans"/>
               </a:rPr>
-              <a:t>source: paper/sections/12_component_verification.tex; 12h_summary.tex</a:t>
+              <a:t>source: Component verification summary</a:t>
             </a:r>
           </a:p>
         </p:txBody>
@@ -4053,7 +4053,7 @@
           <p:cNvPr id="25" name="">
             <a:extLst xmlns:a="http://schemas.openxmlformats.org/drawingml/2006/main">
               <a:ext uri="{FF2B5EF4-FFF2-40B4-BE49-F238E27FC236}">
-                <a16:creationId xmlns:a16="http://schemas.microsoft.com/office/drawing/2014/main" id="{23A8605D-8D52-489C-A677-27BF517DC926}"/>
+                <a16:creationId xmlns:a16="http://schemas.microsoft.com/office/drawing/2014/main" id="{0AEDA9FD-ACB2-4CA3-8BFA-506E9E3323C5}"/>
               </a:ext>
             </a:extLst>
           </p:cNvPr>
@@ -4115,7 +4115,7 @@
     </p:spTree>
     <p:extLst>
       <p:ext uri="{BB962C8B-B14F-4D97-AF65-F5344CB8AC3E}">
-        <p14:creationId xmlns:p14="http://schemas.microsoft.com/office/powerpoint/2010/main" val="1960211788"/>
+        <p14:creationId xmlns:p14="http://schemas.microsoft.com/office/powerpoint/2010/main" val="1779925214"/>
       </p:ext>
     </p:extLst>
   </p:cSld>
@@ -4139,7 +4139,7 @@
           <p:cNvPr id="1" name="">
             <a:extLst xmlns:a="http://schemas.openxmlformats.org/drawingml/2006/main">
               <a:ext uri="{FF2B5EF4-FFF2-40B4-BE49-F238E27FC236}">
-                <a16:creationId xmlns:a16="http://schemas.microsoft.com/office/drawing/2014/main" id="{6AE322DE-E856-4800-B9B2-8055B701D83E}"/>
+                <a16:creationId xmlns:a16="http://schemas.microsoft.com/office/drawing/2014/main" id="{53C2F731-7664-4ED9-9BC2-39135E32EB61}"/>
               </a:ext>
             </a:extLst>
           </p:cNvPr>
@@ -4174,7 +4174,7 @@
           <p:cNvPr id="2" name="">
             <a:extLst xmlns:a="http://schemas.openxmlformats.org/drawingml/2006/main">
               <a:ext uri="{FF2B5EF4-FFF2-40B4-BE49-F238E27FC236}">
-                <a16:creationId xmlns:a16="http://schemas.microsoft.com/office/drawing/2014/main" id="{1EB9A250-E46B-485B-BA6D-F8D846C8D285}"/>
+                <a16:creationId xmlns:a16="http://schemas.microsoft.com/office/drawing/2014/main" id="{C206FF05-52DA-4175-84A8-B1772E063CDC}"/>
               </a:ext>
             </a:extLst>
           </p:cNvPr>
@@ -4209,7 +4209,7 @@
           <p:cNvPr id="3" name="">
             <a:extLst xmlns:a="http://schemas.openxmlformats.org/drawingml/2006/main">
               <a:ext uri="{FF2B5EF4-FFF2-40B4-BE49-F238E27FC236}">
-                <a16:creationId xmlns:a16="http://schemas.microsoft.com/office/drawing/2014/main" id="{370E724B-C426-4F03-92EE-212D215A189A}"/>
+                <a16:creationId xmlns:a16="http://schemas.microsoft.com/office/drawing/2014/main" id="{6592F57F-4711-47EC-A077-F7F2DC9C956A}"/>
               </a:ext>
             </a:extLst>
           </p:cNvPr>
@@ -4263,7 +4263,7 @@
                 <a:ea typeface="Hiragino Sans"/>
                 <a:cs typeface="Hiragino Sans"/>
               </a:rPr>
-              <a:t>統合検証は、合格領域と条件付き領域を分けて読む</a:t>
+              <a:t>統合検証は、合格領域・構造修正・設計限界を分けて読む</a:t>
             </a:r>
           </a:p>
         </p:txBody>
@@ -4273,7 +4273,7 @@
           <p:cNvPr id="4" name="">
             <a:extLst xmlns:a="http://schemas.openxmlformats.org/drawingml/2006/main">
               <a:ext uri="{FF2B5EF4-FFF2-40B4-BE49-F238E27FC236}">
-                <a16:creationId xmlns:a16="http://schemas.microsoft.com/office/drawing/2014/main" id="{026BA82E-EFD9-49D0-89F3-EE4F1B029948}"/>
+                <a16:creationId xmlns:a16="http://schemas.microsoft.com/office/drawing/2014/main" id="{04AB4DE4-11BF-4719-AB20-900DA52CD59D}"/>
               </a:ext>
             </a:extLst>
           </p:cNvPr>
@@ -4327,7 +4327,7 @@
                 <a:ea typeface="Hiragino Sans"/>
                 <a:cs typeface="Hiragino Sans"/>
               </a:rPr>
-              <a:t>V1--V10は x ゼロだが、V7とV10の形状軸はType-Dとして設計限界を明示した。</a:t>
+              <a:t>単に「全ケース合格」と言わず、通常合格、質量補正での合格、理論的限界に分解した。</a:t>
             </a:r>
           </a:p>
         </p:txBody>
@@ -4337,7 +4337,7 @@
           <p:cNvPr id="5" name="">
             <a:extLst xmlns:a="http://schemas.openxmlformats.org/drawingml/2006/main">
               <a:ext uri="{FF2B5EF4-FFF2-40B4-BE49-F238E27FC236}">
-                <a16:creationId xmlns:a16="http://schemas.microsoft.com/office/drawing/2014/main" id="{51457E8E-21DB-4A17-BACD-B6F75E47765E}"/>
+                <a16:creationId xmlns:a16="http://schemas.microsoft.com/office/drawing/2014/main" id="{A54CA181-DCFD-4792-87E3-E36D9FF464B1}"/>
               </a:ext>
             </a:extLst>
           </p:cNvPr>
@@ -4391,7 +4391,7 @@
                 <a:ea typeface="Hiragino Sans"/>
                 <a:cs typeface="Hiragino Sans"/>
               </a:rPr>
-              <a:t>判定軸数（V10は質量保存軸と形状軸に分割）</a:t>
+              <a:t>判定軸数（強変形CLSは質量保存軸と形状軸に分割）</a:t>
             </a:r>
           </a:p>
         </p:txBody>
@@ -4401,7 +4401,7 @@
           <p:cNvPr id="6" name="">
             <a:extLst xmlns:a="http://schemas.openxmlformats.org/drawingml/2006/main">
               <a:ext uri="{FF2B5EF4-FFF2-40B4-BE49-F238E27FC236}">
-                <a16:creationId xmlns:a16="http://schemas.microsoft.com/office/drawing/2014/main" id="{A3A5A73B-7720-4324-BD19-5729EE6BC405}"/>
+                <a16:creationId xmlns:a16="http://schemas.microsoft.com/office/drawing/2014/main" id="{B3A577B2-E11C-42C1-B33A-62F7F3B60DA7}"/>
               </a:ext>
             </a:extLst>
           </p:cNvPr>
@@ -4455,7 +4455,7 @@
                 <a:ea typeface="Hiragino Sans"/>
                 <a:cs typeface="Hiragino Sans"/>
               </a:rPr>
-              <a:t>Design / Type-A</a:t>
+              <a:t>通常合格 / 文献基準</a:t>
             </a:r>
           </a:p>
         </p:txBody>
@@ -4465,7 +4465,7 @@
           <p:cNvPr id="7" name="">
             <a:extLst xmlns:a="http://schemas.openxmlformats.org/drawingml/2006/main">
               <a:ext uri="{FF2B5EF4-FFF2-40B4-BE49-F238E27FC236}">
-                <a16:creationId xmlns:a16="http://schemas.microsoft.com/office/drawing/2014/main" id="{7746B683-7B7D-4ADD-9B72-ECB3B7F1E7C8}"/>
+                <a16:creationId xmlns:a16="http://schemas.microsoft.com/office/drawing/2014/main" id="{40794FB1-B13E-4168-89FB-A85F2CFBC776}"/>
               </a:ext>
             </a:extLst>
           </p:cNvPr>
@@ -4500,7 +4500,7 @@
           <p:cNvPr id="8" name="">
             <a:extLst xmlns:a="http://schemas.openxmlformats.org/drawingml/2006/main">
               <a:ext uri="{FF2B5EF4-FFF2-40B4-BE49-F238E27FC236}">
-                <a16:creationId xmlns:a16="http://schemas.microsoft.com/office/drawing/2014/main" id="{410D131B-040B-45CE-817B-473B186291AC}"/>
+                <a16:creationId xmlns:a16="http://schemas.microsoft.com/office/drawing/2014/main" id="{4D29B966-3566-497C-BD38-A4B272FDB41C}"/>
               </a:ext>
             </a:extLst>
           </p:cNvPr>
@@ -4535,7 +4535,7 @@
           <p:cNvPr id="9" name="">
             <a:extLst xmlns:a="http://schemas.openxmlformats.org/drawingml/2006/main">
               <a:ext uri="{FF2B5EF4-FFF2-40B4-BE49-F238E27FC236}">
-                <a16:creationId xmlns:a16="http://schemas.microsoft.com/office/drawing/2014/main" id="{5008D558-56A4-4021-8384-90F13C9D200E}"/>
+                <a16:creationId xmlns:a16="http://schemas.microsoft.com/office/drawing/2014/main" id="{9F3EDA3E-3FB1-4DA7-8571-E59327AAE119}"/>
               </a:ext>
             </a:extLst>
           </p:cNvPr>
@@ -4599,7 +4599,7 @@
           <p:cNvPr id="10" name="">
             <a:extLst xmlns:a="http://schemas.openxmlformats.org/drawingml/2006/main">
               <a:ext uri="{FF2B5EF4-FFF2-40B4-BE49-F238E27FC236}">
-                <a16:creationId xmlns:a16="http://schemas.microsoft.com/office/drawing/2014/main" id="{C37134D7-3EA1-44DD-9709-D38398C6B11C}"/>
+                <a16:creationId xmlns:a16="http://schemas.microsoft.com/office/drawing/2014/main" id="{4968B4C3-D2DC-4E99-918C-9C94EC7E103D}"/>
               </a:ext>
             </a:extLst>
           </p:cNvPr>
@@ -4653,7 +4653,7 @@
                 <a:ea typeface="Hiragino Sans"/>
                 <a:cs typeface="Hiragino Sans"/>
               </a:rPr>
-              <a:t>Type-B</a:t>
+              <a:t>質量補正で合格</a:t>
             </a:r>
           </a:p>
         </p:txBody>
@@ -4663,7 +4663,7 @@
           <p:cNvPr id="11" name="">
             <a:extLst xmlns:a="http://schemas.openxmlformats.org/drawingml/2006/main">
               <a:ext uri="{FF2B5EF4-FFF2-40B4-BE49-F238E27FC236}">
-                <a16:creationId xmlns:a16="http://schemas.microsoft.com/office/drawing/2014/main" id="{04885B64-A537-4EC2-B23D-BD657501C3B5}"/>
+                <a16:creationId xmlns:a16="http://schemas.microsoft.com/office/drawing/2014/main" id="{03DC73ED-CA06-4F8C-9F47-6A9BAF8D4654}"/>
               </a:ext>
             </a:extLst>
           </p:cNvPr>
@@ -4698,7 +4698,7 @@
           <p:cNvPr id="12" name="">
             <a:extLst xmlns:a="http://schemas.openxmlformats.org/drawingml/2006/main">
               <a:ext uri="{FF2B5EF4-FFF2-40B4-BE49-F238E27FC236}">
-                <a16:creationId xmlns:a16="http://schemas.microsoft.com/office/drawing/2014/main" id="{A7E04479-953A-4C3F-BF2D-5FC93E9E97EE}"/>
+                <a16:creationId xmlns:a16="http://schemas.microsoft.com/office/drawing/2014/main" id="{9232ACC1-4651-4CC9-9988-2D146D8FA144}"/>
               </a:ext>
             </a:extLst>
           </p:cNvPr>
@@ -4733,7 +4733,7 @@
           <p:cNvPr id="13" name="">
             <a:extLst xmlns:a="http://schemas.openxmlformats.org/drawingml/2006/main">
               <a:ext uri="{FF2B5EF4-FFF2-40B4-BE49-F238E27FC236}">
-                <a16:creationId xmlns:a16="http://schemas.microsoft.com/office/drawing/2014/main" id="{BB620404-5571-4C77-B81B-0BCA5DBA97AF}"/>
+                <a16:creationId xmlns:a16="http://schemas.microsoft.com/office/drawing/2014/main" id="{498017D8-14DC-4E8A-BC4E-921A9674A78B}"/>
               </a:ext>
             </a:extLst>
           </p:cNvPr>
@@ -4797,7 +4797,7 @@
           <p:cNvPr id="14" name="">
             <a:extLst xmlns:a="http://schemas.openxmlformats.org/drawingml/2006/main">
               <a:ext uri="{FF2B5EF4-FFF2-40B4-BE49-F238E27FC236}">
-                <a16:creationId xmlns:a16="http://schemas.microsoft.com/office/drawing/2014/main" id="{CA82A1EB-C85A-4E7C-BC50-9AD1ADA197BB}"/>
+                <a16:creationId xmlns:a16="http://schemas.microsoft.com/office/drawing/2014/main" id="{34AF3EB4-83C3-458F-9288-07A25FA55046}"/>
               </a:ext>
             </a:extLst>
           </p:cNvPr>
@@ -4851,7 +4851,7 @@
                 <a:ea typeface="Hiragino Sans"/>
                 <a:cs typeface="Hiragino Sans"/>
               </a:rPr>
-              <a:t>Type-D</a:t>
+              <a:t>設計限界として記録</a:t>
             </a:r>
           </a:p>
         </p:txBody>
@@ -4861,7 +4861,7 @@
           <p:cNvPr id="15" name="">
             <a:extLst xmlns:a="http://schemas.openxmlformats.org/drawingml/2006/main">
               <a:ext uri="{FF2B5EF4-FFF2-40B4-BE49-F238E27FC236}">
-                <a16:creationId xmlns:a16="http://schemas.microsoft.com/office/drawing/2014/main" id="{92467254-C37D-4029-B556-F50EC869262D}"/>
+                <a16:creationId xmlns:a16="http://schemas.microsoft.com/office/drawing/2014/main" id="{5584DC74-401F-4CAD-9625-45EC24199E3E}"/>
               </a:ext>
             </a:extLst>
           </p:cNvPr>
@@ -4896,7 +4896,7 @@
           <p:cNvPr id="16" name="">
             <a:extLst xmlns:a="http://schemas.openxmlformats.org/drawingml/2006/main">
               <a:ext uri="{FF2B5EF4-FFF2-40B4-BE49-F238E27FC236}">
-                <a16:creationId xmlns:a16="http://schemas.microsoft.com/office/drawing/2014/main" id="{804E0CDC-5E75-4AC0-83EF-90C8E060D613}"/>
+                <a16:creationId xmlns:a16="http://schemas.microsoft.com/office/drawing/2014/main" id="{9DD0573B-48F7-4F12-8B4F-8E16FC465FBC}"/>
               </a:ext>
             </a:extLst>
           </p:cNvPr>
@@ -4931,7 +4931,7 @@
           <p:cNvPr id="17" name="">
             <a:extLst xmlns:a="http://schemas.openxmlformats.org/drawingml/2006/main">
               <a:ext uri="{FF2B5EF4-FFF2-40B4-BE49-F238E27FC236}">
-                <a16:creationId xmlns:a16="http://schemas.microsoft.com/office/drawing/2014/main" id="{34D7010E-6346-4A3B-A088-70607EA82DDE}"/>
+                <a16:creationId xmlns:a16="http://schemas.microsoft.com/office/drawing/2014/main" id="{BBABA216-D992-4C59-984A-03D66DEC4E7E}"/>
               </a:ext>
             </a:extLst>
           </p:cNvPr>
@@ -4995,7 +4995,7 @@
           <p:cNvPr id="18" name="">
             <a:extLst xmlns:a="http://schemas.openxmlformats.org/drawingml/2006/main">
               <a:ext uri="{FF2B5EF4-FFF2-40B4-BE49-F238E27FC236}">
-                <a16:creationId xmlns:a16="http://schemas.microsoft.com/office/drawing/2014/main" id="{5B4AC851-1126-478B-8EB9-0629465687D0}"/>
+                <a16:creationId xmlns:a16="http://schemas.microsoft.com/office/drawing/2014/main" id="{B7980A8D-4BD0-4525-AC59-E98476E410FF}"/>
               </a:ext>
             </a:extLst>
           </p:cNvPr>
@@ -5049,7 +5049,7 @@
                 <a:ea typeface="Hiragino Sans"/>
                 <a:cs typeface="Hiragino Sans"/>
               </a:rPr>
-              <a:t>Out of scope</a:t>
+              <a:t>保証範囲外</a:t>
             </a:r>
           </a:p>
         </p:txBody>
@@ -5059,7 +5059,7 @@
           <p:cNvPr id="19" name="">
             <a:extLst xmlns:a="http://schemas.openxmlformats.org/drawingml/2006/main">
               <a:ext uri="{FF2B5EF4-FFF2-40B4-BE49-F238E27FC236}">
-                <a16:creationId xmlns:a16="http://schemas.microsoft.com/office/drawing/2014/main" id="{A6E6C63B-44A1-4A1A-9755-7FE27D31B4C3}"/>
+                <a16:creationId xmlns:a16="http://schemas.microsoft.com/office/drawing/2014/main" id="{A72C0588-254D-4500-AD12-F16742C83532}"/>
               </a:ext>
             </a:extLst>
           </p:cNvPr>
@@ -5094,7 +5094,7 @@
           <p:cNvPr id="20" name="">
             <a:extLst xmlns:a="http://schemas.openxmlformats.org/drawingml/2006/main">
               <a:ext uri="{FF2B5EF4-FFF2-40B4-BE49-F238E27FC236}">
-                <a16:creationId xmlns:a16="http://schemas.microsoft.com/office/drawing/2014/main" id="{E4668BDD-DE5B-410E-A6B9-DD933DAC1E6D}"/>
+                <a16:creationId xmlns:a16="http://schemas.microsoft.com/office/drawing/2014/main" id="{2ED1D81A-32E0-402A-9C5D-9C7D28D8CB04}"/>
               </a:ext>
             </a:extLst>
           </p:cNvPr>
@@ -5129,7 +5129,7 @@
           <p:cNvPr id="21" name="">
             <a:extLst xmlns:a="http://schemas.openxmlformats.org/drawingml/2006/main">
               <a:ext uri="{FF2B5EF4-FFF2-40B4-BE49-F238E27FC236}">
-                <a16:creationId xmlns:a16="http://schemas.microsoft.com/office/drawing/2014/main" id="{1588B8DE-1B2C-4FB3-B9FB-95A8227229B6}"/>
+                <a16:creationId xmlns:a16="http://schemas.microsoft.com/office/drawing/2014/main" id="{EA4A4435-6880-4AA4-8E29-92B5A9DA1762}"/>
               </a:ext>
             </a:extLst>
           </p:cNvPr>
@@ -5193,7 +5193,7 @@
           <p:cNvPr id="22" name="">
             <a:extLst xmlns:a="http://schemas.openxmlformats.org/drawingml/2006/main">
               <a:ext uri="{FF2B5EF4-FFF2-40B4-BE49-F238E27FC236}">
-                <a16:creationId xmlns:a16="http://schemas.microsoft.com/office/drawing/2014/main" id="{2767AB88-840F-4408-8FFF-31329BB0CFDC}"/>
+                <a16:creationId xmlns:a16="http://schemas.microsoft.com/office/drawing/2014/main" id="{0D767893-83B4-46C5-8169-DD1B8BF79051}"/>
               </a:ext>
             </a:extLst>
           </p:cNvPr>
@@ -5228,7 +5228,7 @@
           <p:cNvPr id="23" name="">
             <a:extLst xmlns:a="http://schemas.openxmlformats.org/drawingml/2006/main">
               <a:ext uri="{FF2B5EF4-FFF2-40B4-BE49-F238E27FC236}">
-                <a16:creationId xmlns:a16="http://schemas.microsoft.com/office/drawing/2014/main" id="{74D23BF1-013E-4253-A944-1C28F5493E6E}"/>
+                <a16:creationId xmlns:a16="http://schemas.microsoft.com/office/drawing/2014/main" id="{C5C1C4D1-A41F-4BCA-9D8D-03F730752D0C}"/>
               </a:ext>
             </a:extLst>
           </p:cNvPr>
@@ -5282,7 +5282,7 @@
                 <a:ea typeface="Hiragino Sans"/>
                 <a:cs typeface="Hiragino Sans"/>
               </a:rPr>
-              <a:t>source: paper/sections/13_verification.tex; 13f_error_budget.tex</a:t>
+              <a:t>source: Integrated verification; error budget</a:t>
             </a:r>
           </a:p>
         </p:txBody>
@@ -5292,7 +5292,7 @@
           <p:cNvPr id="24" name="">
             <a:extLst xmlns:a="http://schemas.openxmlformats.org/drawingml/2006/main">
               <a:ext uri="{FF2B5EF4-FFF2-40B4-BE49-F238E27FC236}">
-                <a16:creationId xmlns:a16="http://schemas.microsoft.com/office/drawing/2014/main" id="{5E89BCC2-C07D-48A7-83E0-91D642DA0A4E}"/>
+                <a16:creationId xmlns:a16="http://schemas.microsoft.com/office/drawing/2014/main" id="{4B311622-3C96-4435-9456-AB5BDF570074}"/>
               </a:ext>
             </a:extLst>
           </p:cNvPr>
@@ -5354,7 +5354,7 @@
     </p:spTree>
     <p:extLst>
       <p:ext uri="{BB962C8B-B14F-4D97-AF65-F5344CB8AC3E}">
-        <p14:creationId xmlns:p14="http://schemas.microsoft.com/office/powerpoint/2010/main" val="1277368403"/>
+        <p14:creationId xmlns:p14="http://schemas.microsoft.com/office/powerpoint/2010/main" val="1689731443"/>
       </p:ext>
     </p:extLst>
   </p:cSld>
@@ -5378,7 +5378,7 @@
           <p:cNvPr id="1" name="">
             <a:extLst xmlns:a="http://schemas.openxmlformats.org/drawingml/2006/main">
               <a:ext uri="{FF2B5EF4-FFF2-40B4-BE49-F238E27FC236}">
-                <a16:creationId xmlns:a16="http://schemas.microsoft.com/office/drawing/2014/main" id="{027889CF-52E0-4636-8E69-2F1B34B0FC8A}"/>
+                <a16:creationId xmlns:a16="http://schemas.microsoft.com/office/drawing/2014/main" id="{37F48DD1-05A5-4C9E-9450-39FF79BE13D1}"/>
               </a:ext>
             </a:extLst>
           </p:cNvPr>
@@ -5413,7 +5413,7 @@
           <p:cNvPr id="2" name="">
             <a:extLst xmlns:a="http://schemas.openxmlformats.org/drawingml/2006/main">
               <a:ext uri="{FF2B5EF4-FFF2-40B4-BE49-F238E27FC236}">
-                <a16:creationId xmlns:a16="http://schemas.microsoft.com/office/drawing/2014/main" id="{E78263E2-90FE-4F0A-A3F4-C681DAD1155E}"/>
+                <a16:creationId xmlns:a16="http://schemas.microsoft.com/office/drawing/2014/main" id="{F84BB8FE-F140-4941-8B2E-5C63ED2ED598}"/>
               </a:ext>
             </a:extLst>
           </p:cNvPr>
@@ -5448,7 +5448,7 @@
           <p:cNvPr id="3" name="">
             <a:extLst xmlns:a="http://schemas.openxmlformats.org/drawingml/2006/main">
               <a:ext uri="{FF2B5EF4-FFF2-40B4-BE49-F238E27FC236}">
-                <a16:creationId xmlns:a16="http://schemas.microsoft.com/office/drawing/2014/main" id="{75DCFA6C-85C0-41DC-94DD-4E53A88DA8A2}"/>
+                <a16:creationId xmlns:a16="http://schemas.microsoft.com/office/drawing/2014/main" id="{CCFF37F7-C9A3-43C8-AA42-B7079FBFEE76}"/>
               </a:ext>
             </a:extLst>
           </p:cNvPr>
@@ -5512,7 +5512,7 @@
           <p:cNvPr id="4" name="">
             <a:extLst xmlns:a="http://schemas.openxmlformats.org/drawingml/2006/main">
               <a:ext uri="{FF2B5EF4-FFF2-40B4-BE49-F238E27FC236}">
-                <a16:creationId xmlns:a16="http://schemas.microsoft.com/office/drawing/2014/main" id="{450CB72C-370F-4F55-B319-112938B19DD9}"/>
+                <a16:creationId xmlns:a16="http://schemas.microsoft.com/office/drawing/2014/main" id="{AF0AFF3B-5BD3-4382-AA1E-65264A7140CB}"/>
               </a:ext>
             </a:extLst>
           </p:cNvPr>
@@ -5576,7 +5576,7 @@
           <p:cNvPr id="5" name="">
             <a:extLst xmlns:a="http://schemas.openxmlformats.org/drawingml/2006/main">
               <a:ext uri="{FF2B5EF4-FFF2-40B4-BE49-F238E27FC236}">
-                <a16:creationId xmlns:a16="http://schemas.microsoft.com/office/drawing/2014/main" id="{77EBC99B-8A46-457B-94D3-C5C87D7E8ACB}"/>
+                <a16:creationId xmlns:a16="http://schemas.microsoft.com/office/drawing/2014/main" id="{654A77A1-2118-41C9-93FB-B445EAE214EE}"/>
               </a:ext>
             </a:extLst>
           </p:cNvPr>
@@ -5609,7 +5609,7 @@
           <p:cNvPr id="6" name="">
             <a:extLst xmlns:a="http://schemas.openxmlformats.org/drawingml/2006/main">
               <a:ext uri="{FF2B5EF4-FFF2-40B4-BE49-F238E27FC236}">
-                <a16:creationId xmlns:a16="http://schemas.microsoft.com/office/drawing/2014/main" id="{D662EC76-8816-4381-A116-CDF7F40A8099}"/>
+                <a16:creationId xmlns:a16="http://schemas.microsoft.com/office/drawing/2014/main" id="{E53785BD-7849-435C-9E83-9DD6E2F1924A}"/>
               </a:ext>
             </a:extLst>
           </p:cNvPr>
@@ -5663,7 +5663,7 @@
                 <a:ea typeface="Hiragino Sans"/>
                 <a:cs typeface="Hiragino Sans"/>
               </a:rPr>
-              <a:t>V3</a:t>
+              <a:t>静止液滴</a:t>
             </a:r>
           </a:p>
         </p:txBody>
@@ -5673,7 +5673,7 @@
           <p:cNvPr id="7" name="">
             <a:extLst xmlns:a="http://schemas.openxmlformats.org/drawingml/2006/main">
               <a:ext uri="{FF2B5EF4-FFF2-40B4-BE49-F238E27FC236}">
-                <a16:creationId xmlns:a16="http://schemas.microsoft.com/office/drawing/2014/main" id="{CF49B41D-51F4-4F19-8282-554CAB9A02CB}"/>
+                <a16:creationId xmlns:a16="http://schemas.microsoft.com/office/drawing/2014/main" id="{72C65401-EF8E-4E58-B1C6-33E59EA94967}"/>
               </a:ext>
             </a:extLst>
           </p:cNvPr>
@@ -5737,7 +5737,7 @@
           <p:cNvPr id="8" name="">
             <a:extLst xmlns:a="http://schemas.openxmlformats.org/drawingml/2006/main">
               <a:ext uri="{FF2B5EF4-FFF2-40B4-BE49-F238E27FC236}">
-                <a16:creationId xmlns:a16="http://schemas.microsoft.com/office/drawing/2014/main" id="{ACFCDE60-03BE-44FF-A94E-4F70A15B1491}"/>
+                <a16:creationId xmlns:a16="http://schemas.microsoft.com/office/drawing/2014/main" id="{D9E48C65-DC9E-4713-B847-730284778450}"/>
               </a:ext>
             </a:extLst>
           </p:cNvPr>
@@ -5801,7 +5801,7 @@
           <p:cNvPr id="9" name="">
             <a:extLst xmlns:a="http://schemas.openxmlformats.org/drawingml/2006/main">
               <a:ext uri="{FF2B5EF4-FFF2-40B4-BE49-F238E27FC236}">
-                <a16:creationId xmlns:a16="http://schemas.microsoft.com/office/drawing/2014/main" id="{D829572D-080C-4459-8492-069C53C4CBF5}"/>
+                <a16:creationId xmlns:a16="http://schemas.microsoft.com/office/drawing/2014/main" id="{6CC22A9B-85C6-410C-83F6-96F196E6BBAD}"/>
               </a:ext>
             </a:extLst>
           </p:cNvPr>
@@ -5834,7 +5834,7 @@
           <p:cNvPr id="10" name="">
             <a:extLst xmlns:a="http://schemas.openxmlformats.org/drawingml/2006/main">
               <a:ext uri="{FF2B5EF4-FFF2-40B4-BE49-F238E27FC236}">
-                <a16:creationId xmlns:a16="http://schemas.microsoft.com/office/drawing/2014/main" id="{B3B6AF5E-80E3-40AD-B4C3-326D2B4D3694}"/>
+                <a16:creationId xmlns:a16="http://schemas.microsoft.com/office/drawing/2014/main" id="{B0F625DB-3008-4D8A-B648-A4470F0FF4F2}"/>
               </a:ext>
             </a:extLst>
           </p:cNvPr>
@@ -5888,7 +5888,7 @@
                 <a:ea typeface="Hiragino Sans"/>
                 <a:cs typeface="Hiragino Sans"/>
               </a:rPr>
-              <a:t>V5</a:t>
+              <a:t>寄生流れ</a:t>
             </a:r>
           </a:p>
         </p:txBody>
@@ -5898,7 +5898,7 @@
           <p:cNvPr id="11" name="">
             <a:extLst xmlns:a="http://schemas.openxmlformats.org/drawingml/2006/main">
               <a:ext uri="{FF2B5EF4-FFF2-40B4-BE49-F238E27FC236}">
-                <a16:creationId xmlns:a16="http://schemas.microsoft.com/office/drawing/2014/main" id="{94188FF9-22C8-48F0-9396-C85983568E02}"/>
+                <a16:creationId xmlns:a16="http://schemas.microsoft.com/office/drawing/2014/main" id="{A2C46BFF-A71E-426D-A88E-4406FEDF1C7A}"/>
               </a:ext>
             </a:extLst>
           </p:cNvPr>
@@ -5962,7 +5962,7 @@
           <p:cNvPr id="12" name="">
             <a:extLst xmlns:a="http://schemas.openxmlformats.org/drawingml/2006/main">
               <a:ext uri="{FF2B5EF4-FFF2-40B4-BE49-F238E27FC236}">
-                <a16:creationId xmlns:a16="http://schemas.microsoft.com/office/drawing/2014/main" id="{C2BF9922-FD99-4C4D-9BFB-2D4035BF2B22}"/>
+                <a16:creationId xmlns:a16="http://schemas.microsoft.com/office/drawing/2014/main" id="{4867B0AA-80DF-44E8-A16F-E23B4FDCA2DE}"/>
               </a:ext>
             </a:extLst>
           </p:cNvPr>
@@ -6026,7 +6026,7 @@
           <p:cNvPr id="13" name="">
             <a:extLst xmlns:a="http://schemas.openxmlformats.org/drawingml/2006/main">
               <a:ext uri="{FF2B5EF4-FFF2-40B4-BE49-F238E27FC236}">
-                <a16:creationId xmlns:a16="http://schemas.microsoft.com/office/drawing/2014/main" id="{2F203ED2-9ED0-495F-95E5-CD583757247C}"/>
+                <a16:creationId xmlns:a16="http://schemas.microsoft.com/office/drawing/2014/main" id="{C5F3BCB0-5408-4030-A3A4-623E83E8464B}"/>
               </a:ext>
             </a:extLst>
           </p:cNvPr>
@@ -6059,7 +6059,7 @@
           <p:cNvPr id="14" name="">
             <a:extLst xmlns:a="http://schemas.openxmlformats.org/drawingml/2006/main">
               <a:ext uri="{FF2B5EF4-FFF2-40B4-BE49-F238E27FC236}">
-                <a16:creationId xmlns:a16="http://schemas.microsoft.com/office/drawing/2014/main" id="{060A240D-3AD2-4F9E-9D1A-0DD13DBC6910}"/>
+                <a16:creationId xmlns:a16="http://schemas.microsoft.com/office/drawing/2014/main" id="{A928A4A7-FFAB-4980-8246-A48EA5DD9BDE}"/>
               </a:ext>
             </a:extLst>
           </p:cNvPr>
@@ -6113,7 +6113,7 @@
                 <a:ea typeface="Hiragino Sans"/>
                 <a:cs typeface="Hiragino Sans"/>
               </a:rPr>
-              <a:t>V6</a:t>
+              <a:t>密度比</a:t>
             </a:r>
           </a:p>
         </p:txBody>
@@ -6123,7 +6123,7 @@
           <p:cNvPr id="15" name="">
             <a:extLst xmlns:a="http://schemas.openxmlformats.org/drawingml/2006/main">
               <a:ext uri="{FF2B5EF4-FFF2-40B4-BE49-F238E27FC236}">
-                <a16:creationId xmlns:a16="http://schemas.microsoft.com/office/drawing/2014/main" id="{C3C3B101-41AA-4FB3-A230-6BF1A497000F}"/>
+                <a16:creationId xmlns:a16="http://schemas.microsoft.com/office/drawing/2014/main" id="{C2F267A2-868A-4815-8F99-72FA1D1EA184}"/>
               </a:ext>
             </a:extLst>
           </p:cNvPr>
@@ -6187,7 +6187,7 @@
           <p:cNvPr id="16" name="">
             <a:extLst xmlns:a="http://schemas.openxmlformats.org/drawingml/2006/main">
               <a:ext uri="{FF2B5EF4-FFF2-40B4-BE49-F238E27FC236}">
-                <a16:creationId xmlns:a16="http://schemas.microsoft.com/office/drawing/2014/main" id="{DBCE7E32-6C9D-414A-A1B4-25BAA0040113}"/>
+                <a16:creationId xmlns:a16="http://schemas.microsoft.com/office/drawing/2014/main" id="{F939FD35-6EBE-4B3B-AD5F-FEDC4CF237E6}"/>
               </a:ext>
             </a:extLst>
           </p:cNvPr>
@@ -6251,7 +6251,7 @@
           <p:cNvPr id="17" name="">
             <a:extLst xmlns:a="http://schemas.openxmlformats.org/drawingml/2006/main">
               <a:ext uri="{FF2B5EF4-FFF2-40B4-BE49-F238E27FC236}">
-                <a16:creationId xmlns:a16="http://schemas.microsoft.com/office/drawing/2014/main" id="{C390FBB3-7927-4047-815B-F287CDB37E90}"/>
+                <a16:creationId xmlns:a16="http://schemas.microsoft.com/office/drawing/2014/main" id="{F0195E3A-CF73-494F-A2AD-AA16571C82CB}"/>
               </a:ext>
             </a:extLst>
           </p:cNvPr>
@@ -6284,7 +6284,7 @@
           <p:cNvPr id="18" name="">
             <a:extLst xmlns:a="http://schemas.openxmlformats.org/drawingml/2006/main">
               <a:ext uri="{FF2B5EF4-FFF2-40B4-BE49-F238E27FC236}">
-                <a16:creationId xmlns:a16="http://schemas.microsoft.com/office/drawing/2014/main" id="{7288630F-B005-4669-8AAA-C5F8B14AFEBE}"/>
+                <a16:creationId xmlns:a16="http://schemas.microsoft.com/office/drawing/2014/main" id="{0E506400-4AAC-4FAE-9940-759261FD5023}"/>
               </a:ext>
             </a:extLst>
           </p:cNvPr>
@@ -6338,7 +6338,7 @@
                 <a:ea typeface="Hiragino Sans"/>
                 <a:cs typeface="Hiragino Sans"/>
               </a:rPr>
-              <a:t>V6</a:t>
+              <a:t>体積保存</a:t>
             </a:r>
           </a:p>
         </p:txBody>
@@ -6348,7 +6348,7 @@
           <p:cNvPr id="19" name="">
             <a:extLst xmlns:a="http://schemas.openxmlformats.org/drawingml/2006/main">
               <a:ext uri="{FF2B5EF4-FFF2-40B4-BE49-F238E27FC236}">
-                <a16:creationId xmlns:a16="http://schemas.microsoft.com/office/drawing/2014/main" id="{61DC3B9E-458A-41A8-8E90-EC5ECB810131}"/>
+                <a16:creationId xmlns:a16="http://schemas.microsoft.com/office/drawing/2014/main" id="{2EB72B31-636D-42EC-ABF0-254337F7FFDA}"/>
               </a:ext>
             </a:extLst>
           </p:cNvPr>
@@ -6412,7 +6412,7 @@
           <p:cNvPr id="20" name="">
             <a:extLst xmlns:a="http://schemas.openxmlformats.org/drawingml/2006/main">
               <a:ext uri="{FF2B5EF4-FFF2-40B4-BE49-F238E27FC236}">
-                <a16:creationId xmlns:a16="http://schemas.microsoft.com/office/drawing/2014/main" id="{71DBF420-D3D5-4243-90C1-C5B1AE98EA20}"/>
+                <a16:creationId xmlns:a16="http://schemas.microsoft.com/office/drawing/2014/main" id="{3612F4F8-4B4E-49E8-B037-C840E37EF158}"/>
               </a:ext>
             </a:extLst>
           </p:cNvPr>
@@ -6476,7 +6476,7 @@
           <p:cNvPr id="21" name="">
             <a:extLst xmlns:a="http://schemas.openxmlformats.org/drawingml/2006/main">
               <a:ext uri="{FF2B5EF4-FFF2-40B4-BE49-F238E27FC236}">
-                <a16:creationId xmlns:a16="http://schemas.microsoft.com/office/drawing/2014/main" id="{D35E0231-BFC9-4F54-B1BE-A2A24F0FBE42}"/>
+                <a16:creationId xmlns:a16="http://schemas.microsoft.com/office/drawing/2014/main" id="{E6EDC9C2-44BA-4B0D-A1A5-A105CE99FD13}"/>
               </a:ext>
             </a:extLst>
           </p:cNvPr>
@@ -6511,7 +6511,7 @@
           <p:cNvPr id="22" name="">
             <a:extLst xmlns:a="http://schemas.openxmlformats.org/drawingml/2006/main">
               <a:ext uri="{FF2B5EF4-FFF2-40B4-BE49-F238E27FC236}">
-                <a16:creationId xmlns:a16="http://schemas.microsoft.com/office/drawing/2014/main" id="{7F63CD2C-9A9A-47DD-8BD3-9F328D2F44A3}"/>
+                <a16:creationId xmlns:a16="http://schemas.microsoft.com/office/drawing/2014/main" id="{0E080B07-BF39-4A53-85A7-28BC10E817EC}"/>
               </a:ext>
             </a:extLst>
           </p:cNvPr>
@@ -6565,7 +6565,7 @@
                 <a:ea typeface="Hiragino Sans"/>
                 <a:cs typeface="Hiragino Sans"/>
               </a:rPr>
-              <a:t>source: paper/sections/13b_twophase_static.tex; 13d_density_ratio.tex; 13f_error_budget.tex</a:t>
+              <a:t>source: Static droplet; density-ratio sweep; error budget</a:t>
             </a:r>
           </a:p>
         </p:txBody>
@@ -6575,7 +6575,7 @@
           <p:cNvPr id="23" name="">
             <a:extLst xmlns:a="http://schemas.openxmlformats.org/drawingml/2006/main">
               <a:ext uri="{FF2B5EF4-FFF2-40B4-BE49-F238E27FC236}">
-                <a16:creationId xmlns:a16="http://schemas.microsoft.com/office/drawing/2014/main" id="{34521856-1330-4020-B1D5-E3DD7812366A}"/>
+                <a16:creationId xmlns:a16="http://schemas.microsoft.com/office/drawing/2014/main" id="{395E9F34-0629-4A14-A11D-848595CAF3FE}"/>
               </a:ext>
             </a:extLst>
           </p:cNvPr>
@@ -6637,7 +6637,7 @@
     </p:spTree>
     <p:extLst>
       <p:ext uri="{BB962C8B-B14F-4D97-AF65-F5344CB8AC3E}">
-        <p14:creationId xmlns:p14="http://schemas.microsoft.com/office/powerpoint/2010/main" val="232635242"/>
+        <p14:creationId xmlns:p14="http://schemas.microsoft.com/office/powerpoint/2010/main" val="1302489221"/>
       </p:ext>
     </p:extLst>
   </p:cSld>
@@ -6661,7 +6661,7 @@
           <p:cNvPr id="1" name="">
             <a:extLst xmlns:a="http://schemas.openxmlformats.org/drawingml/2006/main">
               <a:ext uri="{FF2B5EF4-FFF2-40B4-BE49-F238E27FC236}">
-                <a16:creationId xmlns:a16="http://schemas.microsoft.com/office/drawing/2014/main" id="{C0A2D0A2-25A7-4D17-8EFE-96D9AFC0C318}"/>
+                <a16:creationId xmlns:a16="http://schemas.microsoft.com/office/drawing/2014/main" id="{3645B0FA-045E-458A-8412-9B41FACBF8CF}"/>
               </a:ext>
             </a:extLst>
           </p:cNvPr>
@@ -6696,7 +6696,7 @@
           <p:cNvPr id="2" name="">
             <a:extLst xmlns:a="http://schemas.openxmlformats.org/drawingml/2006/main">
               <a:ext uri="{FF2B5EF4-FFF2-40B4-BE49-F238E27FC236}">
-                <a16:creationId xmlns:a16="http://schemas.microsoft.com/office/drawing/2014/main" id="{677A8417-D52D-485A-99ED-1A86B9D83E1F}"/>
+                <a16:creationId xmlns:a16="http://schemas.microsoft.com/office/drawing/2014/main" id="{33490AEC-B86C-4163-BD27-788831EC5A19}"/>
               </a:ext>
             </a:extLst>
           </p:cNvPr>
@@ -6731,7 +6731,7 @@
           <p:cNvPr id="3" name="">
             <a:extLst xmlns:a="http://schemas.openxmlformats.org/drawingml/2006/main">
               <a:ext uri="{FF2B5EF4-FFF2-40B4-BE49-F238E27FC236}">
-                <a16:creationId xmlns:a16="http://schemas.microsoft.com/office/drawing/2014/main" id="{85D0C17D-A113-484B-AA7F-30E04066986C}"/>
+                <a16:creationId xmlns:a16="http://schemas.microsoft.com/office/drawing/2014/main" id="{C5A27CC1-128A-4AB8-A5C8-47AC107C2D49}"/>
               </a:ext>
             </a:extLst>
           </p:cNvPr>
@@ -6785,7 +6785,7 @@
                 <a:ea typeface="Hiragino Sans"/>
                 <a:cs typeface="Hiragino Sans"/>
               </a:rPr>
-              <a:t>限界は隠さず、どの誤差源が支配するかを分離する</a:t>
+              <a:t>設計限界は、テストIDではなく物理的な誤差源として読む</a:t>
             </a:r>
           </a:p>
         </p:txBody>
@@ -6795,7 +6795,7 @@
           <p:cNvPr id="4" name="">
             <a:extLst xmlns:a="http://schemas.openxmlformats.org/drawingml/2006/main">
               <a:ext uri="{FF2B5EF4-FFF2-40B4-BE49-F238E27FC236}">
-                <a16:creationId xmlns:a16="http://schemas.microsoft.com/office/drawing/2014/main" id="{A368CD6E-6D68-44CA-8D91-007CAF3E3848}"/>
+                <a16:creationId xmlns:a16="http://schemas.microsoft.com/office/drawing/2014/main" id="{0950B721-E997-4E61-88F3-FFC0ED2A1D8C}"/>
               </a:ext>
             </a:extLst>
           </p:cNvPr>
@@ -6849,7 +6849,7 @@
                 <a:ea typeface="Hiragino Sans"/>
                 <a:cs typeface="Hiragino Sans"/>
               </a:rPr>
-              <a:t>二相時間精度はcapillary pressure-jump/projection界面帯に律速され、CLS形状復元は固定格子の位相・filament限界に当たる。</a:t>
+              <a:t>時間精度は毛管圧力ジャンプとprojectionの界面帯に律速され、強変形CLSは固定格子の位相・細線解像限界に当たる。</a:t>
             </a:r>
           </a:p>
         </p:txBody>
@@ -6859,7 +6859,7 @@
           <p:cNvPr id="5" name="">
             <a:extLst xmlns:a="http://schemas.openxmlformats.org/drawingml/2006/main">
               <a:ext uri="{FF2B5EF4-FFF2-40B4-BE49-F238E27FC236}">
-                <a16:creationId xmlns:a16="http://schemas.microsoft.com/office/drawing/2014/main" id="{0AB69275-FF15-4B0F-9C7C-006EB6FC6020}"/>
+                <a16:creationId xmlns:a16="http://schemas.microsoft.com/office/drawing/2014/main" id="{883A1BD0-12B3-4C7E-B85A-9DAE2F1393AB}"/>
               </a:ext>
             </a:extLst>
           </p:cNvPr>
@@ -6892,19 +6892,19 @@
           <p:cNvPr id="6" name="">
             <a:extLst xmlns:a="http://schemas.openxmlformats.org/drawingml/2006/main">
               <a:ext uri="{FF2B5EF4-FFF2-40B4-BE49-F238E27FC236}">
-                <a16:creationId xmlns:a16="http://schemas.microsoft.com/office/drawing/2014/main" id="{8D4F6FBE-33CF-47C0-B3DC-1781F05AD448}"/>
-              </a:ext>
-            </a:extLst>
-          </p:cNvPr>
-          <p:cNvSpPr>
-            <a:spLocks xmlns:a="http://schemas.openxmlformats.org/drawingml/2006/main" noGrp="1"/>
-          </p:cNvSpPr>
-          <p:nvPr/>
-        </p:nvSpPr>
-        <p:spPr>
-          <a:xfrm xmlns:a="http://schemas.openxmlformats.org/drawingml/2006/main">
-            <a:off x="1238250" y="2381250"/>
-            <a:ext cx="914400" cy="228600"/>
+                <a16:creationId xmlns:a16="http://schemas.microsoft.com/office/drawing/2014/main" id="{097733A3-8136-4B2D-A352-3680EFF3E322}"/>
+              </a:ext>
+            </a:extLst>
+          </p:cNvPr>
+          <p:cNvSpPr>
+            <a:spLocks xmlns:a="http://schemas.openxmlformats.org/drawingml/2006/main" noGrp="1"/>
+          </p:cNvSpPr>
+          <p:nvPr/>
+        </p:nvSpPr>
+        <p:spPr>
+          <a:xfrm xmlns:a="http://schemas.openxmlformats.org/drawingml/2006/main">
+            <a:off x="1200150" y="2381250"/>
+            <a:ext cx="1352550" cy="228600"/>
           </a:xfrm>
           <a:prstGeom xmlns:a="http://schemas.openxmlformats.org/drawingml/2006/main" prst="rect">
             <a:avLst/>
@@ -6928,7 +6928,7 @@
           <a:lstStyle xmlns:a="http://schemas.openxmlformats.org/drawingml/2006/main"/>
           <a:p xmlns:a="http://schemas.openxmlformats.org/drawingml/2006/main">
             <a:pPr algn="l">
-              <a:defRPr sz="1350" b="1">
+              <a:defRPr sz="1200" b="1">
                 <a:solidFill>
                   <a:srgbClr val="D95D39"/>
                 </a:solidFill>
@@ -6938,7 +6938,7 @@
               </a:defRPr>
             </a:pPr>
             <a:r>
-              <a:rPr sz="1350" b="1">
+              <a:rPr sz="1200" b="1">
                 <a:solidFill>
                   <a:srgbClr val="D95D39"/>
                 </a:solidFill>
@@ -6946,7 +6946,7 @@
                 <a:ea typeface="Hiragino Sans"/>
                 <a:cs typeface="Hiragino Sans"/>
               </a:rPr>
-              <a:t>V7</a:t>
+              <a:t>二相時間精度</a:t>
             </a:r>
           </a:p>
         </p:txBody>
@@ -6956,19 +6956,19 @@
           <p:cNvPr id="7" name="">
             <a:extLst xmlns:a="http://schemas.openxmlformats.org/drawingml/2006/main">
               <a:ext uri="{FF2B5EF4-FFF2-40B4-BE49-F238E27FC236}">
-                <a16:creationId xmlns:a16="http://schemas.microsoft.com/office/drawing/2014/main" id="{482B6303-CABA-4BA8-BF0A-0385F5E70498}"/>
-              </a:ext>
-            </a:extLst>
-          </p:cNvPr>
-          <p:cNvSpPr>
-            <a:spLocks xmlns:a="http://schemas.openxmlformats.org/drawingml/2006/main" noGrp="1"/>
-          </p:cNvSpPr>
-          <p:nvPr/>
-        </p:nvSpPr>
-        <p:spPr>
-          <a:xfrm xmlns:a="http://schemas.openxmlformats.org/drawingml/2006/main">
-            <a:off x="2381250" y="2352675"/>
-            <a:ext cx="2000250" cy="285750"/>
+                <a16:creationId xmlns:a16="http://schemas.microsoft.com/office/drawing/2014/main" id="{56BC4752-FD42-43BA-BCFF-1F1E93D0351A}"/>
+              </a:ext>
+            </a:extLst>
+          </p:cNvPr>
+          <p:cNvSpPr>
+            <a:spLocks xmlns:a="http://schemas.openxmlformats.org/drawingml/2006/main" noGrp="1"/>
+          </p:cNvSpPr>
+          <p:nvPr/>
+        </p:nvSpPr>
+        <p:spPr>
+          <a:xfrm xmlns:a="http://schemas.openxmlformats.org/drawingml/2006/main">
+            <a:off x="2857500" y="2352675"/>
+            <a:ext cx="1809750" cy="285750"/>
           </a:xfrm>
           <a:prstGeom xmlns:a="http://schemas.openxmlformats.org/drawingml/2006/main" prst="rect">
             <a:avLst/>
@@ -7020,19 +7020,19 @@
           <p:cNvPr id="8" name="">
             <a:extLst xmlns:a="http://schemas.openxmlformats.org/drawingml/2006/main">
               <a:ext uri="{FF2B5EF4-FFF2-40B4-BE49-F238E27FC236}">
-                <a16:creationId xmlns:a16="http://schemas.microsoft.com/office/drawing/2014/main" id="{AB94DD7E-844D-410F-8E07-10507F2E313D}"/>
-              </a:ext>
-            </a:extLst>
-          </p:cNvPr>
-          <p:cNvSpPr>
-            <a:spLocks xmlns:a="http://schemas.openxmlformats.org/drawingml/2006/main" noGrp="1"/>
-          </p:cNvSpPr>
-          <p:nvPr/>
-        </p:nvSpPr>
-        <p:spPr>
-          <a:xfrm xmlns:a="http://schemas.openxmlformats.org/drawingml/2006/main">
-            <a:off x="4686300" y="2390775"/>
-            <a:ext cx="5810250" cy="228600"/>
+                <a16:creationId xmlns:a16="http://schemas.microsoft.com/office/drawing/2014/main" id="{497FCF9A-E5B2-4ADE-BFCC-9B95107CED0F}"/>
+              </a:ext>
+            </a:extLst>
+          </p:cNvPr>
+          <p:cNvSpPr>
+            <a:spLocks xmlns:a="http://schemas.openxmlformats.org/drawingml/2006/main" noGrp="1"/>
+          </p:cNvSpPr>
+          <p:nvPr/>
+        </p:nvSpPr>
+        <p:spPr>
+          <a:xfrm xmlns:a="http://schemas.openxmlformats.org/drawingml/2006/main">
+            <a:off x="4953000" y="2390775"/>
+            <a:ext cx="5524500" cy="228600"/>
           </a:xfrm>
           <a:prstGeom xmlns:a="http://schemas.openxmlformats.org/drawingml/2006/main" prst="rect">
             <a:avLst/>
@@ -7074,7 +7074,7 @@
                 <a:ea typeface="Hiragino Sans"/>
                 <a:cs typeface="Hiragino Sans"/>
               </a:rPr>
-              <a:t>BDF2単体ではなくcoupled-stack実効次数</a:t>
+              <a:t>毛管pressure-jump/projection界面帯が支配</a:t>
             </a:r>
           </a:p>
         </p:txBody>
@@ -7084,7 +7084,7 @@
           <p:cNvPr id="9" name="">
             <a:extLst xmlns:a="http://schemas.openxmlformats.org/drawingml/2006/main">
               <a:ext uri="{FF2B5EF4-FFF2-40B4-BE49-F238E27FC236}">
-                <a16:creationId xmlns:a16="http://schemas.microsoft.com/office/drawing/2014/main" id="{5467D770-D911-4D67-BFFA-4CB67C7596F5}"/>
+                <a16:creationId xmlns:a16="http://schemas.microsoft.com/office/drawing/2014/main" id="{7340FAB1-D1A8-447C-AE23-32301129C22E}"/>
               </a:ext>
             </a:extLst>
           </p:cNvPr>
@@ -7117,19 +7117,19 @@
           <p:cNvPr id="10" name="">
             <a:extLst xmlns:a="http://schemas.openxmlformats.org/drawingml/2006/main">
               <a:ext uri="{FF2B5EF4-FFF2-40B4-BE49-F238E27FC236}">
-                <a16:creationId xmlns:a16="http://schemas.microsoft.com/office/drawing/2014/main" id="{90011F47-7A74-4A99-AA33-7E80C94CCA2A}"/>
-              </a:ext>
-            </a:extLst>
-          </p:cNvPr>
-          <p:cNvSpPr>
-            <a:spLocks xmlns:a="http://schemas.openxmlformats.org/drawingml/2006/main" noGrp="1"/>
-          </p:cNvSpPr>
-          <p:nvPr/>
-        </p:nvSpPr>
-        <p:spPr>
-          <a:xfrm xmlns:a="http://schemas.openxmlformats.org/drawingml/2006/main">
-            <a:off x="1238250" y="3486150"/>
-            <a:ext cx="914400" cy="228600"/>
+                <a16:creationId xmlns:a16="http://schemas.microsoft.com/office/drawing/2014/main" id="{72F8B990-1896-4306-9AF4-2CFA919F33BB}"/>
+              </a:ext>
+            </a:extLst>
+          </p:cNvPr>
+          <p:cNvSpPr>
+            <a:spLocks xmlns:a="http://schemas.openxmlformats.org/drawingml/2006/main" noGrp="1"/>
+          </p:cNvSpPr>
+          <p:nvPr/>
+        </p:nvSpPr>
+        <p:spPr>
+          <a:xfrm xmlns:a="http://schemas.openxmlformats.org/drawingml/2006/main">
+            <a:off x="1200150" y="3486150"/>
+            <a:ext cx="1352550" cy="228600"/>
           </a:xfrm>
           <a:prstGeom xmlns:a="http://schemas.openxmlformats.org/drawingml/2006/main" prst="rect">
             <a:avLst/>
@@ -7153,7 +7153,7 @@
           <a:lstStyle xmlns:a="http://schemas.openxmlformats.org/drawingml/2006/main"/>
           <a:p xmlns:a="http://schemas.openxmlformats.org/drawingml/2006/main">
             <a:pPr algn="l">
-              <a:defRPr sz="1350" b="1">
+              <a:defRPr sz="1200" b="1">
                 <a:solidFill>
                   <a:srgbClr val="D95D39"/>
                 </a:solidFill>
@@ -7163,7 +7163,7 @@
               </a:defRPr>
             </a:pPr>
             <a:r>
-              <a:rPr sz="1350" b="1">
+              <a:rPr sz="1200" b="1">
                 <a:solidFill>
                   <a:srgbClr val="D95D39"/>
                 </a:solidFill>
@@ -7171,7 +7171,7 @@
                 <a:ea typeface="Hiragino Sans"/>
                 <a:cs typeface="Hiragino Sans"/>
               </a:rPr>
-              <a:t>V10-a</a:t>
+              <a:t>Zalesak形状</a:t>
             </a:r>
           </a:p>
         </p:txBody>
@@ -7181,19 +7181,19 @@
           <p:cNvPr id="11" name="">
             <a:extLst xmlns:a="http://schemas.openxmlformats.org/drawingml/2006/main">
               <a:ext uri="{FF2B5EF4-FFF2-40B4-BE49-F238E27FC236}">
-                <a16:creationId xmlns:a16="http://schemas.microsoft.com/office/drawing/2014/main" id="{5F662702-842F-4501-BCC3-AB6F1EB106A7}"/>
-              </a:ext>
-            </a:extLst>
-          </p:cNvPr>
-          <p:cNvSpPr>
-            <a:spLocks xmlns:a="http://schemas.openxmlformats.org/drawingml/2006/main" noGrp="1"/>
-          </p:cNvSpPr>
-          <p:nvPr/>
-        </p:nvSpPr>
-        <p:spPr>
-          <a:xfrm xmlns:a="http://schemas.openxmlformats.org/drawingml/2006/main">
-            <a:off x="2381250" y="3457575"/>
-            <a:ext cx="2000250" cy="285750"/>
+                <a16:creationId xmlns:a16="http://schemas.microsoft.com/office/drawing/2014/main" id="{692AF9CF-BBB1-477A-AC26-25090E00A97C}"/>
+              </a:ext>
+            </a:extLst>
+          </p:cNvPr>
+          <p:cNvSpPr>
+            <a:spLocks xmlns:a="http://schemas.openxmlformats.org/drawingml/2006/main" noGrp="1"/>
+          </p:cNvSpPr>
+          <p:nvPr/>
+        </p:nvSpPr>
+        <p:spPr>
+          <a:xfrm xmlns:a="http://schemas.openxmlformats.org/drawingml/2006/main">
+            <a:off x="2857500" y="3457575"/>
+            <a:ext cx="1809750" cy="285750"/>
           </a:xfrm>
           <a:prstGeom xmlns:a="http://schemas.openxmlformats.org/drawingml/2006/main" prst="rect">
             <a:avLst/>
@@ -7245,19 +7245,19 @@
           <p:cNvPr id="12" name="">
             <a:extLst xmlns:a="http://schemas.openxmlformats.org/drawingml/2006/main">
               <a:ext uri="{FF2B5EF4-FFF2-40B4-BE49-F238E27FC236}">
-                <a16:creationId xmlns:a16="http://schemas.microsoft.com/office/drawing/2014/main" id="{7F0161DC-7A02-43F0-863C-F705F2BDAC2E}"/>
-              </a:ext>
-            </a:extLst>
-          </p:cNvPr>
-          <p:cNvSpPr>
-            <a:spLocks xmlns:a="http://schemas.openxmlformats.org/drawingml/2006/main" noGrp="1"/>
-          </p:cNvSpPr>
-          <p:nvPr/>
-        </p:nvSpPr>
-        <p:spPr>
-          <a:xfrm xmlns:a="http://schemas.openxmlformats.org/drawingml/2006/main">
-            <a:off x="4686300" y="3495675"/>
-            <a:ext cx="5810250" cy="228600"/>
+                <a16:creationId xmlns:a16="http://schemas.microsoft.com/office/drawing/2014/main" id="{592C2FB8-40A2-4675-8009-27378732B923}"/>
+              </a:ext>
+            </a:extLst>
+          </p:cNvPr>
+          <p:cNvSpPr>
+            <a:spLocks xmlns:a="http://schemas.openxmlformats.org/drawingml/2006/main" noGrp="1"/>
+          </p:cNvSpPr>
+          <p:nvPr/>
+        </p:nvSpPr>
+        <p:spPr>
+          <a:xfrm xmlns:a="http://schemas.openxmlformats.org/drawingml/2006/main">
+            <a:off x="4953000" y="3495675"/>
+            <a:ext cx="5524500" cy="228600"/>
           </a:xfrm>
           <a:prstGeom xmlns:a="http://schemas.openxmlformats.org/drawingml/2006/main" prst="rect">
             <a:avLst/>
@@ -7299,7 +7299,7 @@
                 <a:ea typeface="Hiragino Sans"/>
                 <a:cs typeface="Hiragino Sans"/>
               </a:rPr>
-              <a:t>Zalesak slot under-resolution</a:t>
+              <a:t>slot under-resolution</a:t>
             </a:r>
           </a:p>
         </p:txBody>
@@ -7309,7 +7309,7 @@
           <p:cNvPr id="13" name="">
             <a:extLst xmlns:a="http://schemas.openxmlformats.org/drawingml/2006/main">
               <a:ext uri="{FF2B5EF4-FFF2-40B4-BE49-F238E27FC236}">
-                <a16:creationId xmlns:a16="http://schemas.microsoft.com/office/drawing/2014/main" id="{A6F2CC5F-524A-4C5D-B274-9542CB789832}"/>
+                <a16:creationId xmlns:a16="http://schemas.microsoft.com/office/drawing/2014/main" id="{0A3EAB40-09D6-43B4-92E4-EBC6EEDAB240}"/>
               </a:ext>
             </a:extLst>
           </p:cNvPr>
@@ -7342,19 +7342,19 @@
           <p:cNvPr id="14" name="">
             <a:extLst xmlns:a="http://schemas.openxmlformats.org/drawingml/2006/main">
               <a:ext uri="{FF2B5EF4-FFF2-40B4-BE49-F238E27FC236}">
-                <a16:creationId xmlns:a16="http://schemas.microsoft.com/office/drawing/2014/main" id="{2568E645-008A-4172-804C-00CACCDA5053}"/>
-              </a:ext>
-            </a:extLst>
-          </p:cNvPr>
-          <p:cNvSpPr>
-            <a:spLocks xmlns:a="http://schemas.openxmlformats.org/drawingml/2006/main" noGrp="1"/>
-          </p:cNvSpPr>
-          <p:nvPr/>
-        </p:nvSpPr>
-        <p:spPr>
-          <a:xfrm xmlns:a="http://schemas.openxmlformats.org/drawingml/2006/main">
-            <a:off x="1238250" y="4591050"/>
-            <a:ext cx="914400" cy="228600"/>
+                <a16:creationId xmlns:a16="http://schemas.microsoft.com/office/drawing/2014/main" id="{14DF37F3-0A3E-44E1-9DD6-C2505BBEAEB8}"/>
+              </a:ext>
+            </a:extLst>
+          </p:cNvPr>
+          <p:cNvSpPr>
+            <a:spLocks xmlns:a="http://schemas.openxmlformats.org/drawingml/2006/main" noGrp="1"/>
+          </p:cNvSpPr>
+          <p:nvPr/>
+        </p:nvSpPr>
+        <p:spPr>
+          <a:xfrm xmlns:a="http://schemas.openxmlformats.org/drawingml/2006/main">
+            <a:off x="1200150" y="4591050"/>
+            <a:ext cx="1352550" cy="228600"/>
           </a:xfrm>
           <a:prstGeom xmlns:a="http://schemas.openxmlformats.org/drawingml/2006/main" prst="rect">
             <a:avLst/>
@@ -7378,7 +7378,7 @@
           <a:lstStyle xmlns:a="http://schemas.openxmlformats.org/drawingml/2006/main"/>
           <a:p xmlns:a="http://schemas.openxmlformats.org/drawingml/2006/main">
             <a:pPr algn="l">
-              <a:defRPr sz="1350" b="1">
+              <a:defRPr sz="1200" b="1">
                 <a:solidFill>
                   <a:srgbClr val="D95D39"/>
                 </a:solidFill>
@@ -7388,7 +7388,7 @@
               </a:defRPr>
             </a:pPr>
             <a:r>
-              <a:rPr sz="1350" b="1">
+              <a:rPr sz="1200" b="1">
                 <a:solidFill>
                   <a:srgbClr val="D95D39"/>
                 </a:solidFill>
@@ -7396,7 +7396,7 @@
                 <a:ea typeface="Hiragino Sans"/>
                 <a:cs typeface="Hiragino Sans"/>
               </a:rPr>
-              <a:t>V10-b</a:t>
+              <a:t>単一渦形状</a:t>
             </a:r>
           </a:p>
         </p:txBody>
@@ -7406,19 +7406,19 @@
           <p:cNvPr id="15" name="">
             <a:extLst xmlns:a="http://schemas.openxmlformats.org/drawingml/2006/main">
               <a:ext uri="{FF2B5EF4-FFF2-40B4-BE49-F238E27FC236}">
-                <a16:creationId xmlns:a16="http://schemas.microsoft.com/office/drawing/2014/main" id="{7979DE99-2FB0-4738-AC91-86548E3519BF}"/>
-              </a:ext>
-            </a:extLst>
-          </p:cNvPr>
-          <p:cNvSpPr>
-            <a:spLocks xmlns:a="http://schemas.openxmlformats.org/drawingml/2006/main" noGrp="1"/>
-          </p:cNvSpPr>
-          <p:nvPr/>
-        </p:nvSpPr>
-        <p:spPr>
-          <a:xfrm xmlns:a="http://schemas.openxmlformats.org/drawingml/2006/main">
-            <a:off x="2381250" y="4562475"/>
-            <a:ext cx="2000250" cy="285750"/>
+                <a16:creationId xmlns:a16="http://schemas.microsoft.com/office/drawing/2014/main" id="{4706ADF0-8217-4A70-B73F-2FADDB4205F4}"/>
+              </a:ext>
+            </a:extLst>
+          </p:cNvPr>
+          <p:cNvSpPr>
+            <a:spLocks xmlns:a="http://schemas.openxmlformats.org/drawingml/2006/main" noGrp="1"/>
+          </p:cNvSpPr>
+          <p:nvPr/>
+        </p:nvSpPr>
+        <p:spPr>
+          <a:xfrm xmlns:a="http://schemas.openxmlformats.org/drawingml/2006/main">
+            <a:off x="2857500" y="4562475"/>
+            <a:ext cx="1809750" cy="285750"/>
           </a:xfrm>
           <a:prstGeom xmlns:a="http://schemas.openxmlformats.org/drawingml/2006/main" prst="rect">
             <a:avLst/>
@@ -7470,19 +7470,19 @@
           <p:cNvPr id="16" name="">
             <a:extLst xmlns:a="http://schemas.openxmlformats.org/drawingml/2006/main">
               <a:ext uri="{FF2B5EF4-FFF2-40B4-BE49-F238E27FC236}">
-                <a16:creationId xmlns:a16="http://schemas.microsoft.com/office/drawing/2014/main" id="{1DE4A2BA-83EE-465C-9F37-347AC6576A16}"/>
-              </a:ext>
-            </a:extLst>
-          </p:cNvPr>
-          <p:cNvSpPr>
-            <a:spLocks xmlns:a="http://schemas.openxmlformats.org/drawingml/2006/main" noGrp="1"/>
-          </p:cNvSpPr>
-          <p:nvPr/>
-        </p:nvSpPr>
-        <p:spPr>
-          <a:xfrm xmlns:a="http://schemas.openxmlformats.org/drawingml/2006/main">
-            <a:off x="4686300" y="4600575"/>
-            <a:ext cx="5810250" cy="228600"/>
+                <a16:creationId xmlns:a16="http://schemas.microsoft.com/office/drawing/2014/main" id="{2D87A749-AFE9-4B83-BE94-CAE7AFF687DB}"/>
+              </a:ext>
+            </a:extLst>
+          </p:cNvPr>
+          <p:cNvSpPr>
+            <a:spLocks xmlns:a="http://schemas.openxmlformats.org/drawingml/2006/main" noGrp="1"/>
+          </p:cNvSpPr>
+          <p:nvPr/>
+        </p:nvSpPr>
+        <p:spPr>
+          <a:xfrm xmlns:a="http://schemas.openxmlformats.org/drawingml/2006/main">
+            <a:off x="4953000" y="4600575"/>
+            <a:ext cx="5524500" cy="228600"/>
           </a:xfrm>
           <a:prstGeom xmlns:a="http://schemas.openxmlformats.org/drawingml/2006/main" prst="rect">
             <a:avLst/>
@@ -7534,7 +7534,7 @@
           <p:cNvPr id="17" name="">
             <a:extLst xmlns:a="http://schemas.openxmlformats.org/drawingml/2006/main">
               <a:ext uri="{FF2B5EF4-FFF2-40B4-BE49-F238E27FC236}">
-                <a16:creationId xmlns:a16="http://schemas.microsoft.com/office/drawing/2014/main" id="{9A7E733F-C237-4EFF-84D4-17B17D1913BC}"/>
+                <a16:creationId xmlns:a16="http://schemas.microsoft.com/office/drawing/2014/main" id="{6AACE739-089F-4C20-AA40-0A0EFAFDA676}"/>
               </a:ext>
             </a:extLst>
           </p:cNvPr>
@@ -7569,7 +7569,7 @@
           <p:cNvPr id="18" name="">
             <a:extLst xmlns:a="http://schemas.openxmlformats.org/drawingml/2006/main">
               <a:ext uri="{FF2B5EF4-FFF2-40B4-BE49-F238E27FC236}">
-                <a16:creationId xmlns:a16="http://schemas.microsoft.com/office/drawing/2014/main" id="{13AD4266-BFE5-4787-B88E-213936537442}"/>
+                <a16:creationId xmlns:a16="http://schemas.microsoft.com/office/drawing/2014/main" id="{5D4C3E37-7236-46C6-A7BF-59E47959FB72}"/>
               </a:ext>
             </a:extLst>
           </p:cNvPr>
@@ -7623,7 +7623,7 @@
                 <a:ea typeface="Hiragino Sans"/>
                 <a:cs typeface="Hiragino Sans"/>
               </a:rPr>
-              <a:t>source: paper/sections/13f_error_budget.tex; 15_conclusion.tex</a:t>
+              <a:t>source: Error budget; conclusion</a:t>
             </a:r>
           </a:p>
         </p:txBody>
@@ -7633,7 +7633,7 @@
           <p:cNvPr id="19" name="">
             <a:extLst xmlns:a="http://schemas.openxmlformats.org/drawingml/2006/main">
               <a:ext uri="{FF2B5EF4-FFF2-40B4-BE49-F238E27FC236}">
-                <a16:creationId xmlns:a16="http://schemas.microsoft.com/office/drawing/2014/main" id="{3E1803DB-300B-4F99-AF07-DB0E56D34C0C}"/>
+                <a16:creationId xmlns:a16="http://schemas.microsoft.com/office/drawing/2014/main" id="{EEAA8641-CE75-4CBA-AFBC-36BED44681CF}"/>
               </a:ext>
             </a:extLst>
           </p:cNvPr>
@@ -7695,7 +7695,7 @@
     </p:spTree>
     <p:extLst>
       <p:ext uri="{BB962C8B-B14F-4D97-AF65-F5344CB8AC3E}">
-        <p14:creationId xmlns:p14="http://schemas.microsoft.com/office/powerpoint/2010/main" val="729564884"/>
+        <p14:creationId xmlns:p14="http://schemas.microsoft.com/office/powerpoint/2010/main" val="960109599"/>
       </p:ext>
     </p:extLst>
   </p:cSld>
@@ -7719,7 +7719,7 @@
           <p:cNvPr id="1" name="">
             <a:extLst xmlns:a="http://schemas.openxmlformats.org/drawingml/2006/main">
               <a:ext uri="{FF2B5EF4-FFF2-40B4-BE49-F238E27FC236}">
-                <a16:creationId xmlns:a16="http://schemas.microsoft.com/office/drawing/2014/main" id="{CF1871D7-E137-42F8-B12A-0C60ADDF7DAE}"/>
+                <a16:creationId xmlns:a16="http://schemas.microsoft.com/office/drawing/2014/main" id="{5C2DC8E3-3B95-441C-9454-55B719FCB45A}"/>
               </a:ext>
             </a:extLst>
           </p:cNvPr>
@@ -7754,7 +7754,7 @@
           <p:cNvPr id="2" name="">
             <a:extLst xmlns:a="http://schemas.openxmlformats.org/drawingml/2006/main">
               <a:ext uri="{FF2B5EF4-FFF2-40B4-BE49-F238E27FC236}">
-                <a16:creationId xmlns:a16="http://schemas.microsoft.com/office/drawing/2014/main" id="{20CC06EC-3F34-4708-AFAC-EB7028DFBAD1}"/>
+                <a16:creationId xmlns:a16="http://schemas.microsoft.com/office/drawing/2014/main" id="{9E069B7A-DB6A-4C57-9EB4-9ACAF2C6C52F}"/>
               </a:ext>
             </a:extLst>
           </p:cNvPr>
@@ -7789,7 +7789,7 @@
           <p:cNvPr id="3" name="">
             <a:extLst xmlns:a="http://schemas.openxmlformats.org/drawingml/2006/main">
               <a:ext uri="{FF2B5EF4-FFF2-40B4-BE49-F238E27FC236}">
-                <a16:creationId xmlns:a16="http://schemas.microsoft.com/office/drawing/2014/main" id="{CC0A95C8-9249-46D2-B1BD-52016CA432EB}"/>
+                <a16:creationId xmlns:a16="http://schemas.microsoft.com/office/drawing/2014/main" id="{16954A17-BB9A-41FC-940F-9F471307D30B}"/>
               </a:ext>
             </a:extLst>
           </p:cNvPr>
@@ -7853,7 +7853,7 @@
           <p:cNvPr id="4" name="">
             <a:extLst xmlns:a="http://schemas.openxmlformats.org/drawingml/2006/main">
               <a:ext uri="{FF2B5EF4-FFF2-40B4-BE49-F238E27FC236}">
-                <a16:creationId xmlns:a16="http://schemas.microsoft.com/office/drawing/2014/main" id="{47F1B5CF-303E-4F19-AC2E-9FD7AD63E0BF}"/>
+                <a16:creationId xmlns:a16="http://schemas.microsoft.com/office/drawing/2014/main" id="{91A8D5DC-E811-4D16-A9C9-971C10068F0F}"/>
               </a:ext>
             </a:extLst>
           </p:cNvPr>
@@ -7917,7 +7917,7 @@
           <p:cNvPr id="5" name="">
             <a:extLst xmlns:a="http://schemas.openxmlformats.org/drawingml/2006/main">
               <a:ext uri="{FF2B5EF4-FFF2-40B4-BE49-F238E27FC236}">
-                <a16:creationId xmlns:a16="http://schemas.microsoft.com/office/drawing/2014/main" id="{7B153813-BDCE-430B-99C9-4089D0BED65F}"/>
+                <a16:creationId xmlns:a16="http://schemas.microsoft.com/office/drawing/2014/main" id="{FD9868C1-E8BE-4091-8F8C-644A91C2616F}"/>
               </a:ext>
             </a:extLst>
           </p:cNvPr>
@@ -7950,7 +7950,7 @@
           <p:cNvPr id="6" name="">
             <a:extLst xmlns:a="http://schemas.openxmlformats.org/drawingml/2006/main">
               <a:ext uri="{FF2B5EF4-FFF2-40B4-BE49-F238E27FC236}">
-                <a16:creationId xmlns:a16="http://schemas.microsoft.com/office/drawing/2014/main" id="{05D05D6D-B6D6-4AB1-AE43-3ADEA40FC44D}"/>
+                <a16:creationId xmlns:a16="http://schemas.microsoft.com/office/drawing/2014/main" id="{F8D0838A-2E29-4D6B-BE36-441096A801FD}"/>
               </a:ext>
             </a:extLst>
           </p:cNvPr>
@@ -8014,7 +8014,7 @@
           <p:cNvPr id="7" name="">
             <a:extLst xmlns:a="http://schemas.openxmlformats.org/drawingml/2006/main">
               <a:ext uri="{FF2B5EF4-FFF2-40B4-BE49-F238E27FC236}">
-                <a16:creationId xmlns:a16="http://schemas.microsoft.com/office/drawing/2014/main" id="{3155C783-EE36-4577-B41C-174CBF9C1E12}"/>
+                <a16:creationId xmlns:a16="http://schemas.microsoft.com/office/drawing/2014/main" id="{57B2ED84-BC15-4B08-914E-7EF5F648D92F}"/>
               </a:ext>
             </a:extLst>
           </p:cNvPr>
@@ -8078,7 +8078,7 @@
           <p:cNvPr id="8" name="">
             <a:extLst xmlns:a="http://schemas.openxmlformats.org/drawingml/2006/main">
               <a:ext uri="{FF2B5EF4-FFF2-40B4-BE49-F238E27FC236}">
-                <a16:creationId xmlns:a16="http://schemas.microsoft.com/office/drawing/2014/main" id="{46F1ADAD-6BF7-404A-A39D-2BC7CD994FBF}"/>
+                <a16:creationId xmlns:a16="http://schemas.microsoft.com/office/drawing/2014/main" id="{9C99C9B5-A3FE-48A7-A580-8B849103EDA3}"/>
               </a:ext>
             </a:extLst>
           </p:cNvPr>
@@ -8113,7 +8113,7 @@
           <p:cNvPr id="9" name="">
             <a:extLst xmlns:a="http://schemas.openxmlformats.org/drawingml/2006/main">
               <a:ext uri="{FF2B5EF4-FFF2-40B4-BE49-F238E27FC236}">
-                <a16:creationId xmlns:a16="http://schemas.microsoft.com/office/drawing/2014/main" id="{AE617A37-4EA7-47D7-8C52-CF5F148466C6}"/>
+                <a16:creationId xmlns:a16="http://schemas.microsoft.com/office/drawing/2014/main" id="{E46D6B5F-5B8A-4F38-A25A-CEFBB0F31A8F}"/>
               </a:ext>
             </a:extLst>
           </p:cNvPr>
@@ -8177,7 +8177,7 @@
           <p:cNvPr id="10" name="">
             <a:extLst xmlns:a="http://schemas.openxmlformats.org/drawingml/2006/main">
               <a:ext uri="{FF2B5EF4-FFF2-40B4-BE49-F238E27FC236}">
-                <a16:creationId xmlns:a16="http://schemas.microsoft.com/office/drawing/2014/main" id="{BFAB29C6-0CA7-4CB5-8A84-DD09D6FB5D40}"/>
+                <a16:creationId xmlns:a16="http://schemas.microsoft.com/office/drawing/2014/main" id="{81F6AD90-4D8F-4927-85B2-CBE354F813AE}"/>
               </a:ext>
             </a:extLst>
           </p:cNvPr>
@@ -8210,7 +8210,7 @@
           <p:cNvPr id="11" name="">
             <a:extLst xmlns:a="http://schemas.openxmlformats.org/drawingml/2006/main">
               <a:ext uri="{FF2B5EF4-FFF2-40B4-BE49-F238E27FC236}">
-                <a16:creationId xmlns:a16="http://schemas.microsoft.com/office/drawing/2014/main" id="{8FDCBBDA-5AE1-4AA1-BE77-5AECC7D64A9C}"/>
+                <a16:creationId xmlns:a16="http://schemas.microsoft.com/office/drawing/2014/main" id="{845A83CC-3F14-4C91-B86F-A45ECA639983}"/>
               </a:ext>
             </a:extLst>
           </p:cNvPr>
@@ -8274,7 +8274,7 @@
           <p:cNvPr id="12" name="">
             <a:extLst xmlns:a="http://schemas.openxmlformats.org/drawingml/2006/main">
               <a:ext uri="{FF2B5EF4-FFF2-40B4-BE49-F238E27FC236}">
-                <a16:creationId xmlns:a16="http://schemas.microsoft.com/office/drawing/2014/main" id="{7600A41F-E495-4DA6-BE32-9DACFE7E2339}"/>
+                <a16:creationId xmlns:a16="http://schemas.microsoft.com/office/drawing/2014/main" id="{7B6E82BC-1D72-41A2-BB4A-4AF35212D59A}"/>
               </a:ext>
             </a:extLst>
           </p:cNvPr>
@@ -8338,7 +8338,7 @@
           <p:cNvPr id="13" name="">
             <a:extLst xmlns:a="http://schemas.openxmlformats.org/drawingml/2006/main">
               <a:ext uri="{FF2B5EF4-FFF2-40B4-BE49-F238E27FC236}">
-                <a16:creationId xmlns:a16="http://schemas.microsoft.com/office/drawing/2014/main" id="{DC112A93-8B12-47C1-9AF3-22DF5293ACC4}"/>
+                <a16:creationId xmlns:a16="http://schemas.microsoft.com/office/drawing/2014/main" id="{17E5E8FE-3AFC-4E21-BD55-439D48B11746}"/>
               </a:ext>
             </a:extLst>
           </p:cNvPr>
@@ -8373,7 +8373,7 @@
           <p:cNvPr id="14" name="">
             <a:extLst xmlns:a="http://schemas.openxmlformats.org/drawingml/2006/main">
               <a:ext uri="{FF2B5EF4-FFF2-40B4-BE49-F238E27FC236}">
-                <a16:creationId xmlns:a16="http://schemas.microsoft.com/office/drawing/2014/main" id="{AF77E749-3C08-4A93-B0E0-6FE7AE8D18D5}"/>
+                <a16:creationId xmlns:a16="http://schemas.microsoft.com/office/drawing/2014/main" id="{2311AF89-47D4-4FA6-8F4C-7BBE784B2175}"/>
               </a:ext>
             </a:extLst>
           </p:cNvPr>
@@ -8437,7 +8437,7 @@
           <p:cNvPr id="15" name="">
             <a:extLst xmlns:a="http://schemas.openxmlformats.org/drawingml/2006/main">
               <a:ext uri="{FF2B5EF4-FFF2-40B4-BE49-F238E27FC236}">
-                <a16:creationId xmlns:a16="http://schemas.microsoft.com/office/drawing/2014/main" id="{982C1DF4-033D-4BF2-9D48-8EB9C1B00AC4}"/>
+                <a16:creationId xmlns:a16="http://schemas.microsoft.com/office/drawing/2014/main" id="{F9EE08A6-3EC2-4042-BBA1-680FC528B646}"/>
               </a:ext>
             </a:extLst>
           </p:cNvPr>
@@ -8470,7 +8470,7 @@
           <p:cNvPr id="16" name="">
             <a:extLst xmlns:a="http://schemas.openxmlformats.org/drawingml/2006/main">
               <a:ext uri="{FF2B5EF4-FFF2-40B4-BE49-F238E27FC236}">
-                <a16:creationId xmlns:a16="http://schemas.microsoft.com/office/drawing/2014/main" id="{EC2BC06D-98DE-430D-9E29-74A6AAF53214}"/>
+                <a16:creationId xmlns:a16="http://schemas.microsoft.com/office/drawing/2014/main" id="{08F51A48-778C-45D2-8CD2-8F8E7AB002CA}"/>
               </a:ext>
             </a:extLst>
           </p:cNvPr>
@@ -8534,7 +8534,7 @@
           <p:cNvPr id="17" name="">
             <a:extLst xmlns:a="http://schemas.openxmlformats.org/drawingml/2006/main">
               <a:ext uri="{FF2B5EF4-FFF2-40B4-BE49-F238E27FC236}">
-                <a16:creationId xmlns:a16="http://schemas.microsoft.com/office/drawing/2014/main" id="{E37DC915-7E1F-4136-8AEC-FA1951BCC4CF}"/>
+                <a16:creationId xmlns:a16="http://schemas.microsoft.com/office/drawing/2014/main" id="{33904FDA-A294-4166-B59F-857BBF7186C1}"/>
               </a:ext>
             </a:extLst>
           </p:cNvPr>
@@ -8598,7 +8598,7 @@
           <p:cNvPr id="18" name="">
             <a:extLst xmlns:a="http://schemas.openxmlformats.org/drawingml/2006/main">
               <a:ext uri="{FF2B5EF4-FFF2-40B4-BE49-F238E27FC236}">
-                <a16:creationId xmlns:a16="http://schemas.microsoft.com/office/drawing/2014/main" id="{2D78AA87-F677-42BB-9968-E00A82FD4707}"/>
+                <a16:creationId xmlns:a16="http://schemas.microsoft.com/office/drawing/2014/main" id="{74748578-B205-4CB5-A246-86D4321D24FE}"/>
               </a:ext>
             </a:extLst>
           </p:cNvPr>
@@ -8633,7 +8633,7 @@
           <p:cNvPr id="19" name="">
             <a:extLst xmlns:a="http://schemas.openxmlformats.org/drawingml/2006/main">
               <a:ext uri="{FF2B5EF4-FFF2-40B4-BE49-F238E27FC236}">
-                <a16:creationId xmlns:a16="http://schemas.microsoft.com/office/drawing/2014/main" id="{EAF89A7B-A710-48C2-B767-C068A2D20646}"/>
+                <a16:creationId xmlns:a16="http://schemas.microsoft.com/office/drawing/2014/main" id="{ED96B2C0-595D-4DD9-9C30-6BA1BA188507}"/>
               </a:ext>
             </a:extLst>
           </p:cNvPr>
@@ -8697,7 +8697,7 @@
           <p:cNvPr id="20" name="">
             <a:extLst xmlns:a="http://schemas.openxmlformats.org/drawingml/2006/main">
               <a:ext uri="{FF2B5EF4-FFF2-40B4-BE49-F238E27FC236}">
-                <a16:creationId xmlns:a16="http://schemas.microsoft.com/office/drawing/2014/main" id="{5DF14C8C-A914-4756-8C09-757C2145AC86}"/>
+                <a16:creationId xmlns:a16="http://schemas.microsoft.com/office/drawing/2014/main" id="{B71414BF-D18F-4830-9505-4092867445DF}"/>
               </a:ext>
             </a:extLst>
           </p:cNvPr>
@@ -8732,7 +8732,7 @@
           <p:cNvPr id="21" name="">
             <a:extLst xmlns:a="http://schemas.openxmlformats.org/drawingml/2006/main">
               <a:ext uri="{FF2B5EF4-FFF2-40B4-BE49-F238E27FC236}">
-                <a16:creationId xmlns:a16="http://schemas.microsoft.com/office/drawing/2014/main" id="{44352CCE-DFB0-4BBD-9785-8EC81C879724}"/>
+                <a16:creationId xmlns:a16="http://schemas.microsoft.com/office/drawing/2014/main" id="{274FDF5B-3083-4C40-AE07-1DF293F31BBE}"/>
               </a:ext>
             </a:extLst>
           </p:cNvPr>
@@ -8786,7 +8786,7 @@
                 <a:ea typeface="Hiragino Sans"/>
                 <a:cs typeface="Hiragino Sans"/>
               </a:rPr>
-              <a:t>source: paper/sections/14_benchmarks.tex; 15_conclusion.tex</a:t>
+              <a:t>source: Benchmark gates; conclusion</a:t>
             </a:r>
           </a:p>
         </p:txBody>
@@ -8796,7 +8796,7 @@
           <p:cNvPr id="22" name="">
             <a:extLst xmlns:a="http://schemas.openxmlformats.org/drawingml/2006/main">
               <a:ext uri="{FF2B5EF4-FFF2-40B4-BE49-F238E27FC236}">
-                <a16:creationId xmlns:a16="http://schemas.microsoft.com/office/drawing/2014/main" id="{9AFC49B9-4073-4CF1-BDF4-7FD183A58834}"/>
+                <a16:creationId xmlns:a16="http://schemas.microsoft.com/office/drawing/2014/main" id="{8DA5BA5C-D622-4D45-8BF1-46DB81EB4C81}"/>
               </a:ext>
             </a:extLst>
           </p:cNvPr>
@@ -8858,7 +8858,7 @@
     </p:spTree>
     <p:extLst>
       <p:ext uri="{BB962C8B-B14F-4D97-AF65-F5344CB8AC3E}">
-        <p14:creationId xmlns:p14="http://schemas.microsoft.com/office/powerpoint/2010/main" val="284782700"/>
+        <p14:creationId xmlns:p14="http://schemas.microsoft.com/office/powerpoint/2010/main" val="1428740930"/>
       </p:ext>
     </p:extLst>
   </p:cSld>
@@ -8882,7 +8882,7 @@
           <p:cNvPr id="1" name="">
             <a:extLst xmlns:a="http://schemas.openxmlformats.org/drawingml/2006/main">
               <a:ext uri="{FF2B5EF4-FFF2-40B4-BE49-F238E27FC236}">
-                <a16:creationId xmlns:a16="http://schemas.microsoft.com/office/drawing/2014/main" id="{958B0436-1CA6-40F7-B0A2-CA7641F174EF}"/>
+                <a16:creationId xmlns:a16="http://schemas.microsoft.com/office/drawing/2014/main" id="{9CE70333-9BE9-4E91-8036-DF5B23CB8CC5}"/>
               </a:ext>
             </a:extLst>
           </p:cNvPr>
@@ -8917,7 +8917,7 @@
           <p:cNvPr id="2" name="">
             <a:extLst xmlns:a="http://schemas.openxmlformats.org/drawingml/2006/main">
               <a:ext uri="{FF2B5EF4-FFF2-40B4-BE49-F238E27FC236}">
-                <a16:creationId xmlns:a16="http://schemas.microsoft.com/office/drawing/2014/main" id="{688A80D9-7C4E-4277-8B32-8D84554BC6B0}"/>
+                <a16:creationId xmlns:a16="http://schemas.microsoft.com/office/drawing/2014/main" id="{B56E384A-EBFF-41E4-B089-E5E82F1EBCDF}"/>
               </a:ext>
             </a:extLst>
           </p:cNvPr>
@@ -8952,7 +8952,7 @@
           <p:cNvPr id="3" name="">
             <a:extLst xmlns:a="http://schemas.openxmlformats.org/drawingml/2006/main">
               <a:ext uri="{FF2B5EF4-FFF2-40B4-BE49-F238E27FC236}">
-                <a16:creationId xmlns:a16="http://schemas.microsoft.com/office/drawing/2014/main" id="{4B7A200F-94BF-492E-BE14-7A1D11411297}"/>
+                <a16:creationId xmlns:a16="http://schemas.microsoft.com/office/drawing/2014/main" id="{72507D50-29A1-479D-BDED-0F9FE10B7567}"/>
               </a:ext>
             </a:extLst>
           </p:cNvPr>
@@ -9016,7 +9016,7 @@
           <p:cNvPr id="4" name="">
             <a:extLst xmlns:a="http://schemas.openxmlformats.org/drawingml/2006/main">
               <a:ext uri="{FF2B5EF4-FFF2-40B4-BE49-F238E27FC236}">
-                <a16:creationId xmlns:a16="http://schemas.microsoft.com/office/drawing/2014/main" id="{342E53C7-0FE2-442B-9076-06A8AD03BDF5}"/>
+                <a16:creationId xmlns:a16="http://schemas.microsoft.com/office/drawing/2014/main" id="{93F99C37-AC56-4A57-8AA9-A9CB2D0C9D37}"/>
               </a:ext>
             </a:extLst>
           </p:cNvPr>
@@ -9070,7 +9070,7 @@
                 <a:ea typeface="Hiragino Sans"/>
                 <a:cs typeface="Hiragino Sans"/>
               </a:rPr>
-              <a:t>本研究は、CCD高次群・分相PPE+HFE+DC・Balanced-Force face subsystemを統合し、二相流で何が合格し何が未解決かを検証軸として固定した。</a:t>
+              <a:t>本研究は、CCD/FCCD/UCCD6を核に分相PPE+HFE+DC・Balanced-Force face subsystemを統合し、合格範囲と未解決範囲を検証軸として固定した。</a:t>
             </a:r>
           </a:p>
         </p:txBody>
@@ -9080,7 +9080,7 @@
           <p:cNvPr id="5" name="">
             <a:extLst xmlns:a="http://schemas.openxmlformats.org/drawingml/2006/main">
               <a:ext uri="{FF2B5EF4-FFF2-40B4-BE49-F238E27FC236}">
-                <a16:creationId xmlns:a16="http://schemas.microsoft.com/office/drawing/2014/main" id="{8E92F1DE-681D-4C28-BB11-CFF773EBE36A}"/>
+                <a16:creationId xmlns:a16="http://schemas.microsoft.com/office/drawing/2014/main" id="{9844C421-0B93-4879-A831-AB2CA6CE6DBA}"/>
               </a:ext>
             </a:extLst>
           </p:cNvPr>
@@ -9113,7 +9113,7 @@
           <p:cNvPr id="6" name="">
             <a:extLst xmlns:a="http://schemas.openxmlformats.org/drawingml/2006/main">
               <a:ext uri="{FF2B5EF4-FFF2-40B4-BE49-F238E27FC236}">
-                <a16:creationId xmlns:a16="http://schemas.microsoft.com/office/drawing/2014/main" id="{DD41D63C-B383-4E8A-8A20-6D52CA0D6D5C}"/>
+                <a16:creationId xmlns:a16="http://schemas.microsoft.com/office/drawing/2014/main" id="{F09A054C-5C05-4283-B974-10A3B0BE93A8}"/>
               </a:ext>
             </a:extLst>
           </p:cNvPr>
@@ -9177,7 +9177,7 @@
           <p:cNvPr id="7" name="">
             <a:extLst xmlns:a="http://schemas.openxmlformats.org/drawingml/2006/main">
               <a:ext uri="{FF2B5EF4-FFF2-40B4-BE49-F238E27FC236}">
-                <a16:creationId xmlns:a16="http://schemas.microsoft.com/office/drawing/2014/main" id="{241DD664-1180-4167-A0E7-71902CCA674E}"/>
+                <a16:creationId xmlns:a16="http://schemas.microsoft.com/office/drawing/2014/main" id="{F1732DDA-CE1E-4723-ABD2-B8E93D7CCCED}"/>
               </a:ext>
             </a:extLst>
           </p:cNvPr>
@@ -9241,7 +9241,7 @@
           <p:cNvPr id="8" name="">
             <a:extLst xmlns:a="http://schemas.openxmlformats.org/drawingml/2006/main">
               <a:ext uri="{FF2B5EF4-FFF2-40B4-BE49-F238E27FC236}">
-                <a16:creationId xmlns:a16="http://schemas.microsoft.com/office/drawing/2014/main" id="{CB7CBC60-1405-4690-A6AB-4D2B566BD18A}"/>
+                <a16:creationId xmlns:a16="http://schemas.microsoft.com/office/drawing/2014/main" id="{FFE18A20-50E1-41A8-B6AB-E5A49D46B303}"/>
               </a:ext>
             </a:extLst>
           </p:cNvPr>
@@ -9274,7 +9274,7 @@
           <p:cNvPr id="9" name="">
             <a:extLst xmlns:a="http://schemas.openxmlformats.org/drawingml/2006/main">
               <a:ext uri="{FF2B5EF4-FFF2-40B4-BE49-F238E27FC236}">
-                <a16:creationId xmlns:a16="http://schemas.microsoft.com/office/drawing/2014/main" id="{69C621CA-E015-4D5E-8251-85B0609DB196}"/>
+                <a16:creationId xmlns:a16="http://schemas.microsoft.com/office/drawing/2014/main" id="{DABD5AE2-38BF-4F98-86FE-17BB2659E135}"/>
               </a:ext>
             </a:extLst>
           </p:cNvPr>
@@ -9338,7 +9338,7 @@
           <p:cNvPr id="10" name="">
             <a:extLst xmlns:a="http://schemas.openxmlformats.org/drawingml/2006/main">
               <a:ext uri="{FF2B5EF4-FFF2-40B4-BE49-F238E27FC236}">
-                <a16:creationId xmlns:a16="http://schemas.microsoft.com/office/drawing/2014/main" id="{A5284D7B-E388-4CC7-AC13-E6D38D3BC001}"/>
+                <a16:creationId xmlns:a16="http://schemas.microsoft.com/office/drawing/2014/main" id="{6EA150DB-2238-4BFE-B511-566196F1E872}"/>
               </a:ext>
             </a:extLst>
           </p:cNvPr>
@@ -9402,7 +9402,7 @@
           <p:cNvPr id="11" name="">
             <a:extLst xmlns:a="http://schemas.openxmlformats.org/drawingml/2006/main">
               <a:ext uri="{FF2B5EF4-FFF2-40B4-BE49-F238E27FC236}">
-                <a16:creationId xmlns:a16="http://schemas.microsoft.com/office/drawing/2014/main" id="{6F0859EA-1B8F-49A0-8540-4D29E119CE93}"/>
+                <a16:creationId xmlns:a16="http://schemas.microsoft.com/office/drawing/2014/main" id="{16732DCE-5E67-41E9-8944-1253EF839EEE}"/>
               </a:ext>
             </a:extLst>
           </p:cNvPr>
@@ -9435,7 +9435,7 @@
           <p:cNvPr id="12" name="">
             <a:extLst xmlns:a="http://schemas.openxmlformats.org/drawingml/2006/main">
               <a:ext uri="{FF2B5EF4-FFF2-40B4-BE49-F238E27FC236}">
-                <a16:creationId xmlns:a16="http://schemas.microsoft.com/office/drawing/2014/main" id="{E4A5324A-B97B-4ECE-B5EA-38ADBDBCBD14}"/>
+                <a16:creationId xmlns:a16="http://schemas.microsoft.com/office/drawing/2014/main" id="{6D6B06F3-FB9F-450B-ABAB-EDC44C7EF33C}"/>
               </a:ext>
             </a:extLst>
           </p:cNvPr>
@@ -9499,7 +9499,7 @@
           <p:cNvPr id="13" name="">
             <a:extLst xmlns:a="http://schemas.openxmlformats.org/drawingml/2006/main">
               <a:ext uri="{FF2B5EF4-FFF2-40B4-BE49-F238E27FC236}">
-                <a16:creationId xmlns:a16="http://schemas.microsoft.com/office/drawing/2014/main" id="{775DEAF8-BDBA-4099-B0C8-F89713B86F14}"/>
+                <a16:creationId xmlns:a16="http://schemas.microsoft.com/office/drawing/2014/main" id="{AFDC8364-AA2C-41D7-A21D-746EF5CBFDAB}"/>
               </a:ext>
             </a:extLst>
           </p:cNvPr>
@@ -9553,7 +9553,7 @@
                 <a:ea typeface="Hiragino Sans"/>
                 <a:cs typeface="Hiragino Sans"/>
               </a:rPr>
-              <a:t>V7 / V10 の Type-D 限界を次の研究ゲートとして明示</a:t>
+              <a:t>二相時間精度と強変形CLSの設計限界を次の研究ゲートとして明示</a:t>
             </a:r>
           </a:p>
         </p:txBody>
@@ -9563,7 +9563,7 @@
           <p:cNvPr id="14" name="">
             <a:extLst xmlns:a="http://schemas.openxmlformats.org/drawingml/2006/main">
               <a:ext uri="{FF2B5EF4-FFF2-40B4-BE49-F238E27FC236}">
-                <a16:creationId xmlns:a16="http://schemas.microsoft.com/office/drawing/2014/main" id="{A4DEB163-4955-487C-B358-AC2D88B18E46}"/>
+                <a16:creationId xmlns:a16="http://schemas.microsoft.com/office/drawing/2014/main" id="{57FDEC9E-49D0-443E-A984-E4FC0424BF38}"/>
               </a:ext>
             </a:extLst>
           </p:cNvPr>
@@ -9598,7 +9598,7 @@
           <p:cNvPr id="15" name="">
             <a:extLst xmlns:a="http://schemas.openxmlformats.org/drawingml/2006/main">
               <a:ext uri="{FF2B5EF4-FFF2-40B4-BE49-F238E27FC236}">
-                <a16:creationId xmlns:a16="http://schemas.microsoft.com/office/drawing/2014/main" id="{39C848DC-27E6-4BDF-96BD-7A44497C8410}"/>
+                <a16:creationId xmlns:a16="http://schemas.microsoft.com/office/drawing/2014/main" id="{473C99A4-DDE5-419F-8703-F26862529DB4}"/>
               </a:ext>
             </a:extLst>
           </p:cNvPr>
@@ -9652,7 +9652,7 @@
                 <a:ea typeface="Hiragino Sans"/>
                 <a:cs typeface="Hiragino Sans"/>
               </a:rPr>
-              <a:t>source: paper/sections/15_conclusion.tex</a:t>
+              <a:t>source: Conclusion</a:t>
             </a:r>
           </a:p>
         </p:txBody>
@@ -9662,7 +9662,7 @@
           <p:cNvPr id="16" name="">
             <a:extLst xmlns:a="http://schemas.openxmlformats.org/drawingml/2006/main">
               <a:ext uri="{FF2B5EF4-FFF2-40B4-BE49-F238E27FC236}">
-                <a16:creationId xmlns:a16="http://schemas.microsoft.com/office/drawing/2014/main" id="{7ED562F2-3BF3-49F9-BB39-739175A495E2}"/>
+                <a16:creationId xmlns:a16="http://schemas.microsoft.com/office/drawing/2014/main" id="{F107AF08-7AE8-47BA-9AE7-2F6F32963901}"/>
               </a:ext>
             </a:extLst>
           </p:cNvPr>
@@ -9724,7 +9724,7 @@
     </p:spTree>
     <p:extLst>
       <p:ext uri="{BB962C8B-B14F-4D97-AF65-F5344CB8AC3E}">
-        <p14:creationId xmlns:p14="http://schemas.microsoft.com/office/powerpoint/2010/main" val="765337899"/>
+        <p14:creationId xmlns:p14="http://schemas.microsoft.com/office/powerpoint/2010/main" val="1886306616"/>
       </p:ext>
     </p:extLst>
   </p:cSld>
@@ -9748,7 +9748,7 @@
           <p:cNvPr id="1" name="">
             <a:extLst xmlns:a="http://schemas.openxmlformats.org/drawingml/2006/main">
               <a:ext uri="{FF2B5EF4-FFF2-40B4-BE49-F238E27FC236}">
-                <a16:creationId xmlns:a16="http://schemas.microsoft.com/office/drawing/2014/main" id="{279DF736-43AA-47AC-8DBF-846980573E4E}"/>
+                <a16:creationId xmlns:a16="http://schemas.microsoft.com/office/drawing/2014/main" id="{AA0AFB7E-64EA-4E37-81EE-5305A53FE1D4}"/>
               </a:ext>
             </a:extLst>
           </p:cNvPr>
@@ -9783,7 +9783,7 @@
           <p:cNvPr id="2" name="">
             <a:extLst xmlns:a="http://schemas.openxmlformats.org/drawingml/2006/main">
               <a:ext uri="{FF2B5EF4-FFF2-40B4-BE49-F238E27FC236}">
-                <a16:creationId xmlns:a16="http://schemas.microsoft.com/office/drawing/2014/main" id="{88F6D66F-E212-4EAE-B0D6-B5CC3CC8E3AE}"/>
+                <a16:creationId xmlns:a16="http://schemas.microsoft.com/office/drawing/2014/main" id="{B5CD94AA-BD26-4FA3-AFAC-08A3662637F7}"/>
               </a:ext>
             </a:extLst>
           </p:cNvPr>
@@ -9818,7 +9818,7 @@
           <p:cNvPr id="3" name="">
             <a:extLst xmlns:a="http://schemas.openxmlformats.org/drawingml/2006/main">
               <a:ext uri="{FF2B5EF4-FFF2-40B4-BE49-F238E27FC236}">
-                <a16:creationId xmlns:a16="http://schemas.microsoft.com/office/drawing/2014/main" id="{107C054C-9E28-411B-8F51-DD145C9B47A3}"/>
+                <a16:creationId xmlns:a16="http://schemas.microsoft.com/office/drawing/2014/main" id="{36C256D1-96D2-4692-B962-60D40BD3AEFF}"/>
               </a:ext>
             </a:extLst>
           </p:cNvPr>
@@ -9882,7 +9882,7 @@
           <p:cNvPr id="4" name="">
             <a:extLst xmlns:a="http://schemas.openxmlformats.org/drawingml/2006/main">
               <a:ext uri="{FF2B5EF4-FFF2-40B4-BE49-F238E27FC236}">
-                <a16:creationId xmlns:a16="http://schemas.microsoft.com/office/drawing/2014/main" id="{5F793A03-0490-4F35-822D-F49B26B8D48A}"/>
+                <a16:creationId xmlns:a16="http://schemas.microsoft.com/office/drawing/2014/main" id="{E4B82317-07B0-4540-B8D8-D79C7C539C2D}"/>
               </a:ext>
             </a:extLst>
           </p:cNvPr>
@@ -9946,7 +9946,7 @@
           <p:cNvPr id="5" name="">
             <a:extLst xmlns:a="http://schemas.openxmlformats.org/drawingml/2006/main">
               <a:ext uri="{FF2B5EF4-FFF2-40B4-BE49-F238E27FC236}">
-                <a16:creationId xmlns:a16="http://schemas.microsoft.com/office/drawing/2014/main" id="{FEE31F2F-6C81-437B-ABD5-9ACB1FC4582C}"/>
+                <a16:creationId xmlns:a16="http://schemas.microsoft.com/office/drawing/2014/main" id="{2CBFA82A-3569-4974-BB6B-C079327F5840}"/>
               </a:ext>
             </a:extLst>
           </p:cNvPr>
@@ -9979,7 +9979,7 @@
           <p:cNvPr id="6" name="">
             <a:extLst xmlns:a="http://schemas.openxmlformats.org/drawingml/2006/main">
               <a:ext uri="{FF2B5EF4-FFF2-40B4-BE49-F238E27FC236}">
-                <a16:creationId xmlns:a16="http://schemas.microsoft.com/office/drawing/2014/main" id="{BF718171-8F26-4648-846C-2961BF1EB2FF}"/>
+                <a16:creationId xmlns:a16="http://schemas.microsoft.com/office/drawing/2014/main" id="{5169A31E-F707-4836-A309-B0A2394E130B}"/>
               </a:ext>
             </a:extLst>
           </p:cNvPr>
@@ -10043,7 +10043,7 @@
           <p:cNvPr id="7" name="">
             <a:extLst xmlns:a="http://schemas.openxmlformats.org/drawingml/2006/main">
               <a:ext uri="{FF2B5EF4-FFF2-40B4-BE49-F238E27FC236}">
-                <a16:creationId xmlns:a16="http://schemas.microsoft.com/office/drawing/2014/main" id="{1DFA9349-5715-4CB9-91DE-F15E633FC651}"/>
+                <a16:creationId xmlns:a16="http://schemas.microsoft.com/office/drawing/2014/main" id="{F0F80D18-DAF7-463C-AFF8-3018E0540302}"/>
               </a:ext>
             </a:extLst>
           </p:cNvPr>
@@ -10107,7 +10107,7 @@
           <p:cNvPr id="8" name="">
             <a:extLst xmlns:a="http://schemas.openxmlformats.org/drawingml/2006/main">
               <a:ext uri="{FF2B5EF4-FFF2-40B4-BE49-F238E27FC236}">
-                <a16:creationId xmlns:a16="http://schemas.microsoft.com/office/drawing/2014/main" id="{3B713A03-F4F3-4F6B-9950-350111EA18B9}"/>
+                <a16:creationId xmlns:a16="http://schemas.microsoft.com/office/drawing/2014/main" id="{8BE4690A-764A-43D2-8248-2EEEC4041266}"/>
               </a:ext>
             </a:extLst>
           </p:cNvPr>
@@ -10140,7 +10140,7 @@
           <p:cNvPr id="9" name="">
             <a:extLst xmlns:a="http://schemas.openxmlformats.org/drawingml/2006/main">
               <a:ext uri="{FF2B5EF4-FFF2-40B4-BE49-F238E27FC236}">
-                <a16:creationId xmlns:a16="http://schemas.microsoft.com/office/drawing/2014/main" id="{C0132531-D98C-4919-B782-2E6DF527E476}"/>
+                <a16:creationId xmlns:a16="http://schemas.microsoft.com/office/drawing/2014/main" id="{9C4BDE1A-1969-4A83-ABB3-99795819261E}"/>
               </a:ext>
             </a:extLst>
           </p:cNvPr>
@@ -10204,7 +10204,7 @@
           <p:cNvPr id="10" name="">
             <a:extLst xmlns:a="http://schemas.openxmlformats.org/drawingml/2006/main">
               <a:ext uri="{FF2B5EF4-FFF2-40B4-BE49-F238E27FC236}">
-                <a16:creationId xmlns:a16="http://schemas.microsoft.com/office/drawing/2014/main" id="{3D9B8B04-68F6-4AC7-B642-EC274582FBD3}"/>
+                <a16:creationId xmlns:a16="http://schemas.microsoft.com/office/drawing/2014/main" id="{5E63B5D6-059B-4442-A3BF-1AFAB77767F8}"/>
               </a:ext>
             </a:extLst>
           </p:cNvPr>
@@ -10268,7 +10268,7 @@
           <p:cNvPr id="11" name="">
             <a:extLst xmlns:a="http://schemas.openxmlformats.org/drawingml/2006/main">
               <a:ext uri="{FF2B5EF4-FFF2-40B4-BE49-F238E27FC236}">
-                <a16:creationId xmlns:a16="http://schemas.microsoft.com/office/drawing/2014/main" id="{22159226-B007-4B0B-BE3F-CB956AB2DDCB}"/>
+                <a16:creationId xmlns:a16="http://schemas.microsoft.com/office/drawing/2014/main" id="{FDEF1180-64DA-4DF0-BB26-C3A0F4ABEA99}"/>
               </a:ext>
             </a:extLst>
           </p:cNvPr>
@@ -10301,7 +10301,7 @@
           <p:cNvPr id="12" name="">
             <a:extLst xmlns:a="http://schemas.openxmlformats.org/drawingml/2006/main">
               <a:ext uri="{FF2B5EF4-FFF2-40B4-BE49-F238E27FC236}">
-                <a16:creationId xmlns:a16="http://schemas.microsoft.com/office/drawing/2014/main" id="{C1D6714A-C795-4A2C-9E31-B9CE65907E58}"/>
+                <a16:creationId xmlns:a16="http://schemas.microsoft.com/office/drawing/2014/main" id="{2B5CD523-8F44-42B5-A40D-6FEF0BB69E03}"/>
               </a:ext>
             </a:extLst>
           </p:cNvPr>
@@ -10365,7 +10365,7 @@
           <p:cNvPr id="13" name="">
             <a:extLst xmlns:a="http://schemas.openxmlformats.org/drawingml/2006/main">
               <a:ext uri="{FF2B5EF4-FFF2-40B4-BE49-F238E27FC236}">
-                <a16:creationId xmlns:a16="http://schemas.microsoft.com/office/drawing/2014/main" id="{865DE2D3-DC5E-4FC9-8FBB-EC4DC41EE9B7}"/>
+                <a16:creationId xmlns:a16="http://schemas.microsoft.com/office/drawing/2014/main" id="{A0DE4DF4-B3CC-4FA1-8A24-39FF4C4C5F26}"/>
               </a:ext>
             </a:extLst>
           </p:cNvPr>
@@ -10429,7 +10429,7 @@
           <p:cNvPr id="14" name="">
             <a:extLst xmlns:a="http://schemas.openxmlformats.org/drawingml/2006/main">
               <a:ext uri="{FF2B5EF4-FFF2-40B4-BE49-F238E27FC236}">
-                <a16:creationId xmlns:a16="http://schemas.microsoft.com/office/drawing/2014/main" id="{44FDDF8D-221F-49B5-B2CB-82BC5E75DFFB}"/>
+                <a16:creationId xmlns:a16="http://schemas.microsoft.com/office/drawing/2014/main" id="{AFF8E6E3-E929-4B3B-A07B-E6E30C4A82F3}"/>
               </a:ext>
             </a:extLst>
           </p:cNvPr>
@@ -10462,7 +10462,7 @@
           <p:cNvPr id="15" name="">
             <a:extLst xmlns:a="http://schemas.openxmlformats.org/drawingml/2006/main">
               <a:ext uri="{FF2B5EF4-FFF2-40B4-BE49-F238E27FC236}">
-                <a16:creationId xmlns:a16="http://schemas.microsoft.com/office/drawing/2014/main" id="{CEC12494-644E-4730-97D3-0CB4A081B4EC}"/>
+                <a16:creationId xmlns:a16="http://schemas.microsoft.com/office/drawing/2014/main" id="{C399EF7D-6607-43B2-9CAE-3A5E3FAB7620}"/>
               </a:ext>
             </a:extLst>
           </p:cNvPr>
@@ -10526,7 +10526,7 @@
           <p:cNvPr id="16" name="">
             <a:extLst xmlns:a="http://schemas.openxmlformats.org/drawingml/2006/main">
               <a:ext uri="{FF2B5EF4-FFF2-40B4-BE49-F238E27FC236}">
-                <a16:creationId xmlns:a16="http://schemas.microsoft.com/office/drawing/2014/main" id="{42482B04-1F4C-4A46-9A45-974FC522E036}"/>
+                <a16:creationId xmlns:a16="http://schemas.microsoft.com/office/drawing/2014/main" id="{823B4B93-1E17-4573-849F-ECF172EF7A60}"/>
               </a:ext>
             </a:extLst>
           </p:cNvPr>
@@ -10590,7 +10590,7 @@
           <p:cNvPr id="17" name="">
             <a:extLst xmlns:a="http://schemas.openxmlformats.org/drawingml/2006/main">
               <a:ext uri="{FF2B5EF4-FFF2-40B4-BE49-F238E27FC236}">
-                <a16:creationId xmlns:a16="http://schemas.microsoft.com/office/drawing/2014/main" id="{0E329818-5EB2-436D-BB12-C5B0DA9767D1}"/>
+                <a16:creationId xmlns:a16="http://schemas.microsoft.com/office/drawing/2014/main" id="{71E8CADF-201C-4C42-8815-4727C543B98F}"/>
               </a:ext>
             </a:extLst>
           </p:cNvPr>
@@ -10625,7 +10625,7 @@
           <p:cNvPr id="18" name="">
             <a:extLst xmlns:a="http://schemas.openxmlformats.org/drawingml/2006/main">
               <a:ext uri="{FF2B5EF4-FFF2-40B4-BE49-F238E27FC236}">
-                <a16:creationId xmlns:a16="http://schemas.microsoft.com/office/drawing/2014/main" id="{9E78ADBF-AEEA-4D86-AB5B-D796C11942B1}"/>
+                <a16:creationId xmlns:a16="http://schemas.microsoft.com/office/drawing/2014/main" id="{92C10739-CD6C-48FD-BC3F-CD76D329ED2C}"/>
               </a:ext>
             </a:extLst>
           </p:cNvPr>
@@ -10689,7 +10689,7 @@
           <p:cNvPr id="19" name="">
             <a:extLst xmlns:a="http://schemas.openxmlformats.org/drawingml/2006/main">
               <a:ext uri="{FF2B5EF4-FFF2-40B4-BE49-F238E27FC236}">
-                <a16:creationId xmlns:a16="http://schemas.microsoft.com/office/drawing/2014/main" id="{DA01022F-5302-423B-B3B9-DE5B7DF69734}"/>
+                <a16:creationId xmlns:a16="http://schemas.microsoft.com/office/drawing/2014/main" id="{7D0D09D6-CBEB-4C55-A8B2-46E066F74B00}"/>
               </a:ext>
             </a:extLst>
           </p:cNvPr>
@@ -10724,7 +10724,7 @@
           <p:cNvPr id="20" name="">
             <a:extLst xmlns:a="http://schemas.openxmlformats.org/drawingml/2006/main">
               <a:ext uri="{FF2B5EF4-FFF2-40B4-BE49-F238E27FC236}">
-                <a16:creationId xmlns:a16="http://schemas.microsoft.com/office/drawing/2014/main" id="{588600EA-9DDB-4A08-B89E-8E11134F676B}"/>
+                <a16:creationId xmlns:a16="http://schemas.microsoft.com/office/drawing/2014/main" id="{71AF549A-A7A9-48AB-B43B-169D9EEAE48B}"/>
               </a:ext>
             </a:extLst>
           </p:cNvPr>
@@ -10788,7 +10788,7 @@
           <p:cNvPr id="21" name="">
             <a:extLst xmlns:a="http://schemas.openxmlformats.org/drawingml/2006/main">
               <a:ext uri="{FF2B5EF4-FFF2-40B4-BE49-F238E27FC236}">
-                <a16:creationId xmlns:a16="http://schemas.microsoft.com/office/drawing/2014/main" id="{B3179002-251D-4233-811F-F612A946BF78}"/>
+                <a16:creationId xmlns:a16="http://schemas.microsoft.com/office/drawing/2014/main" id="{55852BA9-5665-435B-83BF-CB611337EAC4}"/>
               </a:ext>
             </a:extLst>
           </p:cNvPr>
@@ -10823,7 +10823,7 @@
           <p:cNvPr id="22" name="">
             <a:extLst xmlns:a="http://schemas.openxmlformats.org/drawingml/2006/main">
               <a:ext uri="{FF2B5EF4-FFF2-40B4-BE49-F238E27FC236}">
-                <a16:creationId xmlns:a16="http://schemas.microsoft.com/office/drawing/2014/main" id="{87FC6230-4B14-4C9F-B791-FCBF600348A2}"/>
+                <a16:creationId xmlns:a16="http://schemas.microsoft.com/office/drawing/2014/main" id="{A6999461-AC95-4667-A859-826551219170}"/>
               </a:ext>
             </a:extLst>
           </p:cNvPr>
@@ -10858,7 +10858,7 @@
           <p:cNvPr id="23" name="">
             <a:extLst xmlns:a="http://schemas.openxmlformats.org/drawingml/2006/main">
               <a:ext uri="{FF2B5EF4-FFF2-40B4-BE49-F238E27FC236}">
-                <a16:creationId xmlns:a16="http://schemas.microsoft.com/office/drawing/2014/main" id="{F010E7DC-2F1A-43AB-AE76-CB96003B6E24}"/>
+                <a16:creationId xmlns:a16="http://schemas.microsoft.com/office/drawing/2014/main" id="{0E98AF54-6F25-49C0-9AA8-5BCB0D571F8C}"/>
               </a:ext>
             </a:extLst>
           </p:cNvPr>
@@ -10922,7 +10922,7 @@
           <p:cNvPr id="24" name="">
             <a:extLst xmlns:a="http://schemas.openxmlformats.org/drawingml/2006/main">
               <a:ext uri="{FF2B5EF4-FFF2-40B4-BE49-F238E27FC236}">
-                <a16:creationId xmlns:a16="http://schemas.microsoft.com/office/drawing/2014/main" id="{EF3A0542-AE3B-4261-826E-0A1717093A56}"/>
+                <a16:creationId xmlns:a16="http://schemas.microsoft.com/office/drawing/2014/main" id="{E2F72956-70B6-478B-85BC-C9B2B3734DFB}"/>
               </a:ext>
             </a:extLst>
           </p:cNvPr>
@@ -10957,7 +10957,7 @@
           <p:cNvPr id="25" name="">
             <a:extLst xmlns:a="http://schemas.openxmlformats.org/drawingml/2006/main">
               <a:ext uri="{FF2B5EF4-FFF2-40B4-BE49-F238E27FC236}">
-                <a16:creationId xmlns:a16="http://schemas.microsoft.com/office/drawing/2014/main" id="{2D24ED63-02CF-4297-8175-3AFED006C3FE}"/>
+                <a16:creationId xmlns:a16="http://schemas.microsoft.com/office/drawing/2014/main" id="{2ACC2C87-91E6-4870-834C-E644C08CE9CC}"/>
               </a:ext>
             </a:extLst>
           </p:cNvPr>
@@ -10992,7 +10992,7 @@
           <p:cNvPr id="26" name="">
             <a:extLst xmlns:a="http://schemas.openxmlformats.org/drawingml/2006/main">
               <a:ext uri="{FF2B5EF4-FFF2-40B4-BE49-F238E27FC236}">
-                <a16:creationId xmlns:a16="http://schemas.microsoft.com/office/drawing/2014/main" id="{9BE67776-D1B5-450C-A932-BFDB15275179}"/>
+                <a16:creationId xmlns:a16="http://schemas.microsoft.com/office/drawing/2014/main" id="{C0408859-F74F-4197-8073-69A0C2117699}"/>
               </a:ext>
             </a:extLst>
           </p:cNvPr>
@@ -11056,7 +11056,7 @@
           <p:cNvPr id="27" name="">
             <a:extLst xmlns:a="http://schemas.openxmlformats.org/drawingml/2006/main">
               <a:ext uri="{FF2B5EF4-FFF2-40B4-BE49-F238E27FC236}">
-                <a16:creationId xmlns:a16="http://schemas.microsoft.com/office/drawing/2014/main" id="{8D2019F5-5CF8-4F38-BA19-9923E724D7ED}"/>
+                <a16:creationId xmlns:a16="http://schemas.microsoft.com/office/drawing/2014/main" id="{961172C2-F06B-4786-B5CC-FF8B97381CC5}"/>
               </a:ext>
             </a:extLst>
           </p:cNvPr>
@@ -11091,7 +11091,7 @@
           <p:cNvPr id="28" name="">
             <a:extLst xmlns:a="http://schemas.openxmlformats.org/drawingml/2006/main">
               <a:ext uri="{FF2B5EF4-FFF2-40B4-BE49-F238E27FC236}">
-                <a16:creationId xmlns:a16="http://schemas.microsoft.com/office/drawing/2014/main" id="{A8E63165-5591-43AD-AB83-FA407EAF60B1}"/>
+                <a16:creationId xmlns:a16="http://schemas.microsoft.com/office/drawing/2014/main" id="{074E770A-895E-452A-93FD-FBFD10BF24E7}"/>
               </a:ext>
             </a:extLst>
           </p:cNvPr>
@@ -11126,7 +11126,7 @@
           <p:cNvPr id="29" name="">
             <a:extLst xmlns:a="http://schemas.openxmlformats.org/drawingml/2006/main">
               <a:ext uri="{FF2B5EF4-FFF2-40B4-BE49-F238E27FC236}">
-                <a16:creationId xmlns:a16="http://schemas.microsoft.com/office/drawing/2014/main" id="{89892C6B-2DA9-445D-814E-3F14C24DF9B7}"/>
+                <a16:creationId xmlns:a16="http://schemas.microsoft.com/office/drawing/2014/main" id="{241A308B-E48B-4ACB-8D5F-F17C6B0CF7E2}"/>
               </a:ext>
             </a:extLst>
           </p:cNvPr>
@@ -11190,7 +11190,7 @@
           <p:cNvPr id="30" name="">
             <a:extLst xmlns:a="http://schemas.openxmlformats.org/drawingml/2006/main">
               <a:ext uri="{FF2B5EF4-FFF2-40B4-BE49-F238E27FC236}">
-                <a16:creationId xmlns:a16="http://schemas.microsoft.com/office/drawing/2014/main" id="{4EB989BC-3C93-404D-AD2F-3BB8E7002742}"/>
+                <a16:creationId xmlns:a16="http://schemas.microsoft.com/office/drawing/2014/main" id="{171D76A8-1E5F-4805-A90F-AAD9D82F4F2D}"/>
               </a:ext>
             </a:extLst>
           </p:cNvPr>
@@ -11225,7 +11225,7 @@
           <p:cNvPr id="31" name="">
             <a:extLst xmlns:a="http://schemas.openxmlformats.org/drawingml/2006/main">
               <a:ext uri="{FF2B5EF4-FFF2-40B4-BE49-F238E27FC236}">
-                <a16:creationId xmlns:a16="http://schemas.microsoft.com/office/drawing/2014/main" id="{2964888F-DF9D-4346-941E-444903280B07}"/>
+                <a16:creationId xmlns:a16="http://schemas.microsoft.com/office/drawing/2014/main" id="{B46541B0-E694-41CE-B687-9E488303A6AF}"/>
               </a:ext>
             </a:extLst>
           </p:cNvPr>
@@ -11279,7 +11279,7 @@
                 <a:ea typeface="Hiragino Sans"/>
                 <a:cs typeface="Hiragino Sans"/>
               </a:rPr>
-              <a:t>source: paper/sections/01_introduction.tex</a:t>
+              <a:t>source: Introduction</a:t>
             </a:r>
           </a:p>
         </p:txBody>
@@ -11289,7 +11289,7 @@
           <p:cNvPr id="32" name="">
             <a:extLst xmlns:a="http://schemas.openxmlformats.org/drawingml/2006/main">
               <a:ext uri="{FF2B5EF4-FFF2-40B4-BE49-F238E27FC236}">
-                <a16:creationId xmlns:a16="http://schemas.microsoft.com/office/drawing/2014/main" id="{24BE2056-D1AB-4B09-B71B-0BD4C396B550}"/>
+                <a16:creationId xmlns:a16="http://schemas.microsoft.com/office/drawing/2014/main" id="{04D8F476-B7D4-427B-AB4F-60E081C712AC}"/>
               </a:ext>
             </a:extLst>
           </p:cNvPr>
@@ -11351,7 +11351,7 @@
     </p:spTree>
     <p:extLst>
       <p:ext uri="{BB962C8B-B14F-4D97-AF65-F5344CB8AC3E}">
-        <p14:creationId xmlns:p14="http://schemas.microsoft.com/office/powerpoint/2010/main" val="1766727132"/>
+        <p14:creationId xmlns:p14="http://schemas.microsoft.com/office/powerpoint/2010/main" val="167561276"/>
       </p:ext>
     </p:extLst>
   </p:cSld>
@@ -11375,7 +11375,7 @@
           <p:cNvPr id="1" name="">
             <a:extLst xmlns:a="http://schemas.openxmlformats.org/drawingml/2006/main">
               <a:ext uri="{FF2B5EF4-FFF2-40B4-BE49-F238E27FC236}">
-                <a16:creationId xmlns:a16="http://schemas.microsoft.com/office/drawing/2014/main" id="{9F09A4BA-0A39-495A-902B-ABA203304434}"/>
+                <a16:creationId xmlns:a16="http://schemas.microsoft.com/office/drawing/2014/main" id="{61BE61D3-8D45-4C65-BEC5-42EADD6224C4}"/>
               </a:ext>
             </a:extLst>
           </p:cNvPr>
@@ -11410,7 +11410,7 @@
           <p:cNvPr id="2" name="">
             <a:extLst xmlns:a="http://schemas.openxmlformats.org/drawingml/2006/main">
               <a:ext uri="{FF2B5EF4-FFF2-40B4-BE49-F238E27FC236}">
-                <a16:creationId xmlns:a16="http://schemas.microsoft.com/office/drawing/2014/main" id="{0CAE6A24-7ED7-4BDB-9BBA-B5F026065F29}"/>
+                <a16:creationId xmlns:a16="http://schemas.microsoft.com/office/drawing/2014/main" id="{6F1D485E-28FB-498D-BEC0-476332D79AD7}"/>
               </a:ext>
             </a:extLst>
           </p:cNvPr>
@@ -11445,7 +11445,7 @@
           <p:cNvPr id="3" name="">
             <a:extLst xmlns:a="http://schemas.openxmlformats.org/drawingml/2006/main">
               <a:ext uri="{FF2B5EF4-FFF2-40B4-BE49-F238E27FC236}">
-                <a16:creationId xmlns:a16="http://schemas.microsoft.com/office/drawing/2014/main" id="{5143F1D6-653C-4EBD-B5A8-332811E45EA6}"/>
+                <a16:creationId xmlns:a16="http://schemas.microsoft.com/office/drawing/2014/main" id="{D1665F05-C4D6-4277-925B-23F3B9FC44F1}"/>
               </a:ext>
             </a:extLst>
           </p:cNvPr>
@@ -11499,7 +11499,7 @@
                 <a:ea typeface="Hiragino Sans"/>
                 <a:cs typeface="Hiragino Sans"/>
               </a:rPr>
-              <a:t>本研究の主張は、寄生流れを「調整」ではなく離散契約で抑えること</a:t>
+              <a:t>計算コアはCCDファミリ：微分・面フラックス・運動量対流</a:t>
             </a:r>
           </a:p>
         </p:txBody>
@@ -11509,7 +11509,7 @@
           <p:cNvPr id="4" name="">
             <a:extLst xmlns:a="http://schemas.openxmlformats.org/drawingml/2006/main">
               <a:ext uri="{FF2B5EF4-FFF2-40B4-BE49-F238E27FC236}">
-                <a16:creationId xmlns:a16="http://schemas.microsoft.com/office/drawing/2014/main" id="{64E931A1-50FC-442C-8572-1117AFAF1960}"/>
+                <a16:creationId xmlns:a16="http://schemas.microsoft.com/office/drawing/2014/main" id="{A4FA4EF7-09AE-47F1-AE24-25190765A4C4}"/>
               </a:ext>
             </a:extLst>
           </p:cNvPr>
@@ -11563,7 +11563,7 @@
                 <a:ea typeface="Hiragino Sans"/>
                 <a:cs typeface="Hiragino Sans"/>
               </a:rPr>
-              <a:t>曲率・圧力・速度補正・界面輸送を face-space contract に集約し、Balanced-Force 条件を演算子レベルで保つ。</a:t>
+              <a:t>CCDが節点微分、FCCDが面値/面勾配、UCCD6が運動量対流を担い、その上に圧力閉包と界面追跡を載せる。</a:t>
             </a:r>
           </a:p>
         </p:txBody>
@@ -11573,7 +11573,7 @@
           <p:cNvPr id="5" name="">
             <a:extLst xmlns:a="http://schemas.openxmlformats.org/drawingml/2006/main">
               <a:ext uri="{FF2B5EF4-FFF2-40B4-BE49-F238E27FC236}">
-                <a16:creationId xmlns:a16="http://schemas.microsoft.com/office/drawing/2014/main" id="{C272A513-DE48-46C3-9DC2-38D7740CA488}"/>
+                <a16:creationId xmlns:a16="http://schemas.microsoft.com/office/drawing/2014/main" id="{B4333533-8950-4F82-9615-759EDF5E6222}"/>
               </a:ext>
             </a:extLst>
           </p:cNvPr>
@@ -11606,7 +11606,7 @@
           <p:cNvPr id="6" name="">
             <a:extLst xmlns:a="http://schemas.openxmlformats.org/drawingml/2006/main">
               <a:ext uri="{FF2B5EF4-FFF2-40B4-BE49-F238E27FC236}">
-                <a16:creationId xmlns:a16="http://schemas.microsoft.com/office/drawing/2014/main" id="{32F5ADAB-D3BD-42CB-96FD-8A1559EC9EFE}"/>
+                <a16:creationId xmlns:a16="http://schemas.microsoft.com/office/drawing/2014/main" id="{1D7C863D-DCC9-476D-8E27-E412FE7D761E}"/>
               </a:ext>
             </a:extLst>
           </p:cNvPr>
@@ -11670,7 +11670,7 @@
           <p:cNvPr id="7" name="">
             <a:extLst xmlns:a="http://schemas.openxmlformats.org/drawingml/2006/main">
               <a:ext uri="{FF2B5EF4-FFF2-40B4-BE49-F238E27FC236}">
-                <a16:creationId xmlns:a16="http://schemas.microsoft.com/office/drawing/2014/main" id="{0DE95CB1-6D98-4E5B-8647-305738220DB8}"/>
+                <a16:creationId xmlns:a16="http://schemas.microsoft.com/office/drawing/2014/main" id="{55BC9246-68F5-4AC0-BCD4-5432A3DD27B0}"/>
               </a:ext>
             </a:extLst>
           </p:cNvPr>
@@ -11724,7 +11724,7 @@
                 <a:ea typeface="Hiragino Sans"/>
                 <a:cs typeface="Hiragino Sans"/>
               </a:rPr>
-              <a:t>高次演算子群</a:t>
+              <a:t>CCD/FCCD/UCCD6</a:t>
             </a:r>
           </a:p>
         </p:txBody>
@@ -11734,7 +11734,7 @@
           <p:cNvPr id="8" name="">
             <a:extLst xmlns:a="http://schemas.openxmlformats.org/drawingml/2006/main">
               <a:ext uri="{FF2B5EF4-FFF2-40B4-BE49-F238E27FC236}">
-                <a16:creationId xmlns:a16="http://schemas.microsoft.com/office/drawing/2014/main" id="{95BD3240-F935-4B8B-9D76-796B44C26B18}"/>
+                <a16:creationId xmlns:a16="http://schemas.microsoft.com/office/drawing/2014/main" id="{9DCFE51D-CFF2-4E88-A791-B413FAAF64FE}"/>
               </a:ext>
             </a:extLst>
           </p:cNvPr>
@@ -11788,7 +11788,7 @@
                 <a:ea typeface="Hiragino Sans"/>
                 <a:cs typeface="Hiragino Sans"/>
               </a:rPr>
-              <a:t>CCD / DCCD / UCCD6 / FCCD</a:t>
+              <a:t>節点微分・面フラックス・運動量対流</a:t>
             </a:r>
           </a:p>
         </p:txBody>
@@ -11798,7 +11798,7 @@
           <p:cNvPr id="9" name="">
             <a:extLst xmlns:a="http://schemas.openxmlformats.org/drawingml/2006/main">
               <a:ext uri="{FF2B5EF4-FFF2-40B4-BE49-F238E27FC236}">
-                <a16:creationId xmlns:a16="http://schemas.microsoft.com/office/drawing/2014/main" id="{9F733EA4-F8F0-4824-B684-83B53FC4C3FE}"/>
+                <a16:creationId xmlns:a16="http://schemas.microsoft.com/office/drawing/2014/main" id="{49AC0C5F-39D5-423A-9C22-21B5CED6CC1D}"/>
               </a:ext>
             </a:extLst>
           </p:cNvPr>
@@ -11831,7 +11831,7 @@
           <p:cNvPr id="10" name="">
             <a:extLst xmlns:a="http://schemas.openxmlformats.org/drawingml/2006/main">
               <a:ext uri="{FF2B5EF4-FFF2-40B4-BE49-F238E27FC236}">
-                <a16:creationId xmlns:a16="http://schemas.microsoft.com/office/drawing/2014/main" id="{028D0A6F-0408-41DB-9A82-13E3F6E73BFF}"/>
+                <a16:creationId xmlns:a16="http://schemas.microsoft.com/office/drawing/2014/main" id="{EE7C88E7-8A23-4050-B116-2D555E85201D}"/>
               </a:ext>
             </a:extLst>
           </p:cNvPr>
@@ -11895,7 +11895,7 @@
           <p:cNvPr id="11" name="">
             <a:extLst xmlns:a="http://schemas.openxmlformats.org/drawingml/2006/main">
               <a:ext uri="{FF2B5EF4-FFF2-40B4-BE49-F238E27FC236}">
-                <a16:creationId xmlns:a16="http://schemas.microsoft.com/office/drawing/2014/main" id="{369F146D-5A69-4A67-AE00-C8AE29EC9FE5}"/>
+                <a16:creationId xmlns:a16="http://schemas.microsoft.com/office/drawing/2014/main" id="{9028089F-9ACB-4CA1-9C85-4523620A641F}"/>
               </a:ext>
             </a:extLst>
           </p:cNvPr>
@@ -11949,7 +11949,7 @@
                 <a:ea typeface="Hiragino Sans"/>
                 <a:cs typeface="Hiragino Sans"/>
               </a:rPr>
-              <a:t>圧力閉包</a:t>
+              <a:t>圧力ジャンプ閉包</a:t>
             </a:r>
           </a:p>
         </p:txBody>
@@ -11959,7 +11959,7 @@
           <p:cNvPr id="12" name="">
             <a:extLst xmlns:a="http://schemas.openxmlformats.org/drawingml/2006/main">
               <a:ext uri="{FF2B5EF4-FFF2-40B4-BE49-F238E27FC236}">
-                <a16:creationId xmlns:a16="http://schemas.microsoft.com/office/drawing/2014/main" id="{18C8E890-597B-4FF9-A1C2-33747505E8EF}"/>
+                <a16:creationId xmlns:a16="http://schemas.microsoft.com/office/drawing/2014/main" id="{41A95AAB-2D1A-4BEB-B158-29904796C627}"/>
               </a:ext>
             </a:extLst>
           </p:cNvPr>
@@ -12023,7 +12023,7 @@
           <p:cNvPr id="13" name="">
             <a:extLst xmlns:a="http://schemas.openxmlformats.org/drawingml/2006/main">
               <a:ext uri="{FF2B5EF4-FFF2-40B4-BE49-F238E27FC236}">
-                <a16:creationId xmlns:a16="http://schemas.microsoft.com/office/drawing/2014/main" id="{FDF85BA7-85EB-4121-84B9-61DBF987A7D1}"/>
+                <a16:creationId xmlns:a16="http://schemas.microsoft.com/office/drawing/2014/main" id="{244B5601-C51C-4615-8498-0806C24E17AF}"/>
               </a:ext>
             </a:extLst>
           </p:cNvPr>
@@ -12056,7 +12056,7 @@
           <p:cNvPr id="14" name="">
             <a:extLst xmlns:a="http://schemas.openxmlformats.org/drawingml/2006/main">
               <a:ext uri="{FF2B5EF4-FFF2-40B4-BE49-F238E27FC236}">
-                <a16:creationId xmlns:a16="http://schemas.microsoft.com/office/drawing/2014/main" id="{47B8C831-5DD4-4F17-BDCD-71214AADE362}"/>
+                <a16:creationId xmlns:a16="http://schemas.microsoft.com/office/drawing/2014/main" id="{1F6B52FF-A7B5-49F5-8CCE-0A53AF3CEE80}"/>
               </a:ext>
             </a:extLst>
           </p:cNvPr>
@@ -12120,7 +12120,7 @@
           <p:cNvPr id="15" name="">
             <a:extLst xmlns:a="http://schemas.openxmlformats.org/drawingml/2006/main">
               <a:ext uri="{FF2B5EF4-FFF2-40B4-BE49-F238E27FC236}">
-                <a16:creationId xmlns:a16="http://schemas.microsoft.com/office/drawing/2014/main" id="{AB3B6753-13C5-46D9-A33F-5203502F3FD0}"/>
+                <a16:creationId xmlns:a16="http://schemas.microsoft.com/office/drawing/2014/main" id="{F0A0D0BB-DE98-48D8-BE6F-81087DF4CF4F}"/>
               </a:ext>
             </a:extLst>
           </p:cNvPr>
@@ -12184,7 +12184,7 @@
           <p:cNvPr id="16" name="">
             <a:extLst xmlns:a="http://schemas.openxmlformats.org/drawingml/2006/main">
               <a:ext uri="{FF2B5EF4-FFF2-40B4-BE49-F238E27FC236}">
-                <a16:creationId xmlns:a16="http://schemas.microsoft.com/office/drawing/2014/main" id="{831D6311-1D1D-4BC1-81FC-923693F49FA5}"/>
+                <a16:creationId xmlns:a16="http://schemas.microsoft.com/office/drawing/2014/main" id="{A83E4BA1-C43C-4B16-BCE2-7CC69E5014CB}"/>
               </a:ext>
             </a:extLst>
           </p:cNvPr>
@@ -12248,7 +12248,7 @@
           <p:cNvPr id="17" name="">
             <a:extLst xmlns:a="http://schemas.openxmlformats.org/drawingml/2006/main">
               <a:ext uri="{FF2B5EF4-FFF2-40B4-BE49-F238E27FC236}">
-                <a16:creationId xmlns:a16="http://schemas.microsoft.com/office/drawing/2014/main" id="{7447B63D-36AE-404B-B222-888209EAA024}"/>
+                <a16:creationId xmlns:a16="http://schemas.microsoft.com/office/drawing/2014/main" id="{BE724488-42E5-41A1-B2BB-CC79FAC8D36D}"/>
               </a:ext>
             </a:extLst>
           </p:cNvPr>
@@ -12312,7 +12312,7 @@
           <p:cNvPr id="18" name="">
             <a:extLst xmlns:a="http://schemas.openxmlformats.org/drawingml/2006/main">
               <a:ext uri="{FF2B5EF4-FFF2-40B4-BE49-F238E27FC236}">
-                <a16:creationId xmlns:a16="http://schemas.microsoft.com/office/drawing/2014/main" id="{58D517F1-ECDF-4C3B-B1E3-A89954AAAF01}"/>
+                <a16:creationId xmlns:a16="http://schemas.microsoft.com/office/drawing/2014/main" id="{4CBEA3BF-33D7-4EAE-9DDD-C1D36B582ACD}"/>
               </a:ext>
             </a:extLst>
           </p:cNvPr>
@@ -12347,7 +12347,7 @@
           <p:cNvPr id="19" name="">
             <a:extLst xmlns:a="http://schemas.openxmlformats.org/drawingml/2006/main">
               <a:ext uri="{FF2B5EF4-FFF2-40B4-BE49-F238E27FC236}">
-                <a16:creationId xmlns:a16="http://schemas.microsoft.com/office/drawing/2014/main" id="{D01D8FBB-C377-4241-8323-73C01B816FF5}"/>
+                <a16:creationId xmlns:a16="http://schemas.microsoft.com/office/drawing/2014/main" id="{1EAAE395-CF97-4CA2-B159-F077071FA036}"/>
               </a:ext>
             </a:extLst>
           </p:cNvPr>
@@ -12401,7 +12401,7 @@
                 <a:ea typeface="Hiragino Sans"/>
                 <a:cs typeface="Hiragino Sans"/>
               </a:rPr>
-              <a:t>source: paper/sections/01_introduction.tex; 08_collocate.tex; 11_full_algorithm.tex</a:t>
+              <a:t>source: Introduction; collocated face geometry; full algorithm</a:t>
             </a:r>
           </a:p>
         </p:txBody>
@@ -12411,7 +12411,7 @@
           <p:cNvPr id="20" name="">
             <a:extLst xmlns:a="http://schemas.openxmlformats.org/drawingml/2006/main">
               <a:ext uri="{FF2B5EF4-FFF2-40B4-BE49-F238E27FC236}">
-                <a16:creationId xmlns:a16="http://schemas.microsoft.com/office/drawing/2014/main" id="{DF745398-EDA0-4B78-A944-555E1CEE5706}"/>
+                <a16:creationId xmlns:a16="http://schemas.microsoft.com/office/drawing/2014/main" id="{4ED95677-BD64-4A76-9471-2721A03F7989}"/>
               </a:ext>
             </a:extLst>
           </p:cNvPr>
@@ -12473,7 +12473,7 @@
     </p:spTree>
     <p:extLst>
       <p:ext uri="{BB962C8B-B14F-4D97-AF65-F5344CB8AC3E}">
-        <p14:creationId xmlns:p14="http://schemas.microsoft.com/office/powerpoint/2010/main" val="247745974"/>
+        <p14:creationId xmlns:p14="http://schemas.microsoft.com/office/powerpoint/2010/main" val="1868864051"/>
       </p:ext>
     </p:extLst>
   </p:cSld>
@@ -12497,7 +12497,7 @@
           <p:cNvPr id="1" name="">
             <a:extLst xmlns:a="http://schemas.openxmlformats.org/drawingml/2006/main">
               <a:ext uri="{FF2B5EF4-FFF2-40B4-BE49-F238E27FC236}">
-                <a16:creationId xmlns:a16="http://schemas.microsoft.com/office/drawing/2014/main" id="{96174607-8B9F-40A4-A8F7-8559E989327B}"/>
+                <a16:creationId xmlns:a16="http://schemas.microsoft.com/office/drawing/2014/main" id="{C73A6642-35B7-4A7D-82D6-209428ECF38B}"/>
               </a:ext>
             </a:extLst>
           </p:cNvPr>
@@ -12532,7 +12532,7 @@
           <p:cNvPr id="2" name="">
             <a:extLst xmlns:a="http://schemas.openxmlformats.org/drawingml/2006/main">
               <a:ext uri="{FF2B5EF4-FFF2-40B4-BE49-F238E27FC236}">
-                <a16:creationId xmlns:a16="http://schemas.microsoft.com/office/drawing/2014/main" id="{7841E7CF-CEC9-4C5C-8996-72AA7405CCD5}"/>
+                <a16:creationId xmlns:a16="http://schemas.microsoft.com/office/drawing/2014/main" id="{F9C7DB71-858A-4571-B87F-4A80353A52D2}"/>
               </a:ext>
             </a:extLst>
           </p:cNvPr>
@@ -12567,7 +12567,7 @@
           <p:cNvPr id="3" name="">
             <a:extLst xmlns:a="http://schemas.openxmlformats.org/drawingml/2006/main">
               <a:ext uri="{FF2B5EF4-FFF2-40B4-BE49-F238E27FC236}">
-                <a16:creationId xmlns:a16="http://schemas.microsoft.com/office/drawing/2014/main" id="{0FDBEF1A-E350-463A-8C49-485278062EDB}"/>
+                <a16:creationId xmlns:a16="http://schemas.microsoft.com/office/drawing/2014/main" id="{341F9434-B683-4470-AB3A-57A54FB1484B}"/>
               </a:ext>
             </a:extLst>
           </p:cNvPr>
@@ -12631,7 +12631,7 @@
           <p:cNvPr id="4" name="">
             <a:extLst xmlns:a="http://schemas.openxmlformats.org/drawingml/2006/main">
               <a:ext uri="{FF2B5EF4-FFF2-40B4-BE49-F238E27FC236}">
-                <a16:creationId xmlns:a16="http://schemas.microsoft.com/office/drawing/2014/main" id="{D216C9ED-92BF-430F-9D1B-679E15E65626}"/>
+                <a16:creationId xmlns:a16="http://schemas.microsoft.com/office/drawing/2014/main" id="{569C537A-D41F-4D9F-9755-C688773021CB}"/>
               </a:ext>
             </a:extLst>
           </p:cNvPr>
@@ -12695,7 +12695,7 @@
           <p:cNvPr id="5" name="">
             <a:extLst xmlns:a="http://schemas.openxmlformats.org/drawingml/2006/main">
               <a:ext uri="{FF2B5EF4-FFF2-40B4-BE49-F238E27FC236}">
-                <a16:creationId xmlns:a16="http://schemas.microsoft.com/office/drawing/2014/main" id="{2D5A3B2A-4072-46A6-A229-32FE9A46CCBD}"/>
+                <a16:creationId xmlns:a16="http://schemas.microsoft.com/office/drawing/2014/main" id="{F57B7A1C-7539-44B8-8093-29E32B25EF67}"/>
               </a:ext>
             </a:extLst>
           </p:cNvPr>
@@ -12728,7 +12728,7 @@
           <p:cNvPr id="6" name="">
             <a:extLst xmlns:a="http://schemas.openxmlformats.org/drawingml/2006/main">
               <a:ext uri="{FF2B5EF4-FFF2-40B4-BE49-F238E27FC236}">
-                <a16:creationId xmlns:a16="http://schemas.microsoft.com/office/drawing/2014/main" id="{CA6F5A3F-3085-41FF-BD99-9CBB868E1FA3}"/>
+                <a16:creationId xmlns:a16="http://schemas.microsoft.com/office/drawing/2014/main" id="{8ACE160B-2E9A-4C8E-8F5D-B51F113772CE}"/>
               </a:ext>
             </a:extLst>
           </p:cNvPr>
@@ -12792,7 +12792,7 @@
           <p:cNvPr id="7" name="">
             <a:extLst xmlns:a="http://schemas.openxmlformats.org/drawingml/2006/main">
               <a:ext uri="{FF2B5EF4-FFF2-40B4-BE49-F238E27FC236}">
-                <a16:creationId xmlns:a16="http://schemas.microsoft.com/office/drawing/2014/main" id="{2CB6E435-D0B6-4402-897E-AEE886B4A92A}"/>
+                <a16:creationId xmlns:a16="http://schemas.microsoft.com/office/drawing/2014/main" id="{37B77352-2CD4-4E9A-B890-3D378C20C48A}"/>
               </a:ext>
             </a:extLst>
           </p:cNvPr>
@@ -12856,7 +12856,7 @@
           <p:cNvPr id="8" name="">
             <a:extLst xmlns:a="http://schemas.openxmlformats.org/drawingml/2006/main">
               <a:ext uri="{FF2B5EF4-FFF2-40B4-BE49-F238E27FC236}">
-                <a16:creationId xmlns:a16="http://schemas.microsoft.com/office/drawing/2014/main" id="{EC76F24A-A86F-4243-95A6-0EF704D84B66}"/>
+                <a16:creationId xmlns:a16="http://schemas.microsoft.com/office/drawing/2014/main" id="{DDCBA20F-7738-412B-AA1B-78ECA7E51671}"/>
               </a:ext>
             </a:extLst>
           </p:cNvPr>
@@ -12920,7 +12920,7 @@
           <p:cNvPr id="9" name="">
             <a:extLst xmlns:a="http://schemas.openxmlformats.org/drawingml/2006/main">
               <a:ext uri="{FF2B5EF4-FFF2-40B4-BE49-F238E27FC236}">
-                <a16:creationId xmlns:a16="http://schemas.microsoft.com/office/drawing/2014/main" id="{BA48697F-2DEA-4C06-A0D4-377FD433F84B}"/>
+                <a16:creationId xmlns:a16="http://schemas.microsoft.com/office/drawing/2014/main" id="{5BE3E0B2-462C-4D7D-96C5-5D9B10728569}"/>
               </a:ext>
             </a:extLst>
           </p:cNvPr>
@@ -12953,7 +12953,7 @@
           <p:cNvPr id="10" name="">
             <a:extLst xmlns:a="http://schemas.openxmlformats.org/drawingml/2006/main">
               <a:ext uri="{FF2B5EF4-FFF2-40B4-BE49-F238E27FC236}">
-                <a16:creationId xmlns:a16="http://schemas.microsoft.com/office/drawing/2014/main" id="{4A3B4CA9-75BB-4ECD-A332-45B18E99BF82}"/>
+                <a16:creationId xmlns:a16="http://schemas.microsoft.com/office/drawing/2014/main" id="{716D92B3-51FD-4763-A0CE-AB03A2EEDFC9}"/>
               </a:ext>
             </a:extLst>
           </p:cNvPr>
@@ -13017,7 +13017,7 @@
           <p:cNvPr id="11" name="">
             <a:extLst xmlns:a="http://schemas.openxmlformats.org/drawingml/2006/main">
               <a:ext uri="{FF2B5EF4-FFF2-40B4-BE49-F238E27FC236}">
-                <a16:creationId xmlns:a16="http://schemas.microsoft.com/office/drawing/2014/main" id="{28BEFC75-9DB1-476B-AC44-4C5408AC81B2}"/>
+                <a16:creationId xmlns:a16="http://schemas.microsoft.com/office/drawing/2014/main" id="{1EF51C78-A726-4E54-B927-77D5428B3CA3}"/>
               </a:ext>
             </a:extLst>
           </p:cNvPr>
@@ -13081,7 +13081,7 @@
           <p:cNvPr id="12" name="">
             <a:extLst xmlns:a="http://schemas.openxmlformats.org/drawingml/2006/main">
               <a:ext uri="{FF2B5EF4-FFF2-40B4-BE49-F238E27FC236}">
-                <a16:creationId xmlns:a16="http://schemas.microsoft.com/office/drawing/2014/main" id="{F5E89C03-F04E-4709-A390-BA6C88C10868}"/>
+                <a16:creationId xmlns:a16="http://schemas.microsoft.com/office/drawing/2014/main" id="{80F897CC-9350-438C-A785-3F5292EDA741}"/>
               </a:ext>
             </a:extLst>
           </p:cNvPr>
@@ -13145,7 +13145,7 @@
           <p:cNvPr id="13" name="">
             <a:extLst xmlns:a="http://schemas.openxmlformats.org/drawingml/2006/main">
               <a:ext uri="{FF2B5EF4-FFF2-40B4-BE49-F238E27FC236}">
-                <a16:creationId xmlns:a16="http://schemas.microsoft.com/office/drawing/2014/main" id="{D96B9207-F094-43D0-8F60-ECDDEB05E37E}"/>
+                <a16:creationId xmlns:a16="http://schemas.microsoft.com/office/drawing/2014/main" id="{2B83EAD2-FC18-46CF-8F4C-EB37312AA0BD}"/>
               </a:ext>
             </a:extLst>
           </p:cNvPr>
@@ -13178,7 +13178,7 @@
           <p:cNvPr id="14" name="">
             <a:extLst xmlns:a="http://schemas.openxmlformats.org/drawingml/2006/main">
               <a:ext uri="{FF2B5EF4-FFF2-40B4-BE49-F238E27FC236}">
-                <a16:creationId xmlns:a16="http://schemas.microsoft.com/office/drawing/2014/main" id="{D9BDEACB-C53A-41A9-92F8-E899A9F3B983}"/>
+                <a16:creationId xmlns:a16="http://schemas.microsoft.com/office/drawing/2014/main" id="{736E3A8C-39DB-47D0-9608-5866D612456A}"/>
               </a:ext>
             </a:extLst>
           </p:cNvPr>
@@ -13242,7 +13242,7 @@
           <p:cNvPr id="15" name="">
             <a:extLst xmlns:a="http://schemas.openxmlformats.org/drawingml/2006/main">
               <a:ext uri="{FF2B5EF4-FFF2-40B4-BE49-F238E27FC236}">
-                <a16:creationId xmlns:a16="http://schemas.microsoft.com/office/drawing/2014/main" id="{BE95010C-E0E7-43E0-9617-09170581DFBE}"/>
+                <a16:creationId xmlns:a16="http://schemas.microsoft.com/office/drawing/2014/main" id="{A732CD6A-42B5-4C53-8D69-823CD22F5E16}"/>
               </a:ext>
             </a:extLst>
           </p:cNvPr>
@@ -13306,7 +13306,7 @@
           <p:cNvPr id="16" name="">
             <a:extLst xmlns:a="http://schemas.openxmlformats.org/drawingml/2006/main">
               <a:ext uri="{FF2B5EF4-FFF2-40B4-BE49-F238E27FC236}">
-                <a16:creationId xmlns:a16="http://schemas.microsoft.com/office/drawing/2014/main" id="{D490E235-705E-4A78-B46E-42B94E6EEB4B}"/>
+                <a16:creationId xmlns:a16="http://schemas.microsoft.com/office/drawing/2014/main" id="{F13F2C21-8782-429E-B818-BD8C50E71309}"/>
               </a:ext>
             </a:extLst>
           </p:cNvPr>
@@ -13370,7 +13370,7 @@
           <p:cNvPr id="17" name="">
             <a:extLst xmlns:a="http://schemas.openxmlformats.org/drawingml/2006/main">
               <a:ext uri="{FF2B5EF4-FFF2-40B4-BE49-F238E27FC236}">
-                <a16:creationId xmlns:a16="http://schemas.microsoft.com/office/drawing/2014/main" id="{F73CC275-FE2F-4FFB-BE8E-DE624D4DB144}"/>
+                <a16:creationId xmlns:a16="http://schemas.microsoft.com/office/drawing/2014/main" id="{6B81D01E-E425-473E-A33C-E6CE3D5F9DCC}"/>
               </a:ext>
             </a:extLst>
           </p:cNvPr>
@@ -13403,7 +13403,7 @@
           <p:cNvPr id="18" name="">
             <a:extLst xmlns:a="http://schemas.openxmlformats.org/drawingml/2006/main">
               <a:ext uri="{FF2B5EF4-FFF2-40B4-BE49-F238E27FC236}">
-                <a16:creationId xmlns:a16="http://schemas.microsoft.com/office/drawing/2014/main" id="{F8B97E76-0944-49CC-8658-AFE7812F0A09}"/>
+                <a16:creationId xmlns:a16="http://schemas.microsoft.com/office/drawing/2014/main" id="{084CE4E9-8B38-4BE8-93AC-A86BBFCE09AE}"/>
               </a:ext>
             </a:extLst>
           </p:cNvPr>
@@ -13467,7 +13467,7 @@
           <p:cNvPr id="19" name="">
             <a:extLst xmlns:a="http://schemas.openxmlformats.org/drawingml/2006/main">
               <a:ext uri="{FF2B5EF4-FFF2-40B4-BE49-F238E27FC236}">
-                <a16:creationId xmlns:a16="http://schemas.microsoft.com/office/drawing/2014/main" id="{03DB354A-5BCB-4473-BEA6-9CA04BF77B81}"/>
+                <a16:creationId xmlns:a16="http://schemas.microsoft.com/office/drawing/2014/main" id="{BA68AFC8-2806-4BF1-B584-C6ABF8CC8DF0}"/>
               </a:ext>
             </a:extLst>
           </p:cNvPr>
@@ -13531,7 +13531,7 @@
           <p:cNvPr id="20" name="">
             <a:extLst xmlns:a="http://schemas.openxmlformats.org/drawingml/2006/main">
               <a:ext uri="{FF2B5EF4-FFF2-40B4-BE49-F238E27FC236}">
-                <a16:creationId xmlns:a16="http://schemas.microsoft.com/office/drawing/2014/main" id="{0F71EE0E-0154-4847-8BBA-D73F2F242669}"/>
+                <a16:creationId xmlns:a16="http://schemas.microsoft.com/office/drawing/2014/main" id="{71506FB8-BF0C-4112-B08B-993BE43703A3}"/>
               </a:ext>
             </a:extLst>
           </p:cNvPr>
@@ -13595,7 +13595,7 @@
           <p:cNvPr id="21" name="">
             <a:extLst xmlns:a="http://schemas.openxmlformats.org/drawingml/2006/main">
               <a:ext uri="{FF2B5EF4-FFF2-40B4-BE49-F238E27FC236}">
-                <a16:creationId xmlns:a16="http://schemas.microsoft.com/office/drawing/2014/main" id="{8E50A13F-CE8C-432A-804D-08E71466B30C}"/>
+                <a16:creationId xmlns:a16="http://schemas.microsoft.com/office/drawing/2014/main" id="{18AFDDD1-0AEF-41F6-8C65-5CF99147E310}"/>
               </a:ext>
             </a:extLst>
           </p:cNvPr>
@@ -13630,7 +13630,7 @@
           <p:cNvPr id="22" name="">
             <a:extLst xmlns:a="http://schemas.openxmlformats.org/drawingml/2006/main">
               <a:ext uri="{FF2B5EF4-FFF2-40B4-BE49-F238E27FC236}">
-                <a16:creationId xmlns:a16="http://schemas.microsoft.com/office/drawing/2014/main" id="{1D2DFCF4-BB15-4B51-9C76-FAC38BA4CC84}"/>
+                <a16:creationId xmlns:a16="http://schemas.microsoft.com/office/drawing/2014/main" id="{FACEB9C7-8A85-4022-8455-424A17960FC9}"/>
               </a:ext>
             </a:extLst>
           </p:cNvPr>
@@ -13684,7 +13684,7 @@
                 <a:ea typeface="Hiragino Sans"/>
                 <a:cs typeface="Hiragino Sans"/>
               </a:rPr>
-              <a:t>source: paper/sections/02_governing.tex; 02b_surface_tension.tex; 03_levelset.tex; 09b_split_ppe.tex</a:t>
+              <a:t>source: Governing equations; surface tension jump; CLS; split PPE</a:t>
             </a:r>
           </a:p>
         </p:txBody>
@@ -13694,7 +13694,7 @@
           <p:cNvPr id="23" name="">
             <a:extLst xmlns:a="http://schemas.openxmlformats.org/drawingml/2006/main">
               <a:ext uri="{FF2B5EF4-FFF2-40B4-BE49-F238E27FC236}">
-                <a16:creationId xmlns:a16="http://schemas.microsoft.com/office/drawing/2014/main" id="{830FDF60-D4F6-49AD-8556-EEDA346ABDDC}"/>
+                <a16:creationId xmlns:a16="http://schemas.microsoft.com/office/drawing/2014/main" id="{B26FC712-A0EE-4760-AAC2-6EB419219A4E}"/>
               </a:ext>
             </a:extLst>
           </p:cNvPr>
@@ -13756,7 +13756,7 @@
     </p:spTree>
     <p:extLst>
       <p:ext uri="{BB962C8B-B14F-4D97-AF65-F5344CB8AC3E}">
-        <p14:creationId xmlns:p14="http://schemas.microsoft.com/office/powerpoint/2010/main" val="335506152"/>
+        <p14:creationId xmlns:p14="http://schemas.microsoft.com/office/powerpoint/2010/main" val="125300163"/>
       </p:ext>
     </p:extLst>
   </p:cSld>
@@ -13780,7 +13780,7 @@
           <p:cNvPr id="1" name="">
             <a:extLst xmlns:a="http://schemas.openxmlformats.org/drawingml/2006/main">
               <a:ext uri="{FF2B5EF4-FFF2-40B4-BE49-F238E27FC236}">
-                <a16:creationId xmlns:a16="http://schemas.microsoft.com/office/drawing/2014/main" id="{C72CFFAC-C915-42C4-A26C-FD9B9B2421E8}"/>
+                <a16:creationId xmlns:a16="http://schemas.microsoft.com/office/drawing/2014/main" id="{FABD84B6-A43E-4B9F-9CBA-32B70E0B3F80}"/>
               </a:ext>
             </a:extLst>
           </p:cNvPr>
@@ -13815,7 +13815,7 @@
           <p:cNvPr id="2" name="">
             <a:extLst xmlns:a="http://schemas.openxmlformats.org/drawingml/2006/main">
               <a:ext uri="{FF2B5EF4-FFF2-40B4-BE49-F238E27FC236}">
-                <a16:creationId xmlns:a16="http://schemas.microsoft.com/office/drawing/2014/main" id="{81E13922-9E46-42B3-B0A4-11D7DCC76674}"/>
+                <a16:creationId xmlns:a16="http://schemas.microsoft.com/office/drawing/2014/main" id="{7F6B7766-CB3D-4AB7-82BA-9E0200BB7781}"/>
               </a:ext>
             </a:extLst>
           </p:cNvPr>
@@ -13850,7 +13850,7 @@
           <p:cNvPr id="3" name="">
             <a:extLst xmlns:a="http://schemas.openxmlformats.org/drawingml/2006/main">
               <a:ext uri="{FF2B5EF4-FFF2-40B4-BE49-F238E27FC236}">
-                <a16:creationId xmlns:a16="http://schemas.microsoft.com/office/drawing/2014/main" id="{1841785A-1769-4AD1-8947-CA01CBF977BE}"/>
+                <a16:creationId xmlns:a16="http://schemas.microsoft.com/office/drawing/2014/main" id="{D27E8547-430B-45BC-8817-003F4FA0934B}"/>
               </a:ext>
             </a:extLst>
           </p:cNvPr>
@@ -13904,7 +13904,7 @@
                 <a:ea typeface="Hiragino Sans"/>
                 <a:cs typeface="Hiragino Sans"/>
               </a:rPr>
-              <a:t>CCDファミリは、節点中心の高次性を面中心の保存形へ広げる</a:t>
+              <a:t>CCD -&gt; FCCD/UCCD6 が、この数値法の演算子コア</a:t>
             </a:r>
           </a:p>
         </p:txBody>
@@ -13914,7 +13914,7 @@
           <p:cNvPr id="4" name="">
             <a:extLst xmlns:a="http://schemas.openxmlformats.org/drawingml/2006/main">
               <a:ext uri="{FF2B5EF4-FFF2-40B4-BE49-F238E27FC236}">
-                <a16:creationId xmlns:a16="http://schemas.microsoft.com/office/drawing/2014/main" id="{49F7009D-0F69-4713-8C47-CF65685F6811}"/>
+                <a16:creationId xmlns:a16="http://schemas.microsoft.com/office/drawing/2014/main" id="{E8D2ECC9-49A4-4772-B7D4-4FDBB9BBE7E9}"/>
               </a:ext>
             </a:extLst>
           </p:cNvPr>
@@ -13968,7 +13968,7 @@
                 <a:ea typeface="Hiragino Sans"/>
                 <a:cs typeface="Hiragino Sans"/>
               </a:rPr>
-              <a:t>内点6次のCCDを起点に、DCCDで高波数を制御し、UCCD6とFCCDで運動量・界面フラックスを分担する。</a:t>
+              <a:t>CCDの高次微分を、FCCDの保存形face fluxとUCCD6の運動量対流へ展開する。DCCDは補助的な高波数制御に限定する。</a:t>
             </a:r>
           </a:p>
         </p:txBody>
@@ -13978,7 +13978,7 @@
           <p:cNvPr id="5" name="">
             <a:extLst xmlns:a="http://schemas.openxmlformats.org/drawingml/2006/main">
               <a:ext uri="{FF2B5EF4-FFF2-40B4-BE49-F238E27FC236}">
-                <a16:creationId xmlns:a16="http://schemas.microsoft.com/office/drawing/2014/main" id="{FAF2BBBE-075D-4B3C-B567-BA56FE2FEF0B}"/>
+                <a16:creationId xmlns:a16="http://schemas.microsoft.com/office/drawing/2014/main" id="{0AADC06D-9D3E-4BD0-85CA-B83ED01D6797}"/>
               </a:ext>
             </a:extLst>
           </p:cNvPr>
@@ -14011,7 +14011,7 @@
           <p:cNvPr id="6" name="">
             <a:extLst xmlns:a="http://schemas.openxmlformats.org/drawingml/2006/main">
               <a:ext uri="{FF2B5EF4-FFF2-40B4-BE49-F238E27FC236}">
-                <a16:creationId xmlns:a16="http://schemas.microsoft.com/office/drawing/2014/main" id="{914D45B5-67B8-442E-A790-448218E9BA7C}"/>
+                <a16:creationId xmlns:a16="http://schemas.microsoft.com/office/drawing/2014/main" id="{AF47BC59-27D0-4DCE-88BB-215D9C3719F9}"/>
               </a:ext>
             </a:extLst>
           </p:cNvPr>
@@ -14075,7 +14075,7 @@
           <p:cNvPr id="7" name="">
             <a:extLst xmlns:a="http://schemas.openxmlformats.org/drawingml/2006/main">
               <a:ext uri="{FF2B5EF4-FFF2-40B4-BE49-F238E27FC236}">
-                <a16:creationId xmlns:a16="http://schemas.microsoft.com/office/drawing/2014/main" id="{A5CA1D48-0DD1-4279-832A-A277CDBEBD25}"/>
+                <a16:creationId xmlns:a16="http://schemas.microsoft.com/office/drawing/2014/main" id="{20EBDC56-89FB-4BF6-897D-F13DB7D1CA52}"/>
               </a:ext>
             </a:extLst>
           </p:cNvPr>
@@ -14139,7 +14139,7 @@
           <p:cNvPr id="8" name="">
             <a:extLst xmlns:a="http://schemas.openxmlformats.org/drawingml/2006/main">
               <a:ext uri="{FF2B5EF4-FFF2-40B4-BE49-F238E27FC236}">
-                <a16:creationId xmlns:a16="http://schemas.microsoft.com/office/drawing/2014/main" id="{AE7C8581-B5EA-430F-B125-F80D8090ABDB}"/>
+                <a16:creationId xmlns:a16="http://schemas.microsoft.com/office/drawing/2014/main" id="{866C3681-7DD8-453A-B8E1-081F9B0B188D}"/>
               </a:ext>
             </a:extLst>
           </p:cNvPr>
@@ -14203,7 +14203,7 @@
           <p:cNvPr id="9" name="">
             <a:extLst xmlns:a="http://schemas.openxmlformats.org/drawingml/2006/main">
               <a:ext uri="{FF2B5EF4-FFF2-40B4-BE49-F238E27FC236}">
-                <a16:creationId xmlns:a16="http://schemas.microsoft.com/office/drawing/2014/main" id="{EDBA8220-7CE6-440D-A59E-453148404D1E}"/>
+                <a16:creationId xmlns:a16="http://schemas.microsoft.com/office/drawing/2014/main" id="{77406356-E1C7-440D-BD95-96E181D0446B}"/>
               </a:ext>
             </a:extLst>
           </p:cNvPr>
@@ -14236,7 +14236,7 @@
           <p:cNvPr id="10" name="">
             <a:extLst xmlns:a="http://schemas.openxmlformats.org/drawingml/2006/main">
               <a:ext uri="{FF2B5EF4-FFF2-40B4-BE49-F238E27FC236}">
-                <a16:creationId xmlns:a16="http://schemas.microsoft.com/office/drawing/2014/main" id="{0B74FB20-B348-4959-BC7C-6DE17EEECBB6}"/>
+                <a16:creationId xmlns:a16="http://schemas.microsoft.com/office/drawing/2014/main" id="{A7369F63-7D1E-48C9-8A10-5B0BAF5C90FF}"/>
               </a:ext>
             </a:extLst>
           </p:cNvPr>
@@ -14300,7 +14300,7 @@
           <p:cNvPr id="11" name="">
             <a:extLst xmlns:a="http://schemas.openxmlformats.org/drawingml/2006/main">
               <a:ext uri="{FF2B5EF4-FFF2-40B4-BE49-F238E27FC236}">
-                <a16:creationId xmlns:a16="http://schemas.microsoft.com/office/drawing/2014/main" id="{68A34722-5D35-4D85-BED4-D743C0DA0B00}"/>
+                <a16:creationId xmlns:a16="http://schemas.microsoft.com/office/drawing/2014/main" id="{74155F3D-FB54-4179-B53D-99210B60CBBB}"/>
               </a:ext>
             </a:extLst>
           </p:cNvPr>
@@ -14364,7 +14364,7 @@
           <p:cNvPr id="12" name="">
             <a:extLst xmlns:a="http://schemas.openxmlformats.org/drawingml/2006/main">
               <a:ext uri="{FF2B5EF4-FFF2-40B4-BE49-F238E27FC236}">
-                <a16:creationId xmlns:a16="http://schemas.microsoft.com/office/drawing/2014/main" id="{181C65ED-905F-4DED-9012-E0BCADC30074}"/>
+                <a16:creationId xmlns:a16="http://schemas.microsoft.com/office/drawing/2014/main" id="{B2123A81-187D-43B5-8B1D-0E2CCC564804}"/>
               </a:ext>
             </a:extLst>
           </p:cNvPr>
@@ -14428,7 +14428,7 @@
           <p:cNvPr id="13" name="">
             <a:extLst xmlns:a="http://schemas.openxmlformats.org/drawingml/2006/main">
               <a:ext uri="{FF2B5EF4-FFF2-40B4-BE49-F238E27FC236}">
-                <a16:creationId xmlns:a16="http://schemas.microsoft.com/office/drawing/2014/main" id="{C461A3A2-A1D0-49B3-A4B5-84CCE86CEFC4}"/>
+                <a16:creationId xmlns:a16="http://schemas.microsoft.com/office/drawing/2014/main" id="{EB7BED5C-9B95-44DB-B5DB-455414A039E9}"/>
               </a:ext>
             </a:extLst>
           </p:cNvPr>
@@ -14461,7 +14461,7 @@
           <p:cNvPr id="14" name="">
             <a:extLst xmlns:a="http://schemas.openxmlformats.org/drawingml/2006/main">
               <a:ext uri="{FF2B5EF4-FFF2-40B4-BE49-F238E27FC236}">
-                <a16:creationId xmlns:a16="http://schemas.microsoft.com/office/drawing/2014/main" id="{6FFD13E4-82B2-4CF2-9C88-C04689CD9A96}"/>
+                <a16:creationId xmlns:a16="http://schemas.microsoft.com/office/drawing/2014/main" id="{B31A7CBD-9F91-4A06-BAAD-FBFE292E36C7}"/>
               </a:ext>
             </a:extLst>
           </p:cNvPr>
@@ -14525,7 +14525,7 @@
           <p:cNvPr id="15" name="">
             <a:extLst xmlns:a="http://schemas.openxmlformats.org/drawingml/2006/main">
               <a:ext uri="{FF2B5EF4-FFF2-40B4-BE49-F238E27FC236}">
-                <a16:creationId xmlns:a16="http://schemas.microsoft.com/office/drawing/2014/main" id="{4629E4F9-2111-4E84-9191-B29EF6571E4B}"/>
+                <a16:creationId xmlns:a16="http://schemas.microsoft.com/office/drawing/2014/main" id="{E6653405-C42D-42CF-8575-0A142AF42F8E}"/>
               </a:ext>
             </a:extLst>
           </p:cNvPr>
@@ -14589,7 +14589,7 @@
           <p:cNvPr id="16" name="">
             <a:extLst xmlns:a="http://schemas.openxmlformats.org/drawingml/2006/main">
               <a:ext uri="{FF2B5EF4-FFF2-40B4-BE49-F238E27FC236}">
-                <a16:creationId xmlns:a16="http://schemas.microsoft.com/office/drawing/2014/main" id="{152AD671-B7C0-4B82-BC2A-92A201286297}"/>
+                <a16:creationId xmlns:a16="http://schemas.microsoft.com/office/drawing/2014/main" id="{4B2D0612-A18D-4B99-9067-73878A374066}"/>
               </a:ext>
             </a:extLst>
           </p:cNvPr>
@@ -14653,7 +14653,7 @@
           <p:cNvPr id="17" name="">
             <a:extLst xmlns:a="http://schemas.openxmlformats.org/drawingml/2006/main">
               <a:ext uri="{FF2B5EF4-FFF2-40B4-BE49-F238E27FC236}">
-                <a16:creationId xmlns:a16="http://schemas.microsoft.com/office/drawing/2014/main" id="{F37ADF34-8423-420C-A2C1-49645740D2D5}"/>
+                <a16:creationId xmlns:a16="http://schemas.microsoft.com/office/drawing/2014/main" id="{98E94FDD-0F04-45C1-B6EB-63900C990C00}"/>
               </a:ext>
             </a:extLst>
           </p:cNvPr>
@@ -14686,7 +14686,7 @@
           <p:cNvPr id="18" name="">
             <a:extLst xmlns:a="http://schemas.openxmlformats.org/drawingml/2006/main">
               <a:ext uri="{FF2B5EF4-FFF2-40B4-BE49-F238E27FC236}">
-                <a16:creationId xmlns:a16="http://schemas.microsoft.com/office/drawing/2014/main" id="{38C3AFE3-2060-4EA7-BC4A-7744033DF7CD}"/>
+                <a16:creationId xmlns:a16="http://schemas.microsoft.com/office/drawing/2014/main" id="{9E3F7331-751F-4406-AE6F-509A0A192AEF}"/>
               </a:ext>
             </a:extLst>
           </p:cNvPr>
@@ -14750,7 +14750,7 @@
           <p:cNvPr id="19" name="">
             <a:extLst xmlns:a="http://schemas.openxmlformats.org/drawingml/2006/main">
               <a:ext uri="{FF2B5EF4-FFF2-40B4-BE49-F238E27FC236}">
-                <a16:creationId xmlns:a16="http://schemas.microsoft.com/office/drawing/2014/main" id="{B2906601-B0C9-4157-9772-CA2B9120759C}"/>
+                <a16:creationId xmlns:a16="http://schemas.microsoft.com/office/drawing/2014/main" id="{8AF97F13-F72C-4EC3-A03F-C2220D6636FF}"/>
               </a:ext>
             </a:extLst>
           </p:cNvPr>
@@ -14814,7 +14814,7 @@
           <p:cNvPr id="20" name="">
             <a:extLst xmlns:a="http://schemas.openxmlformats.org/drawingml/2006/main">
               <a:ext uri="{FF2B5EF4-FFF2-40B4-BE49-F238E27FC236}">
-                <a16:creationId xmlns:a16="http://schemas.microsoft.com/office/drawing/2014/main" id="{99A52100-1F08-49F9-8E3C-6DEE5326DCD7}"/>
+                <a16:creationId xmlns:a16="http://schemas.microsoft.com/office/drawing/2014/main" id="{244BADED-431F-45C9-8321-0764E9D829B5}"/>
               </a:ext>
             </a:extLst>
           </p:cNvPr>
@@ -14882,7 +14882,7 @@
           <p:nvPr/>
         </p:nvPicPr>
         <p:blipFill>
-          <a:blip xmlns:r="http://schemas.openxmlformats.org/officeDocument/2006/relationships" xmlns:a="http://schemas.openxmlformats.org/drawingml/2006/main" r:embed="Rc5c9b427ecfe410e"/>
+          <a:blip xmlns:r="http://schemas.openxmlformats.org/officeDocument/2006/relationships" xmlns:a="http://schemas.openxmlformats.org/drawingml/2006/main" r:embed="Ra16ed79f27b94653"/>
           <a:stretch xmlns:a="http://schemas.openxmlformats.org/drawingml/2006/main"/>
         </p:blipFill>
         <p:spPr>
@@ -14900,7 +14900,7 @@
           <p:cNvPr id="22" name="">
             <a:extLst xmlns:a="http://schemas.openxmlformats.org/drawingml/2006/main">
               <a:ext uri="{FF2B5EF4-FFF2-40B4-BE49-F238E27FC236}">
-                <a16:creationId xmlns:a16="http://schemas.microsoft.com/office/drawing/2014/main" id="{2C1A2094-CB24-4A6F-BCAC-81E881B13257}"/>
+                <a16:creationId xmlns:a16="http://schemas.microsoft.com/office/drawing/2014/main" id="{F3C303A5-DA05-4509-8914-9A2E772E6B84}"/>
               </a:ext>
             </a:extLst>
           </p:cNvPr>
@@ -14935,7 +14935,7 @@
           <p:cNvPr id="23" name="">
             <a:extLst xmlns:a="http://schemas.openxmlformats.org/drawingml/2006/main">
               <a:ext uri="{FF2B5EF4-FFF2-40B4-BE49-F238E27FC236}">
-                <a16:creationId xmlns:a16="http://schemas.microsoft.com/office/drawing/2014/main" id="{1F88B34F-7ACE-4590-9C38-9933F4D3008F}"/>
+                <a16:creationId xmlns:a16="http://schemas.microsoft.com/office/drawing/2014/main" id="{B9171236-9047-4D7E-9A08-186982380F84}"/>
               </a:ext>
             </a:extLst>
           </p:cNvPr>
@@ -14999,7 +14999,7 @@
           <p:cNvPr id="24" name="">
             <a:extLst xmlns:a="http://schemas.openxmlformats.org/drawingml/2006/main">
               <a:ext uri="{FF2B5EF4-FFF2-40B4-BE49-F238E27FC236}">
-                <a16:creationId xmlns:a16="http://schemas.microsoft.com/office/drawing/2014/main" id="{AA359727-A834-4097-985C-8B495F4DA2A0}"/>
+                <a16:creationId xmlns:a16="http://schemas.microsoft.com/office/drawing/2014/main" id="{F6B068C0-B5FF-482F-A4B2-615E6DAA7F65}"/>
               </a:ext>
             </a:extLst>
           </p:cNvPr>
@@ -15063,7 +15063,7 @@
           <p:cNvPr id="25" name="">
             <a:extLst xmlns:a="http://schemas.openxmlformats.org/drawingml/2006/main">
               <a:ext uri="{FF2B5EF4-FFF2-40B4-BE49-F238E27FC236}">
-                <a16:creationId xmlns:a16="http://schemas.microsoft.com/office/drawing/2014/main" id="{257E4667-A1B6-4C51-B349-F96247094CC1}"/>
+                <a16:creationId xmlns:a16="http://schemas.microsoft.com/office/drawing/2014/main" id="{92D7AE53-88CE-4998-8F63-6D08CF525444}"/>
               </a:ext>
             </a:extLst>
           </p:cNvPr>
@@ -15098,7 +15098,7 @@
           <p:cNvPr id="26" name="">
             <a:extLst xmlns:a="http://schemas.openxmlformats.org/drawingml/2006/main">
               <a:ext uri="{FF2B5EF4-FFF2-40B4-BE49-F238E27FC236}">
-                <a16:creationId xmlns:a16="http://schemas.microsoft.com/office/drawing/2014/main" id="{A33B032C-EF3C-42D2-9AB9-CBDF31F5B809}"/>
+                <a16:creationId xmlns:a16="http://schemas.microsoft.com/office/drawing/2014/main" id="{2DEC3CF9-23F0-4744-B4AA-F4CD6F99E26D}"/>
               </a:ext>
             </a:extLst>
           </p:cNvPr>
@@ -15152,7 +15152,7 @@
                 <a:ea typeface="Hiragino Sans"/>
                 <a:cs typeface="Hiragino Sans"/>
               </a:rPr>
-              <a:t>source: paper/sections/04_ccd.tex; 04c_dccd_derivation.tex; 04d_uccd6.tex; 04e_fccd.tex</a:t>
+              <a:t>source: CCD, DCCD, UCCD6, and FCCD operator derivations</a:t>
             </a:r>
           </a:p>
         </p:txBody>
@@ -15162,7 +15162,7 @@
           <p:cNvPr id="27" name="">
             <a:extLst xmlns:a="http://schemas.openxmlformats.org/drawingml/2006/main">
               <a:ext uri="{FF2B5EF4-FFF2-40B4-BE49-F238E27FC236}">
-                <a16:creationId xmlns:a16="http://schemas.microsoft.com/office/drawing/2014/main" id="{3EA32604-4B43-4086-9A92-B7C5D2CB0694}"/>
+                <a16:creationId xmlns:a16="http://schemas.microsoft.com/office/drawing/2014/main" id="{E508CC40-E9E0-41AF-BBAD-DAF653196B22}"/>
               </a:ext>
             </a:extLst>
           </p:cNvPr>
@@ -15224,7 +15224,7 @@
     </p:spTree>
     <p:extLst>
       <p:ext uri="{BB962C8B-B14F-4D97-AF65-F5344CB8AC3E}">
-        <p14:creationId xmlns:p14="http://schemas.microsoft.com/office/powerpoint/2010/main" val="1360027287"/>
+        <p14:creationId xmlns:p14="http://schemas.microsoft.com/office/powerpoint/2010/main" val="1437372538"/>
       </p:ext>
     </p:extLst>
   </p:cSld>
@@ -15248,7 +15248,7 @@
           <p:cNvPr id="1" name="">
             <a:extLst xmlns:a="http://schemas.openxmlformats.org/drawingml/2006/main">
               <a:ext uri="{FF2B5EF4-FFF2-40B4-BE49-F238E27FC236}">
-                <a16:creationId xmlns:a16="http://schemas.microsoft.com/office/drawing/2014/main" id="{1EFD5AFE-6176-4345-86A3-B8BD3DF11510}"/>
+                <a16:creationId xmlns:a16="http://schemas.microsoft.com/office/drawing/2014/main" id="{02C6E239-EAB3-47E0-9B6A-C7BC235B3825}"/>
               </a:ext>
             </a:extLst>
           </p:cNvPr>
@@ -15283,7 +15283,7 @@
           <p:cNvPr id="2" name="">
             <a:extLst xmlns:a="http://schemas.openxmlformats.org/drawingml/2006/main">
               <a:ext uri="{FF2B5EF4-FFF2-40B4-BE49-F238E27FC236}">
-                <a16:creationId xmlns:a16="http://schemas.microsoft.com/office/drawing/2014/main" id="{71DA4F59-F3DE-4A2B-AF00-984666C146FA}"/>
+                <a16:creationId xmlns:a16="http://schemas.microsoft.com/office/drawing/2014/main" id="{D91F8D9C-4CDE-488F-BD87-D8B280C7F4F5}"/>
               </a:ext>
             </a:extLst>
           </p:cNvPr>
@@ -15318,7 +15318,7 @@
           <p:cNvPr id="3" name="">
             <a:extLst xmlns:a="http://schemas.openxmlformats.org/drawingml/2006/main">
               <a:ext uri="{FF2B5EF4-FFF2-40B4-BE49-F238E27FC236}">
-                <a16:creationId xmlns:a16="http://schemas.microsoft.com/office/drawing/2014/main" id="{51D34152-BC5C-4BDC-8A91-33600CDFF905}"/>
+                <a16:creationId xmlns:a16="http://schemas.microsoft.com/office/drawing/2014/main" id="{96C94659-21C8-4933-8D62-A9A450DC07F3}"/>
               </a:ext>
             </a:extLst>
           </p:cNvPr>
@@ -15382,7 +15382,7 @@
           <p:cNvPr id="4" name="">
             <a:extLst xmlns:a="http://schemas.openxmlformats.org/drawingml/2006/main">
               <a:ext uri="{FF2B5EF4-FFF2-40B4-BE49-F238E27FC236}">
-                <a16:creationId xmlns:a16="http://schemas.microsoft.com/office/drawing/2014/main" id="{E3DADD5B-BD19-43B7-B2B4-B85EBF777126}"/>
+                <a16:creationId xmlns:a16="http://schemas.microsoft.com/office/drawing/2014/main" id="{BC2D9CE6-0B94-4A36-9646-EA4F7047484B}"/>
               </a:ext>
             </a:extLst>
           </p:cNvPr>
@@ -15446,7 +15446,7 @@
           <p:cNvPr id="5" name="">
             <a:extLst xmlns:a="http://schemas.openxmlformats.org/drawingml/2006/main">
               <a:ext uri="{FF2B5EF4-FFF2-40B4-BE49-F238E27FC236}">
-                <a16:creationId xmlns:a16="http://schemas.microsoft.com/office/drawing/2014/main" id="{349BC4BD-1FBA-4084-AC8E-6FA8FF2C0CE4}"/>
+                <a16:creationId xmlns:a16="http://schemas.microsoft.com/office/drawing/2014/main" id="{AD3FE67E-C935-423D-98BE-DE95B9BFAE65}"/>
               </a:ext>
             </a:extLst>
           </p:cNvPr>
@@ -15479,7 +15479,7 @@
           <p:cNvPr id="6" name="">
             <a:extLst xmlns:a="http://schemas.openxmlformats.org/drawingml/2006/main">
               <a:ext uri="{FF2B5EF4-FFF2-40B4-BE49-F238E27FC236}">
-                <a16:creationId xmlns:a16="http://schemas.microsoft.com/office/drawing/2014/main" id="{2C050A8F-70B3-4FB8-B6B6-5DA8FFD3B56D}"/>
+                <a16:creationId xmlns:a16="http://schemas.microsoft.com/office/drawing/2014/main" id="{45AE8153-56A6-4FC8-B9CA-B1FCC43176A1}"/>
               </a:ext>
             </a:extLst>
           </p:cNvPr>
@@ -15543,7 +15543,7 @@
           <p:cNvPr id="7" name="">
             <a:extLst xmlns:a="http://schemas.openxmlformats.org/drawingml/2006/main">
               <a:ext uri="{FF2B5EF4-FFF2-40B4-BE49-F238E27FC236}">
-                <a16:creationId xmlns:a16="http://schemas.microsoft.com/office/drawing/2014/main" id="{CDC60A53-07DB-4D81-A62B-39365F087A3C}"/>
+                <a16:creationId xmlns:a16="http://schemas.microsoft.com/office/drawing/2014/main" id="{B5C123FC-045A-4D33-B5C0-5D3EE95C00A2}"/>
               </a:ext>
             </a:extLst>
           </p:cNvPr>
@@ -15607,7 +15607,7 @@
           <p:cNvPr id="8" name="">
             <a:extLst xmlns:a="http://schemas.openxmlformats.org/drawingml/2006/main">
               <a:ext uri="{FF2B5EF4-FFF2-40B4-BE49-F238E27FC236}">
-                <a16:creationId xmlns:a16="http://schemas.microsoft.com/office/drawing/2014/main" id="{2471CE9E-A69D-4142-84FB-6C4B93497F4E}"/>
+                <a16:creationId xmlns:a16="http://schemas.microsoft.com/office/drawing/2014/main" id="{492F2C73-8CBE-4CDD-B61B-BAA8ECAE9970}"/>
               </a:ext>
             </a:extLst>
           </p:cNvPr>
@@ -15640,7 +15640,7 @@
           <p:cNvPr id="9" name="">
             <a:extLst xmlns:a="http://schemas.openxmlformats.org/drawingml/2006/main">
               <a:ext uri="{FF2B5EF4-FFF2-40B4-BE49-F238E27FC236}">
-                <a16:creationId xmlns:a16="http://schemas.microsoft.com/office/drawing/2014/main" id="{B7E801EE-220F-4FF4-8E97-54E43D6ECD32}"/>
+                <a16:creationId xmlns:a16="http://schemas.microsoft.com/office/drawing/2014/main" id="{8859DC0D-C5AA-4AAA-8A08-54EA07141014}"/>
               </a:ext>
             </a:extLst>
           </p:cNvPr>
@@ -15704,7 +15704,7 @@
           <p:cNvPr id="10" name="">
             <a:extLst xmlns:a="http://schemas.openxmlformats.org/drawingml/2006/main">
               <a:ext uri="{FF2B5EF4-FFF2-40B4-BE49-F238E27FC236}">
-                <a16:creationId xmlns:a16="http://schemas.microsoft.com/office/drawing/2014/main" id="{741ECA38-2FDC-4BA7-B538-3AF8482F24EB}"/>
+                <a16:creationId xmlns:a16="http://schemas.microsoft.com/office/drawing/2014/main" id="{4FFE103F-BDFB-4966-A75C-CF9DEC6675B1}"/>
               </a:ext>
             </a:extLst>
           </p:cNvPr>
@@ -15768,7 +15768,7 @@
           <p:cNvPr id="11" name="">
             <a:extLst xmlns:a="http://schemas.openxmlformats.org/drawingml/2006/main">
               <a:ext uri="{FF2B5EF4-FFF2-40B4-BE49-F238E27FC236}">
-                <a16:creationId xmlns:a16="http://schemas.microsoft.com/office/drawing/2014/main" id="{D3AF08B2-24ED-4697-91A7-67BBF6C0AA94}"/>
+                <a16:creationId xmlns:a16="http://schemas.microsoft.com/office/drawing/2014/main" id="{04E0B43D-281A-46A3-956C-04D01D5AED0A}"/>
               </a:ext>
             </a:extLst>
           </p:cNvPr>
@@ -15801,7 +15801,7 @@
           <p:cNvPr id="12" name="">
             <a:extLst xmlns:a="http://schemas.openxmlformats.org/drawingml/2006/main">
               <a:ext uri="{FF2B5EF4-FFF2-40B4-BE49-F238E27FC236}">
-                <a16:creationId xmlns:a16="http://schemas.microsoft.com/office/drawing/2014/main" id="{E7E750B3-1EA5-4A38-B483-AB21FD736469}"/>
+                <a16:creationId xmlns:a16="http://schemas.microsoft.com/office/drawing/2014/main" id="{282EAC85-0F33-4A4C-B122-1786E9A91B14}"/>
               </a:ext>
             </a:extLst>
           </p:cNvPr>
@@ -15865,7 +15865,7 @@
           <p:cNvPr id="13" name="">
             <a:extLst xmlns:a="http://schemas.openxmlformats.org/drawingml/2006/main">
               <a:ext uri="{FF2B5EF4-FFF2-40B4-BE49-F238E27FC236}">
-                <a16:creationId xmlns:a16="http://schemas.microsoft.com/office/drawing/2014/main" id="{3F24D49F-958C-4396-A72A-8F630E938C9D}"/>
+                <a16:creationId xmlns:a16="http://schemas.microsoft.com/office/drawing/2014/main" id="{D36F310F-4FCC-4700-9383-F6CCC551C67E}"/>
               </a:ext>
             </a:extLst>
           </p:cNvPr>
@@ -15929,7 +15929,7 @@
           <p:cNvPr id="14" name="">
             <a:extLst xmlns:a="http://schemas.openxmlformats.org/drawingml/2006/main">
               <a:ext uri="{FF2B5EF4-FFF2-40B4-BE49-F238E27FC236}">
-                <a16:creationId xmlns:a16="http://schemas.microsoft.com/office/drawing/2014/main" id="{443C50F5-7F72-4014-8FD4-B329EB7D313E}"/>
+                <a16:creationId xmlns:a16="http://schemas.microsoft.com/office/drawing/2014/main" id="{8D16E643-68F4-488A-8594-DE39A0A4FF55}"/>
               </a:ext>
             </a:extLst>
           </p:cNvPr>
@@ -15962,7 +15962,7 @@
           <p:cNvPr id="15" name="">
             <a:extLst xmlns:a="http://schemas.openxmlformats.org/drawingml/2006/main">
               <a:ext uri="{FF2B5EF4-FFF2-40B4-BE49-F238E27FC236}">
-                <a16:creationId xmlns:a16="http://schemas.microsoft.com/office/drawing/2014/main" id="{65DCC711-8976-4A60-BA25-2450C4CF304E}"/>
+                <a16:creationId xmlns:a16="http://schemas.microsoft.com/office/drawing/2014/main" id="{0E4F8E9E-D1B8-48F2-B7E1-6F706B8B0D69}"/>
               </a:ext>
             </a:extLst>
           </p:cNvPr>
@@ -16026,7 +16026,7 @@
           <p:cNvPr id="16" name="">
             <a:extLst xmlns:a="http://schemas.openxmlformats.org/drawingml/2006/main">
               <a:ext uri="{FF2B5EF4-FFF2-40B4-BE49-F238E27FC236}">
-                <a16:creationId xmlns:a16="http://schemas.microsoft.com/office/drawing/2014/main" id="{14B03BDA-F4C9-452C-A461-540F128B5BD3}"/>
+                <a16:creationId xmlns:a16="http://schemas.microsoft.com/office/drawing/2014/main" id="{45CD43EB-7917-4D4B-89F2-88E2F38CE22C}"/>
               </a:ext>
             </a:extLst>
           </p:cNvPr>
@@ -16090,7 +16090,7 @@
           <p:cNvPr id="17" name="">
             <a:extLst xmlns:a="http://schemas.openxmlformats.org/drawingml/2006/main">
               <a:ext uri="{FF2B5EF4-FFF2-40B4-BE49-F238E27FC236}">
-                <a16:creationId xmlns:a16="http://schemas.microsoft.com/office/drawing/2014/main" id="{0C682F11-C316-4E38-8864-56B5E3FEF4AF}"/>
+                <a16:creationId xmlns:a16="http://schemas.microsoft.com/office/drawing/2014/main" id="{1DB30326-6674-41F2-B92A-6E41DB78482E}"/>
               </a:ext>
             </a:extLst>
           </p:cNvPr>
@@ -16123,7 +16123,7 @@
           <p:cNvPr id="18" name="">
             <a:extLst xmlns:a="http://schemas.openxmlformats.org/drawingml/2006/main">
               <a:ext uri="{FF2B5EF4-FFF2-40B4-BE49-F238E27FC236}">
-                <a16:creationId xmlns:a16="http://schemas.microsoft.com/office/drawing/2014/main" id="{81B4C6AE-0D57-42ED-BBB6-965BE9D78ADE}"/>
+                <a16:creationId xmlns:a16="http://schemas.microsoft.com/office/drawing/2014/main" id="{C43A099B-4738-4879-A31E-8053BE691E23}"/>
               </a:ext>
             </a:extLst>
           </p:cNvPr>
@@ -16187,7 +16187,7 @@
           <p:cNvPr id="19" name="">
             <a:extLst xmlns:a="http://schemas.openxmlformats.org/drawingml/2006/main">
               <a:ext uri="{FF2B5EF4-FFF2-40B4-BE49-F238E27FC236}">
-                <a16:creationId xmlns:a16="http://schemas.microsoft.com/office/drawing/2014/main" id="{D6A55647-86FB-4CD6-8ECF-2911220792D5}"/>
+                <a16:creationId xmlns:a16="http://schemas.microsoft.com/office/drawing/2014/main" id="{2C4D0ACB-5FBF-4DDD-AE53-A7A1260373DF}"/>
               </a:ext>
             </a:extLst>
           </p:cNvPr>
@@ -16251,7 +16251,7 @@
           <p:cNvPr id="20" name="">
             <a:extLst xmlns:a="http://schemas.openxmlformats.org/drawingml/2006/main">
               <a:ext uri="{FF2B5EF4-FFF2-40B4-BE49-F238E27FC236}">
-                <a16:creationId xmlns:a16="http://schemas.microsoft.com/office/drawing/2014/main" id="{C6AD8F71-00E0-4388-9CBF-B6666F26E3CB}"/>
+                <a16:creationId xmlns:a16="http://schemas.microsoft.com/office/drawing/2014/main" id="{8F93907E-6382-414D-BAB5-5DAA7729024E}"/>
               </a:ext>
             </a:extLst>
           </p:cNvPr>
@@ -16284,7 +16284,7 @@
           <p:cNvPr id="21" name="">
             <a:extLst xmlns:a="http://schemas.openxmlformats.org/drawingml/2006/main">
               <a:ext uri="{FF2B5EF4-FFF2-40B4-BE49-F238E27FC236}">
-                <a16:creationId xmlns:a16="http://schemas.microsoft.com/office/drawing/2014/main" id="{317BDE79-B577-4729-B4A4-BFFA5DCDE0AC}"/>
+                <a16:creationId xmlns:a16="http://schemas.microsoft.com/office/drawing/2014/main" id="{8DBA770F-7B23-4E69-AC3E-5BCC8924F432}"/>
               </a:ext>
             </a:extLst>
           </p:cNvPr>
@@ -16348,7 +16348,7 @@
           <p:cNvPr id="22" name="">
             <a:extLst xmlns:a="http://schemas.openxmlformats.org/drawingml/2006/main">
               <a:ext uri="{FF2B5EF4-FFF2-40B4-BE49-F238E27FC236}">
-                <a16:creationId xmlns:a16="http://schemas.microsoft.com/office/drawing/2014/main" id="{0C66FC56-D2C8-49E7-89E2-8736CB00306A}"/>
+                <a16:creationId xmlns:a16="http://schemas.microsoft.com/office/drawing/2014/main" id="{A41CEC4C-13E6-4E52-B11F-57294604E42E}"/>
               </a:ext>
             </a:extLst>
           </p:cNvPr>
@@ -16383,7 +16383,7 @@
           <p:cNvPr id="23" name="">
             <a:extLst xmlns:a="http://schemas.openxmlformats.org/drawingml/2006/main">
               <a:ext uri="{FF2B5EF4-FFF2-40B4-BE49-F238E27FC236}">
-                <a16:creationId xmlns:a16="http://schemas.microsoft.com/office/drawing/2014/main" id="{8057E15E-C0EA-4911-A49E-E50A1A18DB82}"/>
+                <a16:creationId xmlns:a16="http://schemas.microsoft.com/office/drawing/2014/main" id="{17831D49-0798-499C-A68D-91236EFC92CC}"/>
               </a:ext>
             </a:extLst>
           </p:cNvPr>
@@ -16447,7 +16447,7 @@
           <p:cNvPr id="24" name="">
             <a:extLst xmlns:a="http://schemas.openxmlformats.org/drawingml/2006/main">
               <a:ext uri="{FF2B5EF4-FFF2-40B4-BE49-F238E27FC236}">
-                <a16:creationId xmlns:a16="http://schemas.microsoft.com/office/drawing/2014/main" id="{5DAAB7B9-DF12-48BB-B66E-14185B9886E0}"/>
+                <a16:creationId xmlns:a16="http://schemas.microsoft.com/office/drawing/2014/main" id="{821F02F8-C618-4528-A1B3-FC188ECE806F}"/>
               </a:ext>
             </a:extLst>
           </p:cNvPr>
@@ -16482,7 +16482,7 @@
           <p:cNvPr id="25" name="">
             <a:extLst xmlns:a="http://schemas.openxmlformats.org/drawingml/2006/main">
               <a:ext uri="{FF2B5EF4-FFF2-40B4-BE49-F238E27FC236}">
-                <a16:creationId xmlns:a16="http://schemas.microsoft.com/office/drawing/2014/main" id="{451675FA-22E3-493D-9ED8-3D4773F5174C}"/>
+                <a16:creationId xmlns:a16="http://schemas.microsoft.com/office/drawing/2014/main" id="{0783C16C-8DCC-4C9B-89CD-3090854182A0}"/>
               </a:ext>
             </a:extLst>
           </p:cNvPr>
@@ -16536,7 +16536,7 @@
                 <a:ea typeface="Hiragino Sans"/>
                 <a:cs typeface="Hiragino Sans"/>
               </a:rPr>
-              <a:t>source: paper/sections/03b_cls_transport.tex; 03d_ridge_eikonal.tex; 05b_cls_stages.tex; 12_component_verification.tex</a:t>
+              <a:t>source: CLS transport; Ridge-Eikonal; CLS stages; component verification</a:t>
             </a:r>
           </a:p>
         </p:txBody>
@@ -16546,7 +16546,7 @@
           <p:cNvPr id="26" name="">
             <a:extLst xmlns:a="http://schemas.openxmlformats.org/drawingml/2006/main">
               <a:ext uri="{FF2B5EF4-FFF2-40B4-BE49-F238E27FC236}">
-                <a16:creationId xmlns:a16="http://schemas.microsoft.com/office/drawing/2014/main" id="{8F364D84-A248-42B7-9E70-3C0C957A3CA1}"/>
+                <a16:creationId xmlns:a16="http://schemas.microsoft.com/office/drawing/2014/main" id="{C95B7869-70B8-4B21-80D5-D02BC12CEDF4}"/>
               </a:ext>
             </a:extLst>
           </p:cNvPr>
@@ -16608,7 +16608,7 @@
     </p:spTree>
     <p:extLst>
       <p:ext uri="{BB962C8B-B14F-4D97-AF65-F5344CB8AC3E}">
-        <p14:creationId xmlns:p14="http://schemas.microsoft.com/office/powerpoint/2010/main" val="1106682885"/>
+        <p14:creationId xmlns:p14="http://schemas.microsoft.com/office/powerpoint/2010/main" val="890915279"/>
       </p:ext>
     </p:extLst>
   </p:cSld>
@@ -16632,7 +16632,7 @@
           <p:cNvPr id="1" name="">
             <a:extLst xmlns:a="http://schemas.openxmlformats.org/drawingml/2006/main">
               <a:ext uri="{FF2B5EF4-FFF2-40B4-BE49-F238E27FC236}">
-                <a16:creationId xmlns:a16="http://schemas.microsoft.com/office/drawing/2014/main" id="{DE74FF0B-F59C-4906-B9DD-E1430A5A8158}"/>
+                <a16:creationId xmlns:a16="http://schemas.microsoft.com/office/drawing/2014/main" id="{9250F09E-82A2-4785-A508-78442C14DD6B}"/>
               </a:ext>
             </a:extLst>
           </p:cNvPr>
@@ -16667,7 +16667,7 @@
           <p:cNvPr id="2" name="">
             <a:extLst xmlns:a="http://schemas.openxmlformats.org/drawingml/2006/main">
               <a:ext uri="{FF2B5EF4-FFF2-40B4-BE49-F238E27FC236}">
-                <a16:creationId xmlns:a16="http://schemas.microsoft.com/office/drawing/2014/main" id="{F4FCAC7C-FF33-4037-8415-80FF5644AF31}"/>
+                <a16:creationId xmlns:a16="http://schemas.microsoft.com/office/drawing/2014/main" id="{A3CFC52B-1161-44A6-AC75-43141C420A2E}"/>
               </a:ext>
             </a:extLst>
           </p:cNvPr>
@@ -16702,7 +16702,7 @@
           <p:cNvPr id="3" name="">
             <a:extLst xmlns:a="http://schemas.openxmlformats.org/drawingml/2006/main">
               <a:ext uri="{FF2B5EF4-FFF2-40B4-BE49-F238E27FC236}">
-                <a16:creationId xmlns:a16="http://schemas.microsoft.com/office/drawing/2014/main" id="{76CDA600-BBBF-4176-BCA2-8ADFDCB89FC9}"/>
+                <a16:creationId xmlns:a16="http://schemas.microsoft.com/office/drawing/2014/main" id="{B1CC1F7F-F98E-4746-B69A-4B8039279839}"/>
               </a:ext>
             </a:extLst>
           </p:cNvPr>
@@ -16766,7 +16766,7 @@
           <p:cNvPr id="4" name="">
             <a:extLst xmlns:a="http://schemas.openxmlformats.org/drawingml/2006/main">
               <a:ext uri="{FF2B5EF4-FFF2-40B4-BE49-F238E27FC236}">
-                <a16:creationId xmlns:a16="http://schemas.microsoft.com/office/drawing/2014/main" id="{929EE222-44BE-4DEB-B695-A1363EEC789E}"/>
+                <a16:creationId xmlns:a16="http://schemas.microsoft.com/office/drawing/2014/main" id="{6FDF7010-A92A-42DB-83B9-11589895DEA2}"/>
               </a:ext>
             </a:extLst>
           </p:cNvPr>
@@ -16830,7 +16830,7 @@
           <p:cNvPr id="5" name="">
             <a:extLst xmlns:a="http://schemas.openxmlformats.org/drawingml/2006/main">
               <a:ext uri="{FF2B5EF4-FFF2-40B4-BE49-F238E27FC236}">
-                <a16:creationId xmlns:a16="http://schemas.microsoft.com/office/drawing/2014/main" id="{105DA11F-FA47-48D3-A62C-05CE4180BB24}"/>
+                <a16:creationId xmlns:a16="http://schemas.microsoft.com/office/drawing/2014/main" id="{5AA9537C-C81B-40B0-A880-96E6014FAAB1}"/>
               </a:ext>
             </a:extLst>
           </p:cNvPr>
@@ -16863,7 +16863,7 @@
           <p:cNvPr id="6" name="">
             <a:extLst xmlns:a="http://schemas.openxmlformats.org/drawingml/2006/main">
               <a:ext uri="{FF2B5EF4-FFF2-40B4-BE49-F238E27FC236}">
-                <a16:creationId xmlns:a16="http://schemas.microsoft.com/office/drawing/2014/main" id="{DA899190-8E56-45CC-917C-2F4B75EDBCCE}"/>
+                <a16:creationId xmlns:a16="http://schemas.microsoft.com/office/drawing/2014/main" id="{DD96914F-ABEE-4E2E-BEA8-26D058CC4F36}"/>
               </a:ext>
             </a:extLst>
           </p:cNvPr>
@@ -16927,7 +16927,7 @@
           <p:cNvPr id="7" name="">
             <a:extLst xmlns:a="http://schemas.openxmlformats.org/drawingml/2006/main">
               <a:ext uri="{FF2B5EF4-FFF2-40B4-BE49-F238E27FC236}">
-                <a16:creationId xmlns:a16="http://schemas.microsoft.com/office/drawing/2014/main" id="{F8D85111-2D59-4EFA-B2DC-35F70C92835A}"/>
+                <a16:creationId xmlns:a16="http://schemas.microsoft.com/office/drawing/2014/main" id="{02D67C75-12B1-47D8-ADC7-FEE3C5306497}"/>
               </a:ext>
             </a:extLst>
           </p:cNvPr>
@@ -16991,7 +16991,7 @@
           <p:cNvPr id="8" name="">
             <a:extLst xmlns:a="http://schemas.openxmlformats.org/drawingml/2006/main">
               <a:ext uri="{FF2B5EF4-FFF2-40B4-BE49-F238E27FC236}">
-                <a16:creationId xmlns:a16="http://schemas.microsoft.com/office/drawing/2014/main" id="{C9D0A053-5878-4925-87DF-B07B15D3361A}"/>
+                <a16:creationId xmlns:a16="http://schemas.microsoft.com/office/drawing/2014/main" id="{2FBC6F20-751B-43ED-A3C3-1848CE9CAA84}"/>
               </a:ext>
             </a:extLst>
           </p:cNvPr>
@@ -17055,7 +17055,7 @@
           <p:cNvPr id="9" name="">
             <a:extLst xmlns:a="http://schemas.openxmlformats.org/drawingml/2006/main">
               <a:ext uri="{FF2B5EF4-FFF2-40B4-BE49-F238E27FC236}">
-                <a16:creationId xmlns:a16="http://schemas.microsoft.com/office/drawing/2014/main" id="{BCEC6BAE-D00D-4D84-B781-F22726625E94}"/>
+                <a16:creationId xmlns:a16="http://schemas.microsoft.com/office/drawing/2014/main" id="{1168C87B-8F73-4252-AF73-46797AB4A729}"/>
               </a:ext>
             </a:extLst>
           </p:cNvPr>
@@ -17088,7 +17088,7 @@
           <p:cNvPr id="10" name="">
             <a:extLst xmlns:a="http://schemas.openxmlformats.org/drawingml/2006/main">
               <a:ext uri="{FF2B5EF4-FFF2-40B4-BE49-F238E27FC236}">
-                <a16:creationId xmlns:a16="http://schemas.microsoft.com/office/drawing/2014/main" id="{6F17F783-9888-48D7-BFA0-4217E868FBDD}"/>
+                <a16:creationId xmlns:a16="http://schemas.microsoft.com/office/drawing/2014/main" id="{E562142A-0A31-4983-B1D2-05DDF15E6E8E}"/>
               </a:ext>
             </a:extLst>
           </p:cNvPr>
@@ -17152,7 +17152,7 @@
           <p:cNvPr id="11" name="">
             <a:extLst xmlns:a="http://schemas.openxmlformats.org/drawingml/2006/main">
               <a:ext uri="{FF2B5EF4-FFF2-40B4-BE49-F238E27FC236}">
-                <a16:creationId xmlns:a16="http://schemas.microsoft.com/office/drawing/2014/main" id="{E28A2740-D1CB-4888-85B1-BB22671B43AB}"/>
+                <a16:creationId xmlns:a16="http://schemas.microsoft.com/office/drawing/2014/main" id="{AF32AF1F-1FED-449D-B6F1-A2AEB72E95FB}"/>
               </a:ext>
             </a:extLst>
           </p:cNvPr>
@@ -17216,7 +17216,7 @@
           <p:cNvPr id="12" name="">
             <a:extLst xmlns:a="http://schemas.openxmlformats.org/drawingml/2006/main">
               <a:ext uri="{FF2B5EF4-FFF2-40B4-BE49-F238E27FC236}">
-                <a16:creationId xmlns:a16="http://schemas.microsoft.com/office/drawing/2014/main" id="{FE61D21D-1E02-41B6-9EBD-FB8267318D69}"/>
+                <a16:creationId xmlns:a16="http://schemas.microsoft.com/office/drawing/2014/main" id="{509EF75D-9F57-42A1-93AE-055204A4D919}"/>
               </a:ext>
             </a:extLst>
           </p:cNvPr>
@@ -17280,7 +17280,7 @@
           <p:cNvPr id="13" name="">
             <a:extLst xmlns:a="http://schemas.openxmlformats.org/drawingml/2006/main">
               <a:ext uri="{FF2B5EF4-FFF2-40B4-BE49-F238E27FC236}">
-                <a16:creationId xmlns:a16="http://schemas.microsoft.com/office/drawing/2014/main" id="{9418902F-1849-4B62-BB47-56828110424E}"/>
+                <a16:creationId xmlns:a16="http://schemas.microsoft.com/office/drawing/2014/main" id="{D30069B7-1E5D-4B59-954D-02397257B411}"/>
               </a:ext>
             </a:extLst>
           </p:cNvPr>
@@ -17313,7 +17313,7 @@
           <p:cNvPr id="14" name="">
             <a:extLst xmlns:a="http://schemas.openxmlformats.org/drawingml/2006/main">
               <a:ext uri="{FF2B5EF4-FFF2-40B4-BE49-F238E27FC236}">
-                <a16:creationId xmlns:a16="http://schemas.microsoft.com/office/drawing/2014/main" id="{F9EDC3C8-CD5A-47FC-A94F-C3E24A7A8A0A}"/>
+                <a16:creationId xmlns:a16="http://schemas.microsoft.com/office/drawing/2014/main" id="{645A7A13-C62D-4F47-9E1E-C0DF751A3AD8}"/>
               </a:ext>
             </a:extLst>
           </p:cNvPr>
@@ -17377,7 +17377,7 @@
           <p:cNvPr id="15" name="">
             <a:extLst xmlns:a="http://schemas.openxmlformats.org/drawingml/2006/main">
               <a:ext uri="{FF2B5EF4-FFF2-40B4-BE49-F238E27FC236}">
-                <a16:creationId xmlns:a16="http://schemas.microsoft.com/office/drawing/2014/main" id="{8E3FFC60-B48E-4F63-80FE-8ED5D647F891}"/>
+                <a16:creationId xmlns:a16="http://schemas.microsoft.com/office/drawing/2014/main" id="{D4F70BFD-2A90-4A6E-B394-7DD25136B1D1}"/>
               </a:ext>
             </a:extLst>
           </p:cNvPr>
@@ -17441,7 +17441,7 @@
           <p:cNvPr id="16" name="">
             <a:extLst xmlns:a="http://schemas.openxmlformats.org/drawingml/2006/main">
               <a:ext uri="{FF2B5EF4-FFF2-40B4-BE49-F238E27FC236}">
-                <a16:creationId xmlns:a16="http://schemas.microsoft.com/office/drawing/2014/main" id="{23F02350-CB60-4B15-AA3B-F737AE901364}"/>
+                <a16:creationId xmlns:a16="http://schemas.microsoft.com/office/drawing/2014/main" id="{9ABDBC94-0D34-4327-BE78-601E840AD512}"/>
               </a:ext>
             </a:extLst>
           </p:cNvPr>
@@ -17505,7 +17505,7 @@
           <p:cNvPr id="17" name="">
             <a:extLst xmlns:a="http://schemas.openxmlformats.org/drawingml/2006/main">
               <a:ext uri="{FF2B5EF4-FFF2-40B4-BE49-F238E27FC236}">
-                <a16:creationId xmlns:a16="http://schemas.microsoft.com/office/drawing/2014/main" id="{071BF0D0-5DAF-43AB-AE37-4B3E5BA3D2A0}"/>
+                <a16:creationId xmlns:a16="http://schemas.microsoft.com/office/drawing/2014/main" id="{1ED24477-438A-4C20-A699-AD954C1DF75B}"/>
               </a:ext>
             </a:extLst>
           </p:cNvPr>
@@ -17538,7 +17538,7 @@
           <p:cNvPr id="18" name="">
             <a:extLst xmlns:a="http://schemas.openxmlformats.org/drawingml/2006/main">
               <a:ext uri="{FF2B5EF4-FFF2-40B4-BE49-F238E27FC236}">
-                <a16:creationId xmlns:a16="http://schemas.microsoft.com/office/drawing/2014/main" id="{AD6A083C-A01B-47FC-9108-48A9699581DC}"/>
+                <a16:creationId xmlns:a16="http://schemas.microsoft.com/office/drawing/2014/main" id="{FDDB7E45-2BBA-4D4E-A0F4-EB721F892E3A}"/>
               </a:ext>
             </a:extLst>
           </p:cNvPr>
@@ -17602,7 +17602,7 @@
           <p:cNvPr id="19" name="">
             <a:extLst xmlns:a="http://schemas.openxmlformats.org/drawingml/2006/main">
               <a:ext uri="{FF2B5EF4-FFF2-40B4-BE49-F238E27FC236}">
-                <a16:creationId xmlns:a16="http://schemas.microsoft.com/office/drawing/2014/main" id="{EC67551A-CDF5-4D25-A182-C094CB6A2FA7}"/>
+                <a16:creationId xmlns:a16="http://schemas.microsoft.com/office/drawing/2014/main" id="{41C8A5E9-6BEE-4DD6-B325-2ED64937FDCF}"/>
               </a:ext>
             </a:extLst>
           </p:cNvPr>
@@ -17666,7 +17666,7 @@
           <p:cNvPr id="20" name="">
             <a:extLst xmlns:a="http://schemas.openxmlformats.org/drawingml/2006/main">
               <a:ext uri="{FF2B5EF4-FFF2-40B4-BE49-F238E27FC236}">
-                <a16:creationId xmlns:a16="http://schemas.microsoft.com/office/drawing/2014/main" id="{BA2984BD-528A-411B-9E59-E1FDBF9BACDF}"/>
+                <a16:creationId xmlns:a16="http://schemas.microsoft.com/office/drawing/2014/main" id="{9382FB57-AA52-4AD5-8FA9-5A2AF72AE670}"/>
               </a:ext>
             </a:extLst>
           </p:cNvPr>
@@ -17699,7 +17699,7 @@
           <p:cNvPr id="21" name="">
             <a:extLst xmlns:a="http://schemas.openxmlformats.org/drawingml/2006/main">
               <a:ext uri="{FF2B5EF4-FFF2-40B4-BE49-F238E27FC236}">
-                <a16:creationId xmlns:a16="http://schemas.microsoft.com/office/drawing/2014/main" id="{95CE3D22-F187-4FCB-9C24-3532A4685AF8}"/>
+                <a16:creationId xmlns:a16="http://schemas.microsoft.com/office/drawing/2014/main" id="{2D066269-804A-49E6-9EE8-3E42AC7CAB40}"/>
               </a:ext>
             </a:extLst>
           </p:cNvPr>
@@ -17763,7 +17763,7 @@
           <p:cNvPr id="22" name="">
             <a:extLst xmlns:a="http://schemas.openxmlformats.org/drawingml/2006/main">
               <a:ext uri="{FF2B5EF4-FFF2-40B4-BE49-F238E27FC236}">
-                <a16:creationId xmlns:a16="http://schemas.microsoft.com/office/drawing/2014/main" id="{46E87949-1789-4251-A8BE-D10C55D6DBE0}"/>
+                <a16:creationId xmlns:a16="http://schemas.microsoft.com/office/drawing/2014/main" id="{8DB557FB-C15F-4AAD-940D-BF2F353FC622}"/>
               </a:ext>
             </a:extLst>
           </p:cNvPr>
@@ -17827,7 +17827,7 @@
           <p:cNvPr id="23" name="">
             <a:extLst xmlns:a="http://schemas.openxmlformats.org/drawingml/2006/main">
               <a:ext uri="{FF2B5EF4-FFF2-40B4-BE49-F238E27FC236}">
-                <a16:creationId xmlns:a16="http://schemas.microsoft.com/office/drawing/2014/main" id="{003F1D27-2695-414B-B298-7CF606E956B7}"/>
+                <a16:creationId xmlns:a16="http://schemas.microsoft.com/office/drawing/2014/main" id="{148A4115-7497-406C-AF02-187C52D8D2B3}"/>
               </a:ext>
             </a:extLst>
           </p:cNvPr>
@@ -17891,7 +17891,7 @@
           <p:cNvPr id="24" name="">
             <a:extLst xmlns:a="http://schemas.openxmlformats.org/drawingml/2006/main">
               <a:ext uri="{FF2B5EF4-FFF2-40B4-BE49-F238E27FC236}">
-                <a16:creationId xmlns:a16="http://schemas.microsoft.com/office/drawing/2014/main" id="{1EC91A9B-DFF9-4BF7-B03B-649013740527}"/>
+                <a16:creationId xmlns:a16="http://schemas.microsoft.com/office/drawing/2014/main" id="{967A4CB7-BFD9-4353-BAE2-010DA9540137}"/>
               </a:ext>
             </a:extLst>
           </p:cNvPr>
@@ -17924,7 +17924,7 @@
           <p:cNvPr id="25" name="">
             <a:extLst xmlns:a="http://schemas.openxmlformats.org/drawingml/2006/main">
               <a:ext uri="{FF2B5EF4-FFF2-40B4-BE49-F238E27FC236}">
-                <a16:creationId xmlns:a16="http://schemas.microsoft.com/office/drawing/2014/main" id="{BF254DA2-4DC2-41DF-BB91-842D40C5B321}"/>
+                <a16:creationId xmlns:a16="http://schemas.microsoft.com/office/drawing/2014/main" id="{6CF320F8-E224-4211-8541-470A4FF624F2}"/>
               </a:ext>
             </a:extLst>
           </p:cNvPr>
@@ -17988,7 +17988,7 @@
           <p:cNvPr id="26" name="">
             <a:extLst xmlns:a="http://schemas.openxmlformats.org/drawingml/2006/main">
               <a:ext uri="{FF2B5EF4-FFF2-40B4-BE49-F238E27FC236}">
-                <a16:creationId xmlns:a16="http://schemas.microsoft.com/office/drawing/2014/main" id="{6FDC3C9B-1479-4477-9FC1-B7D27F36B1BF}"/>
+                <a16:creationId xmlns:a16="http://schemas.microsoft.com/office/drawing/2014/main" id="{FF15FDB3-9FDB-419F-899C-F51751FE8488}"/>
               </a:ext>
             </a:extLst>
           </p:cNvPr>
@@ -18052,7 +18052,7 @@
           <p:cNvPr id="27" name="">
             <a:extLst xmlns:a="http://schemas.openxmlformats.org/drawingml/2006/main">
               <a:ext uri="{FF2B5EF4-FFF2-40B4-BE49-F238E27FC236}">
-                <a16:creationId xmlns:a16="http://schemas.microsoft.com/office/drawing/2014/main" id="{07A740AE-5F59-434F-AD99-8C163E4C347E}"/>
+                <a16:creationId xmlns:a16="http://schemas.microsoft.com/office/drawing/2014/main" id="{13165EFA-BE15-4187-AFA6-5EE04624E740}"/>
               </a:ext>
             </a:extLst>
           </p:cNvPr>
@@ -18116,7 +18116,7 @@
           <p:cNvPr id="28" name="">
             <a:extLst xmlns:a="http://schemas.openxmlformats.org/drawingml/2006/main">
               <a:ext uri="{FF2B5EF4-FFF2-40B4-BE49-F238E27FC236}">
-                <a16:creationId xmlns:a16="http://schemas.microsoft.com/office/drawing/2014/main" id="{6A84E984-D272-457D-B058-9A64040DE5DA}"/>
+                <a16:creationId xmlns:a16="http://schemas.microsoft.com/office/drawing/2014/main" id="{128062F0-BB93-4436-9ED9-676F75E3A6D9}"/>
               </a:ext>
             </a:extLst>
           </p:cNvPr>
@@ -18149,7 +18149,7 @@
           <p:cNvPr id="29" name="">
             <a:extLst xmlns:a="http://schemas.openxmlformats.org/drawingml/2006/main">
               <a:ext uri="{FF2B5EF4-FFF2-40B4-BE49-F238E27FC236}">
-                <a16:creationId xmlns:a16="http://schemas.microsoft.com/office/drawing/2014/main" id="{8534DE38-7FEC-4459-A6AF-82EC70F77236}"/>
+                <a16:creationId xmlns:a16="http://schemas.microsoft.com/office/drawing/2014/main" id="{29326C36-D60A-4A50-B2DB-78E3F2B25655}"/>
               </a:ext>
             </a:extLst>
           </p:cNvPr>
@@ -18213,7 +18213,7 @@
           <p:cNvPr id="30" name="">
             <a:extLst xmlns:a="http://schemas.openxmlformats.org/drawingml/2006/main">
               <a:ext uri="{FF2B5EF4-FFF2-40B4-BE49-F238E27FC236}">
-                <a16:creationId xmlns:a16="http://schemas.microsoft.com/office/drawing/2014/main" id="{B63F2275-CABE-4364-B675-F9FBC2B2745B}"/>
+                <a16:creationId xmlns:a16="http://schemas.microsoft.com/office/drawing/2014/main" id="{BF3C2A2D-51C7-4C20-B579-DD4BB1FABE73}"/>
               </a:ext>
             </a:extLst>
           </p:cNvPr>
@@ -18277,7 +18277,7 @@
           <p:cNvPr id="31" name="">
             <a:extLst xmlns:a="http://schemas.openxmlformats.org/drawingml/2006/main">
               <a:ext uri="{FF2B5EF4-FFF2-40B4-BE49-F238E27FC236}">
-                <a16:creationId xmlns:a16="http://schemas.microsoft.com/office/drawing/2014/main" id="{1BF9F5F4-318B-401D-9E08-C8B9136815AE}"/>
+                <a16:creationId xmlns:a16="http://schemas.microsoft.com/office/drawing/2014/main" id="{EBE34AFC-528C-4017-B1B3-658EEEDD17CC}"/>
               </a:ext>
             </a:extLst>
           </p:cNvPr>
@@ -18331,7 +18331,7 @@
                 <a:ea typeface="Hiragino Sans"/>
                 <a:cs typeface="Hiragino Sans"/>
               </a:rPr>
-              <a:t>U6 split PPE + DC</a:t>
+              <a:t>split PPE + DC</a:t>
             </a:r>
           </a:p>
         </p:txBody>
@@ -18341,7 +18341,7 @@
           <p:cNvPr id="32" name="">
             <a:extLst xmlns:a="http://schemas.openxmlformats.org/drawingml/2006/main">
               <a:ext uri="{FF2B5EF4-FFF2-40B4-BE49-F238E27FC236}">
-                <a16:creationId xmlns:a16="http://schemas.microsoft.com/office/drawing/2014/main" id="{3E4D8F03-9A41-45F0-AFD4-0FD43B996959}"/>
+                <a16:creationId xmlns:a16="http://schemas.microsoft.com/office/drawing/2014/main" id="{01E1316F-3BB5-46EF-9784-D773BA79146F}"/>
               </a:ext>
             </a:extLst>
           </p:cNvPr>
@@ -18376,7 +18376,7 @@
           <p:cNvPr id="33" name="">
             <a:extLst xmlns:a="http://schemas.openxmlformats.org/drawingml/2006/main">
               <a:ext uri="{FF2B5EF4-FFF2-40B4-BE49-F238E27FC236}">
-                <a16:creationId xmlns:a16="http://schemas.microsoft.com/office/drawing/2014/main" id="{5AB26DE7-7781-4787-B3C1-7CB1F550A13D}"/>
+                <a16:creationId xmlns:a16="http://schemas.microsoft.com/office/drawing/2014/main" id="{15860676-0627-4047-A61F-95B01DAF0F45}"/>
               </a:ext>
             </a:extLst>
           </p:cNvPr>
@@ -18430,7 +18430,7 @@
                 <a:ea typeface="Hiragino Sans"/>
                 <a:cs typeface="Hiragino Sans"/>
               </a:rPr>
-              <a:t>source: paper/sections/09b_split_ppe.tex; 09c_hfe.tex; 09d_defect_correction.tex; 12u6_split_ppe_dc_hfe.tex</a:t>
+              <a:t>source: Split PPE; HFE; defect correction; component verification</a:t>
             </a:r>
           </a:p>
         </p:txBody>
@@ -18440,7 +18440,7 @@
           <p:cNvPr id="34" name="">
             <a:extLst xmlns:a="http://schemas.openxmlformats.org/drawingml/2006/main">
               <a:ext uri="{FF2B5EF4-FFF2-40B4-BE49-F238E27FC236}">
-                <a16:creationId xmlns:a16="http://schemas.microsoft.com/office/drawing/2014/main" id="{1425CFA8-35C3-4907-9362-1E4E12734205}"/>
+                <a16:creationId xmlns:a16="http://schemas.microsoft.com/office/drawing/2014/main" id="{01EB91C5-8367-4AD0-92D9-5FB217AF1B20}"/>
               </a:ext>
             </a:extLst>
           </p:cNvPr>
@@ -18502,7 +18502,7 @@
     </p:spTree>
     <p:extLst>
       <p:ext uri="{BB962C8B-B14F-4D97-AF65-F5344CB8AC3E}">
-        <p14:creationId xmlns:p14="http://schemas.microsoft.com/office/powerpoint/2010/main" val="655834991"/>
+        <p14:creationId xmlns:p14="http://schemas.microsoft.com/office/powerpoint/2010/main" val="292935395"/>
       </p:ext>
     </p:extLst>
   </p:cSld>
@@ -18526,7 +18526,7 @@
           <p:cNvPr id="1" name="">
             <a:extLst xmlns:a="http://schemas.openxmlformats.org/drawingml/2006/main">
               <a:ext uri="{FF2B5EF4-FFF2-40B4-BE49-F238E27FC236}">
-                <a16:creationId xmlns:a16="http://schemas.microsoft.com/office/drawing/2014/main" id="{64A7B6EA-90B4-46E5-A8F6-6CA1C074A451}"/>
+                <a16:creationId xmlns:a16="http://schemas.microsoft.com/office/drawing/2014/main" id="{272E0E68-7DD4-4B8D-9565-BAD23CB7C8A0}"/>
               </a:ext>
             </a:extLst>
           </p:cNvPr>
@@ -18561,7 +18561,7 @@
           <p:cNvPr id="2" name="">
             <a:extLst xmlns:a="http://schemas.openxmlformats.org/drawingml/2006/main">
               <a:ext uri="{FF2B5EF4-FFF2-40B4-BE49-F238E27FC236}">
-                <a16:creationId xmlns:a16="http://schemas.microsoft.com/office/drawing/2014/main" id="{E769CE8A-6822-46A6-9555-9BAE65B03877}"/>
+                <a16:creationId xmlns:a16="http://schemas.microsoft.com/office/drawing/2014/main" id="{9D9ECFD4-38C5-4446-A8B8-3D5AF2152B19}"/>
               </a:ext>
             </a:extLst>
           </p:cNvPr>
@@ -18596,7 +18596,7 @@
           <p:cNvPr id="3" name="">
             <a:extLst xmlns:a="http://schemas.openxmlformats.org/drawingml/2006/main">
               <a:ext uri="{FF2B5EF4-FFF2-40B4-BE49-F238E27FC236}">
-                <a16:creationId xmlns:a16="http://schemas.microsoft.com/office/drawing/2014/main" id="{CDFEE3D8-B21E-4C19-8442-8B521D585DFF}"/>
+                <a16:creationId xmlns:a16="http://schemas.microsoft.com/office/drawing/2014/main" id="{F97C6335-FB15-469E-90D0-D29AB32325C5}"/>
               </a:ext>
             </a:extLst>
           </p:cNvPr>
@@ -18660,7 +18660,7 @@
           <p:cNvPr id="4" name="">
             <a:extLst xmlns:a="http://schemas.openxmlformats.org/drawingml/2006/main">
               <a:ext uri="{FF2B5EF4-FFF2-40B4-BE49-F238E27FC236}">
-                <a16:creationId xmlns:a16="http://schemas.microsoft.com/office/drawing/2014/main" id="{B3A613AC-9CB2-4F4C-8A40-9C80623E45AC}"/>
+                <a16:creationId xmlns:a16="http://schemas.microsoft.com/office/drawing/2014/main" id="{85280090-9DDE-4B5E-AD2C-18889D2E25E3}"/>
               </a:ext>
             </a:extLst>
           </p:cNvPr>
@@ -18724,7 +18724,7 @@
           <p:cNvPr id="5" name="">
             <a:extLst xmlns:a="http://schemas.openxmlformats.org/drawingml/2006/main">
               <a:ext uri="{FF2B5EF4-FFF2-40B4-BE49-F238E27FC236}">
-                <a16:creationId xmlns:a16="http://schemas.microsoft.com/office/drawing/2014/main" id="{15F8E2CE-FC69-410E-95D4-4F9C8D6EE45C}"/>
+                <a16:creationId xmlns:a16="http://schemas.microsoft.com/office/drawing/2014/main" id="{36A7C6C0-703F-4298-A27B-EDB055B130F3}"/>
               </a:ext>
             </a:extLst>
           </p:cNvPr>
@@ -18759,7 +18759,7 @@
           <p:cNvPr id="6" name="">
             <a:extLst xmlns:a="http://schemas.openxmlformats.org/drawingml/2006/main">
               <a:ext uri="{FF2B5EF4-FFF2-40B4-BE49-F238E27FC236}">
-                <a16:creationId xmlns:a16="http://schemas.microsoft.com/office/drawing/2014/main" id="{2759B9AF-21F2-4240-832E-A3AA1B04A7C4}"/>
+                <a16:creationId xmlns:a16="http://schemas.microsoft.com/office/drawing/2014/main" id="{9C1F0D40-E53D-44B3-BB78-486A88F102CC}"/>
               </a:ext>
             </a:extLst>
           </p:cNvPr>
@@ -18823,7 +18823,7 @@
           <p:cNvPr id="7" name="">
             <a:extLst xmlns:a="http://schemas.openxmlformats.org/drawingml/2006/main">
               <a:ext uri="{FF2B5EF4-FFF2-40B4-BE49-F238E27FC236}">
-                <a16:creationId xmlns:a16="http://schemas.microsoft.com/office/drawing/2014/main" id="{092D8703-81B9-4839-AAE6-91BCDBCA6C91}"/>
+                <a16:creationId xmlns:a16="http://schemas.microsoft.com/office/drawing/2014/main" id="{C301FB4C-9227-4B48-92A7-0AD7FEFBF460}"/>
               </a:ext>
             </a:extLst>
           </p:cNvPr>
@@ -18858,7 +18858,7 @@
           <p:cNvPr id="8" name="">
             <a:extLst xmlns:a="http://schemas.openxmlformats.org/drawingml/2006/main">
               <a:ext uri="{FF2B5EF4-FFF2-40B4-BE49-F238E27FC236}">
-                <a16:creationId xmlns:a16="http://schemas.microsoft.com/office/drawing/2014/main" id="{9F8B4466-14AE-4F04-B80B-236746781734}"/>
+                <a16:creationId xmlns:a16="http://schemas.microsoft.com/office/drawing/2014/main" id="{64FF1789-A38E-408B-8D61-1F61326634BF}"/>
               </a:ext>
             </a:extLst>
           </p:cNvPr>
@@ -18893,7 +18893,7 @@
           <p:cNvPr id="9" name="">
             <a:extLst xmlns:a="http://schemas.openxmlformats.org/drawingml/2006/main">
               <a:ext uri="{FF2B5EF4-FFF2-40B4-BE49-F238E27FC236}">
-                <a16:creationId xmlns:a16="http://schemas.microsoft.com/office/drawing/2014/main" id="{ED32AD95-8230-436D-A5B5-B67A35900D2C}"/>
+                <a16:creationId xmlns:a16="http://schemas.microsoft.com/office/drawing/2014/main" id="{627660EC-4792-4545-8BE3-80FC101E806A}"/>
               </a:ext>
             </a:extLst>
           </p:cNvPr>
@@ -18928,7 +18928,7 @@
           <p:cNvPr id="10" name="">
             <a:extLst xmlns:a="http://schemas.openxmlformats.org/drawingml/2006/main">
               <a:ext uri="{FF2B5EF4-FFF2-40B4-BE49-F238E27FC236}">
-                <a16:creationId xmlns:a16="http://schemas.microsoft.com/office/drawing/2014/main" id="{65F2A7CE-B21F-438B-AA6D-699982332F0E}"/>
+                <a16:creationId xmlns:a16="http://schemas.microsoft.com/office/drawing/2014/main" id="{199A1BD8-4446-4A1E-9A81-FA1DE09C3848}"/>
               </a:ext>
             </a:extLst>
           </p:cNvPr>
@@ -18963,7 +18963,7 @@
           <p:cNvPr id="11" name="">
             <a:extLst xmlns:a="http://schemas.openxmlformats.org/drawingml/2006/main">
               <a:ext uri="{FF2B5EF4-FFF2-40B4-BE49-F238E27FC236}">
-                <a16:creationId xmlns:a16="http://schemas.microsoft.com/office/drawing/2014/main" id="{BD548BC2-1C77-4174-9008-E390AB663C35}"/>
+                <a16:creationId xmlns:a16="http://schemas.microsoft.com/office/drawing/2014/main" id="{8FF2369E-B915-4B7D-8915-5C77CC9535F4}"/>
               </a:ext>
             </a:extLst>
           </p:cNvPr>
@@ -18998,7 +18998,7 @@
           <p:cNvPr id="12" name="">
             <a:extLst xmlns:a="http://schemas.openxmlformats.org/drawingml/2006/main">
               <a:ext uri="{FF2B5EF4-FFF2-40B4-BE49-F238E27FC236}">
-                <a16:creationId xmlns:a16="http://schemas.microsoft.com/office/drawing/2014/main" id="{97C195B0-0D73-4A97-B5B5-884C21AD7488}"/>
+                <a16:creationId xmlns:a16="http://schemas.microsoft.com/office/drawing/2014/main" id="{FBE20E3B-7A03-4C7C-B925-D4BE5AF3A980}"/>
               </a:ext>
             </a:extLst>
           </p:cNvPr>
@@ -19031,7 +19031,7 @@
           <p:cNvPr id="13" name="">
             <a:extLst xmlns:a="http://schemas.openxmlformats.org/drawingml/2006/main">
               <a:ext uri="{FF2B5EF4-FFF2-40B4-BE49-F238E27FC236}">
-                <a16:creationId xmlns:a16="http://schemas.microsoft.com/office/drawing/2014/main" id="{5508DEDB-D09C-430C-B6EB-89216C40F68F}"/>
+                <a16:creationId xmlns:a16="http://schemas.microsoft.com/office/drawing/2014/main" id="{BB458252-12DA-405D-8EDA-C4B2088FEABE}"/>
               </a:ext>
             </a:extLst>
           </p:cNvPr>
@@ -19095,7 +19095,7 @@
           <p:cNvPr id="14" name="">
             <a:extLst xmlns:a="http://schemas.openxmlformats.org/drawingml/2006/main">
               <a:ext uri="{FF2B5EF4-FFF2-40B4-BE49-F238E27FC236}">
-                <a16:creationId xmlns:a16="http://schemas.microsoft.com/office/drawing/2014/main" id="{0416DE31-9F10-4C8E-8FB2-77553E9999A6}"/>
+                <a16:creationId xmlns:a16="http://schemas.microsoft.com/office/drawing/2014/main" id="{141490EC-3245-413C-9E1F-B57C7419E6CF}"/>
               </a:ext>
             </a:extLst>
           </p:cNvPr>
@@ -19128,7 +19128,7 @@
           <p:cNvPr id="15" name="">
             <a:extLst xmlns:a="http://schemas.openxmlformats.org/drawingml/2006/main">
               <a:ext uri="{FF2B5EF4-FFF2-40B4-BE49-F238E27FC236}">
-                <a16:creationId xmlns:a16="http://schemas.microsoft.com/office/drawing/2014/main" id="{DC6628C6-704C-4B7B-A93F-DF9EA847EB39}"/>
+                <a16:creationId xmlns:a16="http://schemas.microsoft.com/office/drawing/2014/main" id="{4CCCCEDA-4F3F-428E-A32E-D663D1D73445}"/>
               </a:ext>
             </a:extLst>
           </p:cNvPr>
@@ -19192,7 +19192,7 @@
           <p:cNvPr id="16" name="">
             <a:extLst xmlns:a="http://schemas.openxmlformats.org/drawingml/2006/main">
               <a:ext uri="{FF2B5EF4-FFF2-40B4-BE49-F238E27FC236}">
-                <a16:creationId xmlns:a16="http://schemas.microsoft.com/office/drawing/2014/main" id="{2B7F23F0-0761-464B-82D2-5EFC644E9925}"/>
+                <a16:creationId xmlns:a16="http://schemas.microsoft.com/office/drawing/2014/main" id="{04CFA144-E18B-49CA-9075-7CAB2E950BD1}"/>
               </a:ext>
             </a:extLst>
           </p:cNvPr>
@@ -19225,7 +19225,7 @@
           <p:cNvPr id="17" name="">
             <a:extLst xmlns:a="http://schemas.openxmlformats.org/drawingml/2006/main">
               <a:ext uri="{FF2B5EF4-FFF2-40B4-BE49-F238E27FC236}">
-                <a16:creationId xmlns:a16="http://schemas.microsoft.com/office/drawing/2014/main" id="{18BC7239-A88E-4212-8457-CE58B8C6E114}"/>
+                <a16:creationId xmlns:a16="http://schemas.microsoft.com/office/drawing/2014/main" id="{29FD259F-5367-48A3-8681-FCBD11F7B66C}"/>
               </a:ext>
             </a:extLst>
           </p:cNvPr>
@@ -19289,7 +19289,7 @@
           <p:cNvPr id="18" name="">
             <a:extLst xmlns:a="http://schemas.openxmlformats.org/drawingml/2006/main">
               <a:ext uri="{FF2B5EF4-FFF2-40B4-BE49-F238E27FC236}">
-                <a16:creationId xmlns:a16="http://schemas.microsoft.com/office/drawing/2014/main" id="{3DA7A65F-1F88-4713-9EE6-797F0CFF4A69}"/>
+                <a16:creationId xmlns:a16="http://schemas.microsoft.com/office/drawing/2014/main" id="{806DD71B-0ADC-4FC2-9B46-0F8C9B72FF5D}"/>
               </a:ext>
             </a:extLst>
           </p:cNvPr>
@@ -19322,7 +19322,7 @@
           <p:cNvPr id="19" name="">
             <a:extLst xmlns:a="http://schemas.openxmlformats.org/drawingml/2006/main">
               <a:ext uri="{FF2B5EF4-FFF2-40B4-BE49-F238E27FC236}">
-                <a16:creationId xmlns:a16="http://schemas.microsoft.com/office/drawing/2014/main" id="{01DB7B19-F624-4ECE-AD8C-9BA90FF3C27D}"/>
+                <a16:creationId xmlns:a16="http://schemas.microsoft.com/office/drawing/2014/main" id="{C556E1C2-D7C6-4361-8229-F5D049A198C9}"/>
               </a:ext>
             </a:extLst>
           </p:cNvPr>
@@ -19386,7 +19386,7 @@
           <p:cNvPr id="20" name="">
             <a:extLst xmlns:a="http://schemas.openxmlformats.org/drawingml/2006/main">
               <a:ext uri="{FF2B5EF4-FFF2-40B4-BE49-F238E27FC236}">
-                <a16:creationId xmlns:a16="http://schemas.microsoft.com/office/drawing/2014/main" id="{36DB62D0-931E-4E4F-8384-866699FA004F}"/>
+                <a16:creationId xmlns:a16="http://schemas.microsoft.com/office/drawing/2014/main" id="{B2DDC524-C06C-4B86-A63D-DA47BF0BAD87}"/>
               </a:ext>
             </a:extLst>
           </p:cNvPr>
@@ -19419,7 +19419,7 @@
           <p:cNvPr id="21" name="">
             <a:extLst xmlns:a="http://schemas.openxmlformats.org/drawingml/2006/main">
               <a:ext uri="{FF2B5EF4-FFF2-40B4-BE49-F238E27FC236}">
-                <a16:creationId xmlns:a16="http://schemas.microsoft.com/office/drawing/2014/main" id="{FE60C3ED-EB3A-429A-B52E-A8376980E342}"/>
+                <a16:creationId xmlns:a16="http://schemas.microsoft.com/office/drawing/2014/main" id="{628BBAE7-1099-4B5D-BF09-2F7F313059C7}"/>
               </a:ext>
             </a:extLst>
           </p:cNvPr>
@@ -19483,7 +19483,7 @@
           <p:cNvPr id="22" name="">
             <a:extLst xmlns:a="http://schemas.openxmlformats.org/drawingml/2006/main">
               <a:ext uri="{FF2B5EF4-FFF2-40B4-BE49-F238E27FC236}">
-                <a16:creationId xmlns:a16="http://schemas.microsoft.com/office/drawing/2014/main" id="{A3E5D49C-B893-4BFD-896C-2CDFB9270A08}"/>
+                <a16:creationId xmlns:a16="http://schemas.microsoft.com/office/drawing/2014/main" id="{862FEA90-6300-488C-809B-B8B976F95055}"/>
               </a:ext>
             </a:extLst>
           </p:cNvPr>
@@ -19547,7 +19547,7 @@
           <p:cNvPr id="23" name="">
             <a:extLst xmlns:a="http://schemas.openxmlformats.org/drawingml/2006/main">
               <a:ext uri="{FF2B5EF4-FFF2-40B4-BE49-F238E27FC236}">
-                <a16:creationId xmlns:a16="http://schemas.microsoft.com/office/drawing/2014/main" id="{92425358-FBCD-41E1-991E-29566440FA48}"/>
+                <a16:creationId xmlns:a16="http://schemas.microsoft.com/office/drawing/2014/main" id="{3CE8A664-5709-4C0C-A63C-3C7A5B8C2FF8}"/>
               </a:ext>
             </a:extLst>
           </p:cNvPr>
@@ -19582,7 +19582,7 @@
           <p:cNvPr id="24" name="">
             <a:extLst xmlns:a="http://schemas.openxmlformats.org/drawingml/2006/main">
               <a:ext uri="{FF2B5EF4-FFF2-40B4-BE49-F238E27FC236}">
-                <a16:creationId xmlns:a16="http://schemas.microsoft.com/office/drawing/2014/main" id="{E11341E4-BA4C-4A17-8E26-91F8AF0E4DD1}"/>
+                <a16:creationId xmlns:a16="http://schemas.microsoft.com/office/drawing/2014/main" id="{CE1F5E5B-FA60-4627-A737-5BBEB207F59F}"/>
               </a:ext>
             </a:extLst>
           </p:cNvPr>
@@ -19636,7 +19636,7 @@
                 <a:ea typeface="Hiragino Sans"/>
                 <a:cs typeface="Hiragino Sans"/>
               </a:rPr>
-              <a:t>source: paper/sections/08_collocate.tex; 11_full_algorithm.tex; 14_benchmarks.tex</a:t>
+              <a:t>source: Collocated face geometry; full algorithm; benchmark conditions</a:t>
             </a:r>
           </a:p>
         </p:txBody>
@@ -19646,7 +19646,7 @@
           <p:cNvPr id="25" name="">
             <a:extLst xmlns:a="http://schemas.openxmlformats.org/drawingml/2006/main">
               <a:ext uri="{FF2B5EF4-FFF2-40B4-BE49-F238E27FC236}">
-                <a16:creationId xmlns:a16="http://schemas.microsoft.com/office/drawing/2014/main" id="{4F16D9FC-46C3-46CD-8201-01D4787CE173}"/>
+                <a16:creationId xmlns:a16="http://schemas.microsoft.com/office/drawing/2014/main" id="{52B687C7-39B6-438A-8831-D0E82055560B}"/>
               </a:ext>
             </a:extLst>
           </p:cNvPr>
@@ -19708,7 +19708,7 @@
     </p:spTree>
     <p:extLst>
       <p:ext uri="{BB962C8B-B14F-4D97-AF65-F5344CB8AC3E}">
-        <p14:creationId xmlns:p14="http://schemas.microsoft.com/office/powerpoint/2010/main" val="1136211786"/>
+        <p14:creationId xmlns:p14="http://schemas.microsoft.com/office/powerpoint/2010/main" val="825938474"/>
       </p:ext>
     </p:extLst>
   </p:cSld>
@@ -19732,7 +19732,7 @@
           <p:cNvPr id="1" name="">
             <a:extLst xmlns:a="http://schemas.openxmlformats.org/drawingml/2006/main">
               <a:ext uri="{FF2B5EF4-FFF2-40B4-BE49-F238E27FC236}">
-                <a16:creationId xmlns:a16="http://schemas.microsoft.com/office/drawing/2014/main" id="{0EEACFA5-9098-4E40-A626-276B1AA114D5}"/>
+                <a16:creationId xmlns:a16="http://schemas.microsoft.com/office/drawing/2014/main" id="{8A100D0A-FE84-449A-A434-1402FFCBDB32}"/>
               </a:ext>
             </a:extLst>
           </p:cNvPr>
@@ -19767,7 +19767,7 @@
           <p:cNvPr id="2" name="">
             <a:extLst xmlns:a="http://schemas.openxmlformats.org/drawingml/2006/main">
               <a:ext uri="{FF2B5EF4-FFF2-40B4-BE49-F238E27FC236}">
-                <a16:creationId xmlns:a16="http://schemas.microsoft.com/office/drawing/2014/main" id="{5572E310-4BDC-4CF7-BA2C-6FF466156C32}"/>
+                <a16:creationId xmlns:a16="http://schemas.microsoft.com/office/drawing/2014/main" id="{1D1742EF-46B4-47B3-9B38-7FB36EC8A397}"/>
               </a:ext>
             </a:extLst>
           </p:cNvPr>
@@ -19802,7 +19802,7 @@
           <p:cNvPr id="3" name="">
             <a:extLst xmlns:a="http://schemas.openxmlformats.org/drawingml/2006/main">
               <a:ext uri="{FF2B5EF4-FFF2-40B4-BE49-F238E27FC236}">
-                <a16:creationId xmlns:a16="http://schemas.microsoft.com/office/drawing/2014/main" id="{C24FF07A-183E-46BC-8CFA-21A13E7D1987}"/>
+                <a16:creationId xmlns:a16="http://schemas.microsoft.com/office/drawing/2014/main" id="{267469D2-B9E5-4587-9C41-539BA208BE1E}"/>
               </a:ext>
             </a:extLst>
           </p:cNvPr>
@@ -19866,7 +19866,7 @@
           <p:cNvPr id="4" name="">
             <a:extLst xmlns:a="http://schemas.openxmlformats.org/drawingml/2006/main">
               <a:ext uri="{FF2B5EF4-FFF2-40B4-BE49-F238E27FC236}">
-                <a16:creationId xmlns:a16="http://schemas.microsoft.com/office/drawing/2014/main" id="{46C13254-FC95-4A64-926C-97F72FD67433}"/>
+                <a16:creationId xmlns:a16="http://schemas.microsoft.com/office/drawing/2014/main" id="{17C1FC53-9D5D-41FE-9EB4-CAF40F8046F9}"/>
               </a:ext>
             </a:extLst>
           </p:cNvPr>
@@ -19930,7 +19930,7 @@
           <p:cNvPr id="5" name="">
             <a:extLst xmlns:a="http://schemas.openxmlformats.org/drawingml/2006/main">
               <a:ext uri="{FF2B5EF4-FFF2-40B4-BE49-F238E27FC236}">
-                <a16:creationId xmlns:a16="http://schemas.microsoft.com/office/drawing/2014/main" id="{CF89DD59-A01F-4C75-86D8-8DFBD7C39B2D}"/>
+                <a16:creationId xmlns:a16="http://schemas.microsoft.com/office/drawing/2014/main" id="{D48056BE-4F72-45AF-85F2-CCEEB432DBC6}"/>
               </a:ext>
             </a:extLst>
           </p:cNvPr>
@@ -19963,7 +19963,7 @@
           <p:cNvPr id="6" name="">
             <a:extLst xmlns:a="http://schemas.openxmlformats.org/drawingml/2006/main">
               <a:ext uri="{FF2B5EF4-FFF2-40B4-BE49-F238E27FC236}">
-                <a16:creationId xmlns:a16="http://schemas.microsoft.com/office/drawing/2014/main" id="{A84BD8F0-4C02-4056-B255-BF25875B65FB}"/>
+                <a16:creationId xmlns:a16="http://schemas.microsoft.com/office/drawing/2014/main" id="{A8B64AFA-1C84-4C3D-9329-1A60387EFF8F}"/>
               </a:ext>
             </a:extLst>
           </p:cNvPr>
@@ -20027,7 +20027,7 @@
           <p:cNvPr id="7" name="">
             <a:extLst xmlns:a="http://schemas.openxmlformats.org/drawingml/2006/main">
               <a:ext uri="{FF2B5EF4-FFF2-40B4-BE49-F238E27FC236}">
-                <a16:creationId xmlns:a16="http://schemas.microsoft.com/office/drawing/2014/main" id="{7EAD79E4-52DF-4DF3-BC98-A44D4267E1B5}"/>
+                <a16:creationId xmlns:a16="http://schemas.microsoft.com/office/drawing/2014/main" id="{8E66D3E8-89C1-4AEA-803B-CEC5F00DD8F7}"/>
               </a:ext>
             </a:extLst>
           </p:cNvPr>
@@ -20091,7 +20091,7 @@
           <p:cNvPr id="8" name="">
             <a:extLst xmlns:a="http://schemas.openxmlformats.org/drawingml/2006/main">
               <a:ext uri="{FF2B5EF4-FFF2-40B4-BE49-F238E27FC236}">
-                <a16:creationId xmlns:a16="http://schemas.microsoft.com/office/drawing/2014/main" id="{61BCD362-A1B4-427A-92E3-7DE3E256028C}"/>
+                <a16:creationId xmlns:a16="http://schemas.microsoft.com/office/drawing/2014/main" id="{2588AB3A-A82C-4957-80A4-F1406C672822}"/>
               </a:ext>
             </a:extLst>
           </p:cNvPr>
@@ -20124,7 +20124,7 @@
           <p:cNvPr id="9" name="">
             <a:extLst xmlns:a="http://schemas.openxmlformats.org/drawingml/2006/main">
               <a:ext uri="{FF2B5EF4-FFF2-40B4-BE49-F238E27FC236}">
-                <a16:creationId xmlns:a16="http://schemas.microsoft.com/office/drawing/2014/main" id="{95D12C1C-CA49-4A01-AF1E-966B291D03BB}"/>
+                <a16:creationId xmlns:a16="http://schemas.microsoft.com/office/drawing/2014/main" id="{7B758519-B06F-4C2E-858D-FFB12B20DE44}"/>
               </a:ext>
             </a:extLst>
           </p:cNvPr>
@@ -20188,7 +20188,7 @@
           <p:cNvPr id="10" name="">
             <a:extLst xmlns:a="http://schemas.openxmlformats.org/drawingml/2006/main">
               <a:ext uri="{FF2B5EF4-FFF2-40B4-BE49-F238E27FC236}">
-                <a16:creationId xmlns:a16="http://schemas.microsoft.com/office/drawing/2014/main" id="{F8AFFD3F-6032-48DE-8698-D825B98A7050}"/>
+                <a16:creationId xmlns:a16="http://schemas.microsoft.com/office/drawing/2014/main" id="{11950493-51E6-484B-9E35-2EB9061F1462}"/>
               </a:ext>
             </a:extLst>
           </p:cNvPr>
@@ -20252,7 +20252,7 @@
           <p:cNvPr id="11" name="">
             <a:extLst xmlns:a="http://schemas.openxmlformats.org/drawingml/2006/main">
               <a:ext uri="{FF2B5EF4-FFF2-40B4-BE49-F238E27FC236}">
-                <a16:creationId xmlns:a16="http://schemas.microsoft.com/office/drawing/2014/main" id="{58191993-458F-4B38-93A2-DEDBCF63AE02}"/>
+                <a16:creationId xmlns:a16="http://schemas.microsoft.com/office/drawing/2014/main" id="{EBA9860D-247F-46C1-978A-F4984BC255D6}"/>
               </a:ext>
             </a:extLst>
           </p:cNvPr>
@@ -20285,7 +20285,7 @@
           <p:cNvPr id="12" name="">
             <a:extLst xmlns:a="http://schemas.openxmlformats.org/drawingml/2006/main">
               <a:ext uri="{FF2B5EF4-FFF2-40B4-BE49-F238E27FC236}">
-                <a16:creationId xmlns:a16="http://schemas.microsoft.com/office/drawing/2014/main" id="{A03E97BC-4471-4493-A640-8EEEA842426B}"/>
+                <a16:creationId xmlns:a16="http://schemas.microsoft.com/office/drawing/2014/main" id="{D766FB39-76DA-4343-B2EA-E4E1D9B21EFA}"/>
               </a:ext>
             </a:extLst>
           </p:cNvPr>
@@ -20349,7 +20349,7 @@
           <p:cNvPr id="13" name="">
             <a:extLst xmlns:a="http://schemas.openxmlformats.org/drawingml/2006/main">
               <a:ext uri="{FF2B5EF4-FFF2-40B4-BE49-F238E27FC236}">
-                <a16:creationId xmlns:a16="http://schemas.microsoft.com/office/drawing/2014/main" id="{83A9E1B7-5E4A-4500-A7E4-E47718D3F7BE}"/>
+                <a16:creationId xmlns:a16="http://schemas.microsoft.com/office/drawing/2014/main" id="{89EA5940-EF99-4C32-84DA-ABD7950AEF2C}"/>
               </a:ext>
             </a:extLst>
           </p:cNvPr>
@@ -20413,7 +20413,7 @@
           <p:cNvPr id="14" name="">
             <a:extLst xmlns:a="http://schemas.openxmlformats.org/drawingml/2006/main">
               <a:ext uri="{FF2B5EF4-FFF2-40B4-BE49-F238E27FC236}">
-                <a16:creationId xmlns:a16="http://schemas.microsoft.com/office/drawing/2014/main" id="{5A798750-4DDA-48DD-B480-86213834A2BA}"/>
+                <a16:creationId xmlns:a16="http://schemas.microsoft.com/office/drawing/2014/main" id="{366D2121-4BE0-4D25-9830-D5CCFE7BC884}"/>
               </a:ext>
             </a:extLst>
           </p:cNvPr>
@@ -20446,7 +20446,7 @@
           <p:cNvPr id="15" name="">
             <a:extLst xmlns:a="http://schemas.openxmlformats.org/drawingml/2006/main">
               <a:ext uri="{FF2B5EF4-FFF2-40B4-BE49-F238E27FC236}">
-                <a16:creationId xmlns:a16="http://schemas.microsoft.com/office/drawing/2014/main" id="{18B95A21-4CF5-47A8-BC77-3ADE99FD219D}"/>
+                <a16:creationId xmlns:a16="http://schemas.microsoft.com/office/drawing/2014/main" id="{5EB4978D-5F45-4D3F-86BA-BAF96FBE061D}"/>
               </a:ext>
             </a:extLst>
           </p:cNvPr>
@@ -20510,7 +20510,7 @@
           <p:cNvPr id="16" name="">
             <a:extLst xmlns:a="http://schemas.openxmlformats.org/drawingml/2006/main">
               <a:ext uri="{FF2B5EF4-FFF2-40B4-BE49-F238E27FC236}">
-                <a16:creationId xmlns:a16="http://schemas.microsoft.com/office/drawing/2014/main" id="{A950E464-A0D9-4D4F-A1D3-226565A918C7}"/>
+                <a16:creationId xmlns:a16="http://schemas.microsoft.com/office/drawing/2014/main" id="{3C8C4067-43DE-429A-8319-AA8A57B50A51}"/>
               </a:ext>
             </a:extLst>
           </p:cNvPr>
@@ -20574,7 +20574,7 @@
           <p:cNvPr id="17" name="">
             <a:extLst xmlns:a="http://schemas.openxmlformats.org/drawingml/2006/main">
               <a:ext uri="{FF2B5EF4-FFF2-40B4-BE49-F238E27FC236}">
-                <a16:creationId xmlns:a16="http://schemas.microsoft.com/office/drawing/2014/main" id="{AC8A02A9-7113-4E2F-B587-4ADFC27CFB4A}"/>
+                <a16:creationId xmlns:a16="http://schemas.microsoft.com/office/drawing/2014/main" id="{2BF5A780-D56F-4483-A162-918654C10C4A}"/>
               </a:ext>
             </a:extLst>
           </p:cNvPr>
@@ -20607,7 +20607,7 @@
           <p:cNvPr id="18" name="">
             <a:extLst xmlns:a="http://schemas.openxmlformats.org/drawingml/2006/main">
               <a:ext uri="{FF2B5EF4-FFF2-40B4-BE49-F238E27FC236}">
-                <a16:creationId xmlns:a16="http://schemas.microsoft.com/office/drawing/2014/main" id="{B1387DDF-D743-4920-B8FA-BF07667BFDF4}"/>
+                <a16:creationId xmlns:a16="http://schemas.microsoft.com/office/drawing/2014/main" id="{D194E55E-3A21-4BCA-AF8C-48912C2BFFFF}"/>
               </a:ext>
             </a:extLst>
           </p:cNvPr>
@@ -20671,7 +20671,7 @@
           <p:cNvPr id="19" name="">
             <a:extLst xmlns:a="http://schemas.openxmlformats.org/drawingml/2006/main">
               <a:ext uri="{FF2B5EF4-FFF2-40B4-BE49-F238E27FC236}">
-                <a16:creationId xmlns:a16="http://schemas.microsoft.com/office/drawing/2014/main" id="{AE3175F0-5C73-44AF-B044-8661306CB562}"/>
+                <a16:creationId xmlns:a16="http://schemas.microsoft.com/office/drawing/2014/main" id="{5FAB7ADB-C446-4D75-BF5D-DE89254993C1}"/>
               </a:ext>
             </a:extLst>
           </p:cNvPr>
@@ -20735,7 +20735,7 @@
           <p:cNvPr id="20" name="">
             <a:extLst xmlns:a="http://schemas.openxmlformats.org/drawingml/2006/main">
               <a:ext uri="{FF2B5EF4-FFF2-40B4-BE49-F238E27FC236}">
-                <a16:creationId xmlns:a16="http://schemas.microsoft.com/office/drawing/2014/main" id="{E5BDBAA5-930C-471F-B77D-C4614D852F71}"/>
+                <a16:creationId xmlns:a16="http://schemas.microsoft.com/office/drawing/2014/main" id="{CD4B95D2-EBD6-4DA7-AFC9-0C3F65F7F6B1}"/>
               </a:ext>
             </a:extLst>
           </p:cNvPr>
@@ -20768,7 +20768,7 @@
           <p:cNvPr id="21" name="">
             <a:extLst xmlns:a="http://schemas.openxmlformats.org/drawingml/2006/main">
               <a:ext uri="{FF2B5EF4-FFF2-40B4-BE49-F238E27FC236}">
-                <a16:creationId xmlns:a16="http://schemas.microsoft.com/office/drawing/2014/main" id="{134EF0F8-044B-4D33-BB90-23844A845F4E}"/>
+                <a16:creationId xmlns:a16="http://schemas.microsoft.com/office/drawing/2014/main" id="{AA6A7B19-1B3F-42FD-AFF7-2FA85C8B5C9B}"/>
               </a:ext>
             </a:extLst>
           </p:cNvPr>
@@ -20832,7 +20832,7 @@
           <p:cNvPr id="22" name="">
             <a:extLst xmlns:a="http://schemas.openxmlformats.org/drawingml/2006/main">
               <a:ext uri="{FF2B5EF4-FFF2-40B4-BE49-F238E27FC236}">
-                <a16:creationId xmlns:a16="http://schemas.microsoft.com/office/drawing/2014/main" id="{71150565-7AE7-4C77-8186-A411D47A9ABE}"/>
+                <a16:creationId xmlns:a16="http://schemas.microsoft.com/office/drawing/2014/main" id="{C124A566-7201-4739-AED0-60DC5858901C}"/>
               </a:ext>
             </a:extLst>
           </p:cNvPr>
@@ -20896,7 +20896,7 @@
           <p:cNvPr id="23" name="">
             <a:extLst xmlns:a="http://schemas.openxmlformats.org/drawingml/2006/main">
               <a:ext uri="{FF2B5EF4-FFF2-40B4-BE49-F238E27FC236}">
-                <a16:creationId xmlns:a16="http://schemas.microsoft.com/office/drawing/2014/main" id="{151D759D-9E04-44D8-A6A5-2EB0C2959681}"/>
+                <a16:creationId xmlns:a16="http://schemas.microsoft.com/office/drawing/2014/main" id="{3E4083BB-9BA2-4477-B40C-AAA51228D768}"/>
               </a:ext>
             </a:extLst>
           </p:cNvPr>
@@ -20929,7 +20929,7 @@
           <p:cNvPr id="24" name="">
             <a:extLst xmlns:a="http://schemas.openxmlformats.org/drawingml/2006/main">
               <a:ext uri="{FF2B5EF4-FFF2-40B4-BE49-F238E27FC236}">
-                <a16:creationId xmlns:a16="http://schemas.microsoft.com/office/drawing/2014/main" id="{9C17D24B-0B16-446C-92BF-E62DD5EF18DF}"/>
+                <a16:creationId xmlns:a16="http://schemas.microsoft.com/office/drawing/2014/main" id="{99BFB131-63D3-4015-8162-0F936EDA139E}"/>
               </a:ext>
             </a:extLst>
           </p:cNvPr>
@@ -20993,7 +20993,7 @@
           <p:cNvPr id="25" name="">
             <a:extLst xmlns:a="http://schemas.openxmlformats.org/drawingml/2006/main">
               <a:ext uri="{FF2B5EF4-FFF2-40B4-BE49-F238E27FC236}">
-                <a16:creationId xmlns:a16="http://schemas.microsoft.com/office/drawing/2014/main" id="{10AE6980-5FF5-4631-B1EB-CF0DE8DB7E00}"/>
+                <a16:creationId xmlns:a16="http://schemas.microsoft.com/office/drawing/2014/main" id="{9EC7EFC1-856E-42BE-8392-60161B2969EC}"/>
               </a:ext>
             </a:extLst>
           </p:cNvPr>
@@ -21057,7 +21057,7 @@
           <p:cNvPr id="26" name="">
             <a:extLst xmlns:a="http://schemas.openxmlformats.org/drawingml/2006/main">
               <a:ext uri="{FF2B5EF4-FFF2-40B4-BE49-F238E27FC236}">
-                <a16:creationId xmlns:a16="http://schemas.microsoft.com/office/drawing/2014/main" id="{1FDAD6FC-071E-4C64-B2E8-C0DD8AA21FBE}"/>
+                <a16:creationId xmlns:a16="http://schemas.microsoft.com/office/drawing/2014/main" id="{09F1CFD9-DAF2-4B61-BCA0-55E7E2CDAFB1}"/>
               </a:ext>
             </a:extLst>
           </p:cNvPr>
@@ -21121,7 +21121,7 @@
           <p:cNvPr id="27" name="">
             <a:extLst xmlns:a="http://schemas.openxmlformats.org/drawingml/2006/main">
               <a:ext uri="{FF2B5EF4-FFF2-40B4-BE49-F238E27FC236}">
-                <a16:creationId xmlns:a16="http://schemas.microsoft.com/office/drawing/2014/main" id="{B6173FAE-0E78-48C8-8E2E-C870D4844611}"/>
+                <a16:creationId xmlns:a16="http://schemas.microsoft.com/office/drawing/2014/main" id="{416D037A-8B6C-46B3-8824-4DDC5459ECB8}"/>
               </a:ext>
             </a:extLst>
           </p:cNvPr>
@@ -21185,7 +21185,7 @@
           <p:cNvPr id="28" name="">
             <a:extLst xmlns:a="http://schemas.openxmlformats.org/drawingml/2006/main">
               <a:ext uri="{FF2B5EF4-FFF2-40B4-BE49-F238E27FC236}">
-                <a16:creationId xmlns:a16="http://schemas.microsoft.com/office/drawing/2014/main" id="{7A101E4D-0001-4FE8-8414-9A2D27E99609}"/>
+                <a16:creationId xmlns:a16="http://schemas.microsoft.com/office/drawing/2014/main" id="{C56AC720-7602-45D5-A362-83910D54473F}"/>
               </a:ext>
             </a:extLst>
           </p:cNvPr>
@@ -21220,7 +21220,7 @@
           <p:cNvPr id="29" name="">
             <a:extLst xmlns:a="http://schemas.openxmlformats.org/drawingml/2006/main">
               <a:ext uri="{FF2B5EF4-FFF2-40B4-BE49-F238E27FC236}">
-                <a16:creationId xmlns:a16="http://schemas.microsoft.com/office/drawing/2014/main" id="{130FCF20-57B1-4539-A6C2-FD00B46267CB}"/>
+                <a16:creationId xmlns:a16="http://schemas.microsoft.com/office/drawing/2014/main" id="{F8421AD4-F43B-4196-B60E-AF192D0FDA32}"/>
               </a:ext>
             </a:extLst>
           </p:cNvPr>
@@ -21274,7 +21274,7 @@
                 <a:ea typeface="Hiragino Sans"/>
                 <a:cs typeface="Hiragino Sans"/>
               </a:rPr>
-              <a:t>source: paper/sections/11_full_algorithm.tex</a:t>
+              <a:t>source: Full algorithm</a:t>
             </a:r>
           </a:p>
         </p:txBody>
@@ -21284,7 +21284,7 @@
           <p:cNvPr id="30" name="">
             <a:extLst xmlns:a="http://schemas.openxmlformats.org/drawingml/2006/main">
               <a:ext uri="{FF2B5EF4-FFF2-40B4-BE49-F238E27FC236}">
-                <a16:creationId xmlns:a16="http://schemas.microsoft.com/office/drawing/2014/main" id="{3CB99DAF-6D16-452E-9F95-E3A4086D253E}"/>
+                <a16:creationId xmlns:a16="http://schemas.microsoft.com/office/drawing/2014/main" id="{8E39795F-00E6-49EF-8316-36B5727C80F2}"/>
               </a:ext>
             </a:extLst>
           </p:cNvPr>
@@ -21346,7 +21346,7 @@
     </p:spTree>
     <p:extLst>
       <p:ext uri="{BB962C8B-B14F-4D97-AF65-F5344CB8AC3E}">
-        <p14:creationId xmlns:p14="http://schemas.microsoft.com/office/powerpoint/2010/main" val="286758635"/>
+        <p14:creationId xmlns:p14="http://schemas.microsoft.com/office/powerpoint/2010/main" val="883906089"/>
       </p:ext>
     </p:extLst>
   </p:cSld>

</xml_diff>